<commit_message>
feat: add CellShapeManager for table cell shape overlays and polymorphic cell data handling
</commit_message>
<xml_diff>
--- a/showcase/templates/TablePowerPointSample.pptx
+++ b/showcase/templates/TablePowerPointSample.pptx
@@ -4582,7 +4582,7 @@
           <p:nvPr>
             <p:extLst>
               <p:ext uri="{D42A27DB-BD31-4B8C-83A1-F6EECF244321}">
-                <p14:modId xmlns:p14="http://schemas.microsoft.com/office/powerpoint/2010/main" val="4085423743"/>
+                <p14:modId xmlns:p14="http://schemas.microsoft.com/office/powerpoint/2010/main" val="3190809374"/>
               </p:ext>
             </p:extLst>
           </p:nvPr>
@@ -4690,6 +4690,10 @@
                     <a:bodyPr/>
                     <a:lstStyle/>
                     <a:p>
+                      <a:r>
+                        <a:rPr lang="en-IN"/>
+                        <a:t>Stauts</a:t>
+                      </a:r>
                       <a:endParaRPr dirty="0"/>
                     </a:p>
                   </a:txBody>
@@ -4859,6 +4863,98 @@
           </a:graphicData>
         </a:graphic>
       </p:graphicFrame>
+      <p:sp>
+        <p:nvSpPr>
+          <p:cNvPr id="5" name="Rectangle 4">
+            <a:extLst>
+              <a:ext uri="{FF2B5EF4-FFF2-40B4-BE49-F238E27FC236}">
+                <a16:creationId xmlns:a16="http://schemas.microsoft.com/office/drawing/2014/main" id="{015F84A7-56D9-6F15-BF5D-B9FE4828B0CB}"/>
+              </a:ext>
+            </a:extLst>
+          </p:cNvPr>
+          <p:cNvSpPr/>
+          <p:nvPr/>
+        </p:nvSpPr>
+        <p:spPr>
+          <a:xfrm>
+            <a:off x="9328639" y="1461574"/>
+            <a:ext cx="342900" cy="237392"/>
+          </a:xfrm>
+          <a:prstGeom prst="rect">
+            <a:avLst/>
+          </a:prstGeom>
+        </p:spPr>
+        <p:style>
+          <a:lnRef idx="2">
+            <a:schemeClr val="accent1">
+              <a:shade val="15000"/>
+            </a:schemeClr>
+          </a:lnRef>
+          <a:fillRef idx="1">
+            <a:schemeClr val="accent1"/>
+          </a:fillRef>
+          <a:effectRef idx="0">
+            <a:schemeClr val="accent1"/>
+          </a:effectRef>
+          <a:fontRef idx="minor">
+            <a:schemeClr val="lt1"/>
+          </a:fontRef>
+        </p:style>
+        <p:txBody>
+          <a:bodyPr rtlCol="0" anchor="ctr"/>
+          <a:lstStyle/>
+          <a:p>
+            <a:pPr algn="ctr"/>
+            <a:endParaRPr lang="en-IN"/>
+          </a:p>
+        </p:txBody>
+      </p:sp>
+      <p:sp>
+        <p:nvSpPr>
+          <p:cNvPr id="7" name="Oval 6">
+            <a:extLst>
+              <a:ext uri="{FF2B5EF4-FFF2-40B4-BE49-F238E27FC236}">
+                <a16:creationId xmlns:a16="http://schemas.microsoft.com/office/drawing/2014/main" id="{EB648652-79D4-02BA-C7E4-2B61DE7E47AE}"/>
+              </a:ext>
+            </a:extLst>
+          </p:cNvPr>
+          <p:cNvSpPr/>
+          <p:nvPr/>
+        </p:nvSpPr>
+        <p:spPr>
+          <a:xfrm>
+            <a:off x="10155115" y="1811215"/>
+            <a:ext cx="254977" cy="254977"/>
+          </a:xfrm>
+          <a:prstGeom prst="ellipse">
+            <a:avLst/>
+          </a:prstGeom>
+        </p:spPr>
+        <p:style>
+          <a:lnRef idx="2">
+            <a:schemeClr val="accent6">
+              <a:shade val="15000"/>
+            </a:schemeClr>
+          </a:lnRef>
+          <a:fillRef idx="1">
+            <a:schemeClr val="accent6"/>
+          </a:fillRef>
+          <a:effectRef idx="0">
+            <a:schemeClr val="accent6"/>
+          </a:effectRef>
+          <a:fontRef idx="minor">
+            <a:schemeClr val="lt1"/>
+          </a:fontRef>
+        </p:style>
+        <p:txBody>
+          <a:bodyPr rtlCol="0" anchor="ctr"/>
+          <a:lstStyle/>
+          <a:p>
+            <a:pPr algn="ctr"/>
+            <a:endParaRPr lang="en-IN"/>
+          </a:p>
+        </p:txBody>
+      </p:sp>
     </p:spTree>
     <p:extLst>
       <p:ext uri="{BB962C8B-B14F-4D97-AF65-F5344CB8AC3E}">
@@ -4937,6 +5033,926 @@
             <a:extLst>
               <a:ext uri="{FF2B5EF4-FFF2-40B4-BE49-F238E27FC236}">
                 <a16:creationId xmlns:a16="http://schemas.microsoft.com/office/drawing/2014/main" id="{0CAC8E42-6152-1215-96E1-71642C4847B1}"/>
+              </a:ext>
+            </a:extLst>
+          </p:cNvPr>
+          <p:cNvGraphicFramePr>
+            <a:graphicFrameLocks/>
+          </p:cNvGraphicFramePr>
+          <p:nvPr>
+            <p:extLst>
+              <p:ext uri="{D42A27DB-BD31-4B8C-83A1-F6EECF244321}">
+                <p14:modId xmlns:p14="http://schemas.microsoft.com/office/powerpoint/2010/main" val="2077607690"/>
+              </p:ext>
+            </p:extLst>
+          </p:nvPr>
+        </p:nvGraphicFramePr>
+        <p:xfrm>
+          <a:off x="838200" y="1024010"/>
+          <a:ext cx="10515600" cy="1112520"/>
+        </p:xfrm>
+        <a:graphic>
+          <a:graphicData uri="http://schemas.openxmlformats.org/drawingml/2006/table">
+            <a:tbl>
+              <a:tblPr firstRow="1" bandRow="1">
+                <a:tableStyleId>{5C22544A-7EE6-4342-B048-85BDC9FD1C3A}</a:tableStyleId>
+              </a:tblPr>
+              <a:tblGrid>
+                <a:gridCol w="2103120">
+                  <a:extLst>
+                    <a:ext uri="{9D8B030D-6E8A-4147-A177-3AD203B41FA5}">
+                      <a16:colId xmlns:a16="http://schemas.microsoft.com/office/drawing/2014/main" val="1526623959"/>
+                    </a:ext>
+                  </a:extLst>
+                </a:gridCol>
+                <a:gridCol w="2103120">
+                  <a:extLst>
+                    <a:ext uri="{9D8B030D-6E8A-4147-A177-3AD203B41FA5}">
+                      <a16:colId xmlns:a16="http://schemas.microsoft.com/office/drawing/2014/main" val="1036110465"/>
+                    </a:ext>
+                  </a:extLst>
+                </a:gridCol>
+                <a:gridCol w="2103120">
+                  <a:extLst>
+                    <a:ext uri="{9D8B030D-6E8A-4147-A177-3AD203B41FA5}">
+                      <a16:colId xmlns:a16="http://schemas.microsoft.com/office/drawing/2014/main" val="1994860425"/>
+                    </a:ext>
+                  </a:extLst>
+                </a:gridCol>
+                <a:gridCol w="2103120">
+                  <a:extLst>
+                    <a:ext uri="{9D8B030D-6E8A-4147-A177-3AD203B41FA5}">
+                      <a16:colId xmlns:a16="http://schemas.microsoft.com/office/drawing/2014/main" val="3533840823"/>
+                    </a:ext>
+                  </a:extLst>
+                </a:gridCol>
+                <a:gridCol w="2103120">
+                  <a:extLst>
+                    <a:ext uri="{9D8B030D-6E8A-4147-A177-3AD203B41FA5}">
+                      <a16:colId xmlns:a16="http://schemas.microsoft.com/office/drawing/2014/main" val="1604916882"/>
+                    </a:ext>
+                  </a:extLst>
+                </a:gridCol>
+              </a:tblGrid>
+              <a:tr h="370840">
+                <a:tc gridSpan="2">
+                  <a:txBody>
+                    <a:bodyPr/>
+                    <a:lstStyle/>
+                    <a:p>
+                      <a:pPr algn="ctr"/>
+                      <a:r>
+                        <a:rPr lang="en-IN" dirty="0"/>
+                        <a:t>Department</a:t>
+                      </a:r>
+                    </a:p>
+                  </a:txBody>
+                  <a:tcPr/>
+                </a:tc>
+                <a:tc hMerge="1">
+                  <a:txBody>
+                    <a:bodyPr/>
+                    <a:lstStyle/>
+                    <a:p>
+                      <a:endParaRPr lang="en-IN"/>
+                    </a:p>
+                  </a:txBody>
+                  <a:tcPr/>
+                </a:tc>
+                <a:tc>
+                  <a:txBody>
+                    <a:bodyPr/>
+                    <a:lstStyle/>
+                    <a:p>
+                      <a:r>
+                        <a:rPr dirty="0"/>
+                        <a:t>Q1 Target</a:t>
+                      </a:r>
+                    </a:p>
+                  </a:txBody>
+                  <a:tcPr/>
+                </a:tc>
+                <a:tc>
+                  <a:txBody>
+                    <a:bodyPr/>
+                    <a:lstStyle/>
+                    <a:p>
+                      <a:r>
+                        <a:rPr dirty="0"/>
+                        <a:t>Q1 Actual</a:t>
+                      </a:r>
+                    </a:p>
+                  </a:txBody>
+                  <a:tcPr/>
+                </a:tc>
+                <a:tc>
+                  <a:txBody>
+                    <a:bodyPr/>
+                    <a:lstStyle/>
+                    <a:p>
+                      <a:r>
+                        <a:rPr lang="en-IN" dirty="0"/>
+                        <a:t>Status</a:t>
+                      </a:r>
+                      <a:endParaRPr dirty="0"/>
+                    </a:p>
+                  </a:txBody>
+                  <a:tcPr/>
+                </a:tc>
+                <a:extLst>
+                  <a:ext uri="{0D108BD9-81ED-4DB2-BD59-A6C34878D82A}">
+                    <a16:rowId xmlns:a16="http://schemas.microsoft.com/office/drawing/2014/main" val="1869212938"/>
+                  </a:ext>
+                </a:extLst>
+              </a:tr>
+              <a:tr h="370840">
+                <a:tc gridSpan="2">
+                  <a:txBody>
+                    <a:bodyPr/>
+                    <a:lstStyle/>
+                    <a:p>
+                      <a:pPr marL="0" marR="0" lvl="0" indent="0" algn="ctr" defTabSz="914400" rtl="0" eaLnBrk="1" fontAlgn="auto" latinLnBrk="0" hangingPunct="1">
+                        <a:lnSpc>
+                          <a:spcPct val="100000"/>
+                        </a:lnSpc>
+                        <a:spcBef>
+                          <a:spcPts val="0"/>
+                        </a:spcBef>
+                        <a:spcAft>
+                          <a:spcPts val="0"/>
+                        </a:spcAft>
+                        <a:buClrTx/>
+                        <a:buSzTx/>
+                        <a:buFontTx/>
+                        <a:buNone/>
+                        <a:tabLst/>
+                        <a:defRPr/>
+                      </a:pPr>
+                      <a:r>
+                        <a:rPr lang="en-IN" dirty="0"/>
+                        <a:t>Global Marketing</a:t>
+                      </a:r>
+                    </a:p>
+                  </a:txBody>
+                  <a:tcPr/>
+                </a:tc>
+                <a:tc hMerge="1">
+                  <a:txBody>
+                    <a:bodyPr/>
+                    <a:lstStyle/>
+                    <a:p>
+                      <a:endParaRPr lang="en-IN"/>
+                    </a:p>
+                  </a:txBody>
+                  <a:tcPr/>
+                </a:tc>
+                <a:tc>
+                  <a:txBody>
+                    <a:bodyPr/>
+                    <a:lstStyle/>
+                    <a:p>
+                      <a:r>
+                        <a:rPr dirty="0"/>
+                        <a:t>$500,000</a:t>
+                      </a:r>
+                    </a:p>
+                  </a:txBody>
+                  <a:tcPr/>
+                </a:tc>
+                <a:tc>
+                  <a:txBody>
+                    <a:bodyPr/>
+                    <a:lstStyle/>
+                    <a:p>
+                      <a:r>
+                        <a:rPr dirty="0"/>
+                        <a:t>$520,000</a:t>
+                      </a:r>
+                    </a:p>
+                  </a:txBody>
+                  <a:tcPr/>
+                </a:tc>
+                <a:tc>
+                  <a:txBody>
+                    <a:bodyPr/>
+                    <a:lstStyle/>
+                    <a:p>
+                      <a:endParaRPr dirty="0"/>
+                    </a:p>
+                  </a:txBody>
+                  <a:tcPr/>
+                </a:tc>
+                <a:extLst>
+                  <a:ext uri="{0D108BD9-81ED-4DB2-BD59-A6C34878D82A}">
+                    <a16:rowId xmlns:a16="http://schemas.microsoft.com/office/drawing/2014/main" val="2673184772"/>
+                  </a:ext>
+                </a:extLst>
+              </a:tr>
+              <a:tr h="370840">
+                <a:tc>
+                  <a:txBody>
+                    <a:bodyPr/>
+                    <a:lstStyle/>
+                    <a:p>
+                      <a:pPr algn="ctr"/>
+                      <a:r>
+                        <a:rPr lang="en-IN" dirty="0"/>
+                        <a:t>Engineering</a:t>
+                      </a:r>
+                    </a:p>
+                  </a:txBody>
+                  <a:tcPr/>
+                </a:tc>
+                <a:tc>
+                  <a:txBody>
+                    <a:bodyPr/>
+                    <a:lstStyle/>
+                    <a:p>
+                      <a:pPr algn="ctr"/>
+                      <a:r>
+                        <a:rPr lang="en-IN" dirty="0"/>
+                        <a:t>Product</a:t>
+                      </a:r>
+                    </a:p>
+                  </a:txBody>
+                  <a:tcPr/>
+                </a:tc>
+                <a:tc>
+                  <a:txBody>
+                    <a:bodyPr/>
+                    <a:lstStyle/>
+                    <a:p>
+                      <a:r>
+                        <a:rPr dirty="0"/>
+                        <a:t>$250,000</a:t>
+                      </a:r>
+                    </a:p>
+                  </a:txBody>
+                  <a:tcPr/>
+                </a:tc>
+                <a:tc>
+                  <a:txBody>
+                    <a:bodyPr/>
+                    <a:lstStyle/>
+                    <a:p>
+                      <a:r>
+                        <a:rPr dirty="0"/>
+                        <a:t>$245,000</a:t>
+                      </a:r>
+                    </a:p>
+                  </a:txBody>
+                  <a:tcPr/>
+                </a:tc>
+                <a:tc>
+                  <a:txBody>
+                    <a:bodyPr/>
+                    <a:lstStyle/>
+                    <a:p>
+                      <a:endParaRPr dirty="0"/>
+                    </a:p>
+                  </a:txBody>
+                  <a:tcPr/>
+                </a:tc>
+                <a:extLst>
+                  <a:ext uri="{0D108BD9-81ED-4DB2-BD59-A6C34878D82A}">
+                    <a16:rowId xmlns:a16="http://schemas.microsoft.com/office/drawing/2014/main" val="2462398921"/>
+                  </a:ext>
+                </a:extLst>
+              </a:tr>
+            </a:tbl>
+          </a:graphicData>
+        </a:graphic>
+      </p:graphicFrame>
+      <p:sp>
+        <p:nvSpPr>
+          <p:cNvPr id="5" name="Rectangle 4">
+            <a:extLst>
+              <a:ext uri="{FF2B5EF4-FFF2-40B4-BE49-F238E27FC236}">
+                <a16:creationId xmlns:a16="http://schemas.microsoft.com/office/drawing/2014/main" id="{56203012-5132-2A5E-93E4-E8E38FAF5BF7}"/>
+              </a:ext>
+            </a:extLst>
+          </p:cNvPr>
+          <p:cNvSpPr/>
+          <p:nvPr/>
+        </p:nvSpPr>
+        <p:spPr>
+          <a:xfrm>
+            <a:off x="9328639" y="1461574"/>
+            <a:ext cx="342900" cy="237392"/>
+          </a:xfrm>
+          <a:prstGeom prst="rect">
+            <a:avLst/>
+          </a:prstGeom>
+        </p:spPr>
+        <p:style>
+          <a:lnRef idx="2">
+            <a:schemeClr val="accent1">
+              <a:shade val="15000"/>
+            </a:schemeClr>
+          </a:lnRef>
+          <a:fillRef idx="1">
+            <a:schemeClr val="accent1"/>
+          </a:fillRef>
+          <a:effectRef idx="0">
+            <a:schemeClr val="accent1"/>
+          </a:effectRef>
+          <a:fontRef idx="minor">
+            <a:schemeClr val="lt1"/>
+          </a:fontRef>
+        </p:style>
+        <p:txBody>
+          <a:bodyPr rtlCol="0" anchor="ctr"/>
+          <a:lstStyle/>
+          <a:p>
+            <a:pPr algn="ctr"/>
+            <a:endParaRPr lang="en-IN"/>
+          </a:p>
+        </p:txBody>
+      </p:sp>
+      <p:sp>
+        <p:nvSpPr>
+          <p:cNvPr id="7" name="Oval 6">
+            <a:extLst>
+              <a:ext uri="{FF2B5EF4-FFF2-40B4-BE49-F238E27FC236}">
+                <a16:creationId xmlns:a16="http://schemas.microsoft.com/office/drawing/2014/main" id="{DE79A736-5224-5FBE-1F85-E3FD8699135D}"/>
+              </a:ext>
+            </a:extLst>
+          </p:cNvPr>
+          <p:cNvSpPr/>
+          <p:nvPr/>
+        </p:nvSpPr>
+        <p:spPr>
+          <a:xfrm>
+            <a:off x="10155115" y="1811215"/>
+            <a:ext cx="254977" cy="254977"/>
+          </a:xfrm>
+          <a:prstGeom prst="ellipse">
+            <a:avLst/>
+          </a:prstGeom>
+        </p:spPr>
+        <p:style>
+          <a:lnRef idx="2">
+            <a:schemeClr val="accent6">
+              <a:shade val="15000"/>
+            </a:schemeClr>
+          </a:lnRef>
+          <a:fillRef idx="1">
+            <a:schemeClr val="accent6"/>
+          </a:fillRef>
+          <a:effectRef idx="0">
+            <a:schemeClr val="accent6"/>
+          </a:effectRef>
+          <a:fontRef idx="minor">
+            <a:schemeClr val="lt1"/>
+          </a:fontRef>
+        </p:style>
+        <p:txBody>
+          <a:bodyPr rtlCol="0" anchor="ctr"/>
+          <a:lstStyle/>
+          <a:p>
+            <a:pPr algn="ctr"/>
+            <a:endParaRPr lang="en-IN"/>
+          </a:p>
+        </p:txBody>
+      </p:sp>
+    </p:spTree>
+    <p:extLst>
+      <p:ext uri="{BB962C8B-B14F-4D97-AF65-F5344CB8AC3E}">
+        <p14:creationId xmlns:p14="http://schemas.microsoft.com/office/powerpoint/2010/main" val="2181556897"/>
+      </p:ext>
+    </p:extLst>
+  </p:cSld>
+  <p:clrMapOvr>
+    <a:masterClrMapping/>
+  </p:clrMapOvr>
+</p:sld>
+</file>
+
+<file path=ppt/slides/slide15.xml><?xml version="1.0" encoding="utf-8"?>
+<p:sld xmlns:a="http://schemas.openxmlformats.org/drawingml/2006/main" xmlns:r="http://schemas.openxmlformats.org/officeDocument/2006/relationships" xmlns:p="http://schemas.openxmlformats.org/presentationml/2006/main">
+  <p:cSld>
+    <p:spTree>
+      <p:nvGrpSpPr>
+        <p:cNvPr id="1" name="">
+          <a:extLst>
+            <a:ext uri="{FF2B5EF4-FFF2-40B4-BE49-F238E27FC236}">
+              <a16:creationId xmlns:a16="http://schemas.microsoft.com/office/drawing/2014/main" id="{11F8C139-8905-2EA4-D49B-FB51814D72D7}"/>
+            </a:ext>
+          </a:extLst>
+        </p:cNvPr>
+        <p:cNvGrpSpPr/>
+        <p:nvPr/>
+      </p:nvGrpSpPr>
+      <p:grpSpPr>
+        <a:xfrm>
+          <a:off x="0" y="0"/>
+          <a:ext cx="0" cy="0"/>
+          <a:chOff x="0" y="0"/>
+          <a:chExt cx="0" cy="0"/>
+        </a:xfrm>
+      </p:grpSpPr>
+      <p:sp>
+        <p:nvSpPr>
+          <p:cNvPr id="3" name="Subtitle 2">
+            <a:extLst>
+              <a:ext uri="{FF2B5EF4-FFF2-40B4-BE49-F238E27FC236}">
+                <a16:creationId xmlns:a16="http://schemas.microsoft.com/office/drawing/2014/main" id="{84A764F5-6CCC-8A59-55D8-30B467F85BD5}"/>
+              </a:ext>
+            </a:extLst>
+          </p:cNvPr>
+          <p:cNvSpPr>
+            <a:spLocks noGrp="1"/>
+          </p:cNvSpPr>
+          <p:nvPr>
+            <p:ph type="subTitle" idx="1"/>
+          </p:nvPr>
+        </p:nvSpPr>
+        <p:spPr>
+          <a:xfrm>
+            <a:off x="1524000" y="340092"/>
+            <a:ext cx="9144000" cy="380877"/>
+          </a:xfrm>
+        </p:spPr>
+        <p:txBody>
+          <a:bodyPr>
+            <a:normAutofit fontScale="92500" lnSpcReduction="10000"/>
+          </a:bodyPr>
+          <a:lstStyle/>
+          <a:p>
+            <a:r>
+              <a:rPr lang="en-IN" b="1" dirty="0" err="1"/>
+              <a:t>clearCellData</a:t>
+            </a:r>
+            <a:endParaRPr lang="en-IN" b="1" dirty="0"/>
+          </a:p>
+        </p:txBody>
+      </p:sp>
+      <p:graphicFrame>
+        <p:nvGraphicFramePr>
+          <p:cNvPr id="4" name="UpdateTable">
+            <a:extLst>
+              <a:ext uri="{FF2B5EF4-FFF2-40B4-BE49-F238E27FC236}">
+                <a16:creationId xmlns:a16="http://schemas.microsoft.com/office/drawing/2014/main" id="{29C5B3A6-5888-F1BB-6D19-70E9DA6E1166}"/>
+              </a:ext>
+            </a:extLst>
+          </p:cNvPr>
+          <p:cNvGraphicFramePr>
+            <a:graphicFrameLocks/>
+          </p:cNvGraphicFramePr>
+          <p:nvPr>
+            <p:extLst>
+              <p:ext uri="{D42A27DB-BD31-4B8C-83A1-F6EECF244321}">
+                <p14:modId xmlns:p14="http://schemas.microsoft.com/office/powerpoint/2010/main" val="3352301125"/>
+              </p:ext>
+            </p:extLst>
+          </p:nvPr>
+        </p:nvGraphicFramePr>
+        <p:xfrm>
+          <a:off x="838200" y="1024010"/>
+          <a:ext cx="10515600" cy="1112520"/>
+        </p:xfrm>
+        <a:graphic>
+          <a:graphicData uri="http://schemas.openxmlformats.org/drawingml/2006/table">
+            <a:tbl>
+              <a:tblPr firstRow="1" bandRow="1">
+                <a:tableStyleId>{5C22544A-7EE6-4342-B048-85BDC9FD1C3A}</a:tableStyleId>
+              </a:tblPr>
+              <a:tblGrid>
+                <a:gridCol w="2103120">
+                  <a:extLst>
+                    <a:ext uri="{9D8B030D-6E8A-4147-A177-3AD203B41FA5}">
+                      <a16:colId xmlns:a16="http://schemas.microsoft.com/office/drawing/2014/main" val="1526623959"/>
+                    </a:ext>
+                  </a:extLst>
+                </a:gridCol>
+                <a:gridCol w="2103120">
+                  <a:extLst>
+                    <a:ext uri="{9D8B030D-6E8A-4147-A177-3AD203B41FA5}">
+                      <a16:colId xmlns:a16="http://schemas.microsoft.com/office/drawing/2014/main" val="1036110465"/>
+                    </a:ext>
+                  </a:extLst>
+                </a:gridCol>
+                <a:gridCol w="2103120">
+                  <a:extLst>
+                    <a:ext uri="{9D8B030D-6E8A-4147-A177-3AD203B41FA5}">
+                      <a16:colId xmlns:a16="http://schemas.microsoft.com/office/drawing/2014/main" val="1994860425"/>
+                    </a:ext>
+                  </a:extLst>
+                </a:gridCol>
+                <a:gridCol w="2103120">
+                  <a:extLst>
+                    <a:ext uri="{9D8B030D-6E8A-4147-A177-3AD203B41FA5}">
+                      <a16:colId xmlns:a16="http://schemas.microsoft.com/office/drawing/2014/main" val="3533840823"/>
+                    </a:ext>
+                  </a:extLst>
+                </a:gridCol>
+                <a:gridCol w="2103120">
+                  <a:extLst>
+                    <a:ext uri="{9D8B030D-6E8A-4147-A177-3AD203B41FA5}">
+                      <a16:colId xmlns:a16="http://schemas.microsoft.com/office/drawing/2014/main" val="1604916882"/>
+                    </a:ext>
+                  </a:extLst>
+                </a:gridCol>
+              </a:tblGrid>
+              <a:tr h="370840">
+                <a:tc gridSpan="2">
+                  <a:txBody>
+                    <a:bodyPr/>
+                    <a:lstStyle/>
+                    <a:p>
+                      <a:pPr algn="ctr"/>
+                      <a:r>
+                        <a:rPr lang="en-IN" dirty="0"/>
+                        <a:t>Department</a:t>
+                      </a:r>
+                    </a:p>
+                  </a:txBody>
+                  <a:tcPr/>
+                </a:tc>
+                <a:tc hMerge="1">
+                  <a:txBody>
+                    <a:bodyPr/>
+                    <a:lstStyle/>
+                    <a:p>
+                      <a:endParaRPr lang="en-IN"/>
+                    </a:p>
+                  </a:txBody>
+                  <a:tcPr/>
+                </a:tc>
+                <a:tc>
+                  <a:txBody>
+                    <a:bodyPr/>
+                    <a:lstStyle/>
+                    <a:p>
+                      <a:r>
+                        <a:rPr dirty="0"/>
+                        <a:t>Q1 Target</a:t>
+                      </a:r>
+                    </a:p>
+                  </a:txBody>
+                  <a:tcPr/>
+                </a:tc>
+                <a:tc>
+                  <a:txBody>
+                    <a:bodyPr/>
+                    <a:lstStyle/>
+                    <a:p>
+                      <a:r>
+                        <a:rPr dirty="0"/>
+                        <a:t>Q1 Actual</a:t>
+                      </a:r>
+                    </a:p>
+                  </a:txBody>
+                  <a:tcPr/>
+                </a:tc>
+                <a:tc>
+                  <a:txBody>
+                    <a:bodyPr/>
+                    <a:lstStyle/>
+                    <a:p>
+                      <a:r>
+                        <a:rPr lang="en-IN" dirty="0"/>
+                        <a:t>Status</a:t>
+                      </a:r>
+                      <a:endParaRPr dirty="0"/>
+                    </a:p>
+                  </a:txBody>
+                  <a:tcPr/>
+                </a:tc>
+                <a:extLst>
+                  <a:ext uri="{0D108BD9-81ED-4DB2-BD59-A6C34878D82A}">
+                    <a16:rowId xmlns:a16="http://schemas.microsoft.com/office/drawing/2014/main" val="1869212938"/>
+                  </a:ext>
+                </a:extLst>
+              </a:tr>
+              <a:tr h="370840">
+                <a:tc gridSpan="2">
+                  <a:txBody>
+                    <a:bodyPr/>
+                    <a:lstStyle/>
+                    <a:p>
+                      <a:pPr marL="0" marR="0" lvl="0" indent="0" algn="ctr" defTabSz="914400" rtl="0" eaLnBrk="1" fontAlgn="auto" latinLnBrk="0" hangingPunct="1">
+                        <a:lnSpc>
+                          <a:spcPct val="100000"/>
+                        </a:lnSpc>
+                        <a:spcBef>
+                          <a:spcPts val="0"/>
+                        </a:spcBef>
+                        <a:spcAft>
+                          <a:spcPts val="0"/>
+                        </a:spcAft>
+                        <a:buClrTx/>
+                        <a:buSzTx/>
+                        <a:buFontTx/>
+                        <a:buNone/>
+                        <a:tabLst/>
+                        <a:defRPr/>
+                      </a:pPr>
+                      <a:r>
+                        <a:rPr lang="en-IN" dirty="0"/>
+                        <a:t>Global Marketing</a:t>
+                      </a:r>
+                    </a:p>
+                  </a:txBody>
+                  <a:tcPr/>
+                </a:tc>
+                <a:tc hMerge="1">
+                  <a:txBody>
+                    <a:bodyPr/>
+                    <a:lstStyle/>
+                    <a:p>
+                      <a:endParaRPr lang="en-IN"/>
+                    </a:p>
+                  </a:txBody>
+                  <a:tcPr/>
+                </a:tc>
+                <a:tc>
+                  <a:txBody>
+                    <a:bodyPr/>
+                    <a:lstStyle/>
+                    <a:p>
+                      <a:r>
+                        <a:rPr dirty="0"/>
+                        <a:t>$500,000</a:t>
+                      </a:r>
+                    </a:p>
+                  </a:txBody>
+                  <a:tcPr/>
+                </a:tc>
+                <a:tc>
+                  <a:txBody>
+                    <a:bodyPr/>
+                    <a:lstStyle/>
+                    <a:p>
+                      <a:r>
+                        <a:rPr dirty="0"/>
+                        <a:t>$520,000</a:t>
+                      </a:r>
+                    </a:p>
+                  </a:txBody>
+                  <a:tcPr/>
+                </a:tc>
+                <a:tc>
+                  <a:txBody>
+                    <a:bodyPr/>
+                    <a:lstStyle/>
+                    <a:p>
+                      <a:endParaRPr dirty="0"/>
+                    </a:p>
+                  </a:txBody>
+                  <a:tcPr/>
+                </a:tc>
+                <a:extLst>
+                  <a:ext uri="{0D108BD9-81ED-4DB2-BD59-A6C34878D82A}">
+                    <a16:rowId xmlns:a16="http://schemas.microsoft.com/office/drawing/2014/main" val="2673184772"/>
+                  </a:ext>
+                </a:extLst>
+              </a:tr>
+              <a:tr h="370840">
+                <a:tc>
+                  <a:txBody>
+                    <a:bodyPr/>
+                    <a:lstStyle/>
+                    <a:p>
+                      <a:pPr algn="ctr"/>
+                      <a:r>
+                        <a:rPr lang="en-IN" dirty="0"/>
+                        <a:t>Engineering</a:t>
+                      </a:r>
+                    </a:p>
+                  </a:txBody>
+                  <a:tcPr/>
+                </a:tc>
+                <a:tc>
+                  <a:txBody>
+                    <a:bodyPr/>
+                    <a:lstStyle/>
+                    <a:p>
+                      <a:pPr algn="ctr"/>
+                      <a:r>
+                        <a:rPr lang="en-IN" dirty="0"/>
+                        <a:t>Product</a:t>
+                      </a:r>
+                    </a:p>
+                  </a:txBody>
+                  <a:tcPr/>
+                </a:tc>
+                <a:tc>
+                  <a:txBody>
+                    <a:bodyPr/>
+                    <a:lstStyle/>
+                    <a:p>
+                      <a:r>
+                        <a:rPr dirty="0"/>
+                        <a:t>$250,000</a:t>
+                      </a:r>
+                    </a:p>
+                  </a:txBody>
+                  <a:tcPr/>
+                </a:tc>
+                <a:tc>
+                  <a:txBody>
+                    <a:bodyPr/>
+                    <a:lstStyle/>
+                    <a:p>
+                      <a:r>
+                        <a:rPr dirty="0"/>
+                        <a:t>$245,000</a:t>
+                      </a:r>
+                    </a:p>
+                  </a:txBody>
+                  <a:tcPr/>
+                </a:tc>
+                <a:tc>
+                  <a:txBody>
+                    <a:bodyPr/>
+                    <a:lstStyle/>
+                    <a:p>
+                      <a:endParaRPr dirty="0"/>
+                    </a:p>
+                  </a:txBody>
+                  <a:tcPr/>
+                </a:tc>
+                <a:extLst>
+                  <a:ext uri="{0D108BD9-81ED-4DB2-BD59-A6C34878D82A}">
+                    <a16:rowId xmlns:a16="http://schemas.microsoft.com/office/drawing/2014/main" val="2462398921"/>
+                  </a:ext>
+                </a:extLst>
+              </a:tr>
+            </a:tbl>
+          </a:graphicData>
+        </a:graphic>
+      </p:graphicFrame>
+      <p:sp>
+        <p:nvSpPr>
+          <p:cNvPr id="5" name="Rectangle 4">
+            <a:extLst>
+              <a:ext uri="{FF2B5EF4-FFF2-40B4-BE49-F238E27FC236}">
+                <a16:creationId xmlns:a16="http://schemas.microsoft.com/office/drawing/2014/main" id="{3BDC568A-8982-7696-6E7A-FA0EF50F8829}"/>
+              </a:ext>
+            </a:extLst>
+          </p:cNvPr>
+          <p:cNvSpPr/>
+          <p:nvPr/>
+        </p:nvSpPr>
+        <p:spPr>
+          <a:xfrm>
+            <a:off x="9328639" y="1461574"/>
+            <a:ext cx="342900" cy="237392"/>
+          </a:xfrm>
+          <a:prstGeom prst="rect">
+            <a:avLst/>
+          </a:prstGeom>
+        </p:spPr>
+        <p:style>
+          <a:lnRef idx="2">
+            <a:schemeClr val="accent1">
+              <a:shade val="15000"/>
+            </a:schemeClr>
+          </a:lnRef>
+          <a:fillRef idx="1">
+            <a:schemeClr val="accent1"/>
+          </a:fillRef>
+          <a:effectRef idx="0">
+            <a:schemeClr val="accent1"/>
+          </a:effectRef>
+          <a:fontRef idx="minor">
+            <a:schemeClr val="lt1"/>
+          </a:fontRef>
+        </p:style>
+        <p:txBody>
+          <a:bodyPr rtlCol="0" anchor="ctr"/>
+          <a:lstStyle/>
+          <a:p>
+            <a:pPr algn="ctr"/>
+            <a:endParaRPr lang="en-IN"/>
+          </a:p>
+        </p:txBody>
+      </p:sp>
+      <p:sp>
+        <p:nvSpPr>
+          <p:cNvPr id="7" name="Oval 6">
+            <a:extLst>
+              <a:ext uri="{FF2B5EF4-FFF2-40B4-BE49-F238E27FC236}">
+                <a16:creationId xmlns:a16="http://schemas.microsoft.com/office/drawing/2014/main" id="{8591A7E0-DD3E-9832-31B5-DB0D630AF29D}"/>
+              </a:ext>
+            </a:extLst>
+          </p:cNvPr>
+          <p:cNvSpPr/>
+          <p:nvPr/>
+        </p:nvSpPr>
+        <p:spPr>
+          <a:xfrm>
+            <a:off x="10155115" y="1811215"/>
+            <a:ext cx="254977" cy="254977"/>
+          </a:xfrm>
+          <a:prstGeom prst="ellipse">
+            <a:avLst/>
+          </a:prstGeom>
+        </p:spPr>
+        <p:style>
+          <a:lnRef idx="2">
+            <a:schemeClr val="accent6">
+              <a:shade val="15000"/>
+            </a:schemeClr>
+          </a:lnRef>
+          <a:fillRef idx="1">
+            <a:schemeClr val="accent6"/>
+          </a:fillRef>
+          <a:effectRef idx="0">
+            <a:schemeClr val="accent6"/>
+          </a:effectRef>
+          <a:fontRef idx="minor">
+            <a:schemeClr val="lt1"/>
+          </a:fontRef>
+        </p:style>
+        <p:txBody>
+          <a:bodyPr rtlCol="0" anchor="ctr"/>
+          <a:lstStyle/>
+          <a:p>
+            <a:pPr algn="ctr"/>
+            <a:endParaRPr lang="en-IN"/>
+          </a:p>
+        </p:txBody>
+      </p:sp>
+    </p:spTree>
+    <p:extLst>
+      <p:ext uri="{BB962C8B-B14F-4D97-AF65-F5344CB8AC3E}">
+        <p14:creationId xmlns:p14="http://schemas.microsoft.com/office/powerpoint/2010/main" val="175517017"/>
+      </p:ext>
+    </p:extLst>
+  </p:cSld>
+  <p:clrMapOvr>
+    <a:masterClrMapping/>
+  </p:clrMapOvr>
+</p:sld>
+</file>
+
+<file path=ppt/slides/slide16.xml><?xml version="1.0" encoding="utf-8"?>
+<p:sld xmlns:a="http://schemas.openxmlformats.org/drawingml/2006/main" xmlns:r="http://schemas.openxmlformats.org/officeDocument/2006/relationships" xmlns:p="http://schemas.openxmlformats.org/presentationml/2006/main">
+  <p:cSld>
+    <p:spTree>
+      <p:nvGrpSpPr>
+        <p:cNvPr id="1" name="">
+          <a:extLst>
+            <a:ext uri="{FF2B5EF4-FFF2-40B4-BE49-F238E27FC236}">
+              <a16:creationId xmlns:a16="http://schemas.microsoft.com/office/drawing/2014/main" id="{146A0363-D833-BFE8-C73A-88D44BDC755D}"/>
+            </a:ext>
+          </a:extLst>
+        </p:cNvPr>
+        <p:cNvGrpSpPr/>
+        <p:nvPr/>
+      </p:nvGrpSpPr>
+      <p:grpSpPr>
+        <a:xfrm>
+          <a:off x="0" y="0"/>
+          <a:ext cx="0" cy="0"/>
+          <a:chOff x="0" y="0"/>
+          <a:chExt cx="0" cy="0"/>
+        </a:xfrm>
+      </p:grpSpPr>
+      <p:sp>
+        <p:nvSpPr>
+          <p:cNvPr id="3" name="Subtitle 2">
+            <a:extLst>
+              <a:ext uri="{FF2B5EF4-FFF2-40B4-BE49-F238E27FC236}">
+                <a16:creationId xmlns:a16="http://schemas.microsoft.com/office/drawing/2014/main" id="{DCEB2EFD-CA21-5206-0020-087A4B1A9910}"/>
+              </a:ext>
+            </a:extLst>
+          </p:cNvPr>
+          <p:cNvSpPr>
+            <a:spLocks noGrp="1"/>
+          </p:cNvSpPr>
+          <p:nvPr>
+            <p:ph type="subTitle" idx="1"/>
+          </p:nvPr>
+        </p:nvSpPr>
+        <p:spPr>
+          <a:xfrm>
+            <a:off x="1524000" y="340092"/>
+            <a:ext cx="9144000" cy="380877"/>
+          </a:xfrm>
+        </p:spPr>
+        <p:txBody>
+          <a:bodyPr>
+            <a:normAutofit fontScale="92500" lnSpcReduction="10000"/>
+          </a:bodyPr>
+          <a:lstStyle/>
+          <a:p>
+            <a:r>
+              <a:rPr lang="en-IN" b="1" dirty="0" err="1"/>
+              <a:t>mergeCells</a:t>
+            </a:r>
+            <a:endParaRPr lang="en-IN" b="1" dirty="0"/>
+          </a:p>
+        </p:txBody>
+      </p:sp>
+      <p:graphicFrame>
+        <p:nvGraphicFramePr>
+          <p:cNvPr id="4" name="UpdateTable">
+            <a:extLst>
+              <a:ext uri="{FF2B5EF4-FFF2-40B4-BE49-F238E27FC236}">
+                <a16:creationId xmlns:a16="http://schemas.microsoft.com/office/drawing/2014/main" id="{6C16D33D-6348-E3BA-7663-45A5DBDFB2E3}"/>
               </a:ext>
             </a:extLst>
           </p:cNvPr>
@@ -5226,7 +6242,7 @@
     </p:spTree>
     <p:extLst>
       <p:ext uri="{BB962C8B-B14F-4D97-AF65-F5344CB8AC3E}">
-        <p14:creationId xmlns:p14="http://schemas.microsoft.com/office/powerpoint/2010/main" val="2181556897"/>
+        <p14:creationId xmlns:p14="http://schemas.microsoft.com/office/powerpoint/2010/main" val="4011267850"/>
       </p:ext>
     </p:extLst>
   </p:cSld>
@@ -5236,7 +6252,7 @@
 </p:sld>
 </file>
 
-<file path=ppt/slides/slide15.xml><?xml version="1.0" encoding="utf-8"?>
+<file path=ppt/slides/slide17.xml><?xml version="1.0" encoding="utf-8"?>
 <p:sld xmlns:a="http://schemas.openxmlformats.org/drawingml/2006/main" xmlns:r="http://schemas.openxmlformats.org/officeDocument/2006/relationships" xmlns:p="http://schemas.openxmlformats.org/presentationml/2006/main">
   <p:cSld>
     <p:spTree>
@@ -5244,7 +6260,7 @@
         <p:cNvPr id="1" name="">
           <a:extLst>
             <a:ext uri="{FF2B5EF4-FFF2-40B4-BE49-F238E27FC236}">
-              <a16:creationId xmlns:a16="http://schemas.microsoft.com/office/drawing/2014/main" id="{11F8C139-8905-2EA4-D49B-FB51814D72D7}"/>
+              <a16:creationId xmlns:a16="http://schemas.microsoft.com/office/drawing/2014/main" id="{C3C16CD4-324C-0B3A-F6AF-C1A009B182FB}"/>
             </a:ext>
           </a:extLst>
         </p:cNvPr>
@@ -5264,7 +6280,7 @@
           <p:cNvPr id="3" name="Subtitle 2">
             <a:extLst>
               <a:ext uri="{FF2B5EF4-FFF2-40B4-BE49-F238E27FC236}">
-                <a16:creationId xmlns:a16="http://schemas.microsoft.com/office/drawing/2014/main" id="{84A764F5-6CCC-8A59-55D8-30B467F85BD5}"/>
+                <a16:creationId xmlns:a16="http://schemas.microsoft.com/office/drawing/2014/main" id="{5D155F54-71B5-11C1-C0E9-966882732701}"/>
               </a:ext>
             </a:extLst>
           </p:cNvPr>
@@ -5289,7 +6305,7 @@
           <a:p>
             <a:r>
               <a:rPr lang="en-IN" b="1" dirty="0" err="1"/>
-              <a:t>clearCellData</a:t>
+              <a:t>splitCell</a:t>
             </a:r>
             <a:endParaRPr lang="en-IN" b="1" dirty="0"/>
           </a:p>
@@ -5300,7 +6316,7 @@
           <p:cNvPr id="4" name="UpdateTable">
             <a:extLst>
               <a:ext uri="{FF2B5EF4-FFF2-40B4-BE49-F238E27FC236}">
-                <a16:creationId xmlns:a16="http://schemas.microsoft.com/office/drawing/2014/main" id="{29C5B3A6-5888-F1BB-6D19-70E9DA6E1166}"/>
+                <a16:creationId xmlns:a16="http://schemas.microsoft.com/office/drawing/2014/main" id="{15727E9B-E8C2-52A0-888C-67D29F6DD631}"/>
               </a:ext>
             </a:extLst>
           </p:cNvPr>
@@ -5590,7 +6606,7 @@
     </p:spTree>
     <p:extLst>
       <p:ext uri="{BB962C8B-B14F-4D97-AF65-F5344CB8AC3E}">
-        <p14:creationId xmlns:p14="http://schemas.microsoft.com/office/powerpoint/2010/main" val="175517017"/>
+        <p14:creationId xmlns:p14="http://schemas.microsoft.com/office/powerpoint/2010/main" val="2264364868"/>
       </p:ext>
     </p:extLst>
   </p:cSld>
@@ -5600,7 +6616,7 @@
 </p:sld>
 </file>
 
-<file path=ppt/slides/slide16.xml><?xml version="1.0" encoding="utf-8"?>
+<file path=ppt/slides/slide18.xml><?xml version="1.0" encoding="utf-8"?>
 <p:sld xmlns:a="http://schemas.openxmlformats.org/drawingml/2006/main" xmlns:r="http://schemas.openxmlformats.org/officeDocument/2006/relationships" xmlns:p="http://schemas.openxmlformats.org/presentationml/2006/main">
   <p:cSld>
     <p:spTree>
@@ -5608,7 +6624,7 @@
         <p:cNvPr id="1" name="">
           <a:extLst>
             <a:ext uri="{FF2B5EF4-FFF2-40B4-BE49-F238E27FC236}">
-              <a16:creationId xmlns:a16="http://schemas.microsoft.com/office/drawing/2014/main" id="{146A0363-D833-BFE8-C73A-88D44BDC755D}"/>
+              <a16:creationId xmlns:a16="http://schemas.microsoft.com/office/drawing/2014/main" id="{2DE5C2A7-71F0-8FC6-7DBB-7C147AF645CA}"/>
             </a:ext>
           </a:extLst>
         </p:cNvPr>
@@ -5628,7 +6644,7 @@
           <p:cNvPr id="3" name="Subtitle 2">
             <a:extLst>
               <a:ext uri="{FF2B5EF4-FFF2-40B4-BE49-F238E27FC236}">
-                <a16:creationId xmlns:a16="http://schemas.microsoft.com/office/drawing/2014/main" id="{DCEB2EFD-CA21-5206-0020-087A4B1A9910}"/>
+                <a16:creationId xmlns:a16="http://schemas.microsoft.com/office/drawing/2014/main" id="{611172CF-323C-E96C-775A-636A6967D5AF}"/>
               </a:ext>
             </a:extLst>
           </p:cNvPr>
@@ -5653,7 +6669,7 @@
           <a:p>
             <a:r>
               <a:rPr lang="en-IN" b="1" dirty="0" err="1"/>
-              <a:t>mergeCells</a:t>
+              <a:t>styleTable</a:t>
             </a:r>
             <a:endParaRPr lang="en-IN" b="1" dirty="0"/>
           </a:p>
@@ -5664,7 +6680,7 @@
           <p:cNvPr id="4" name="UpdateTable">
             <a:extLst>
               <a:ext uri="{FF2B5EF4-FFF2-40B4-BE49-F238E27FC236}">
-                <a16:creationId xmlns:a16="http://schemas.microsoft.com/office/drawing/2014/main" id="{6C16D33D-6348-E3BA-7663-45A5DBDFB2E3}"/>
+                <a16:creationId xmlns:a16="http://schemas.microsoft.com/office/drawing/2014/main" id="{CF894ED1-CD1E-8A7E-8363-860F63369400}"/>
               </a:ext>
             </a:extLst>
           </p:cNvPr>
@@ -5954,7 +6970,7 @@
     </p:spTree>
     <p:extLst>
       <p:ext uri="{BB962C8B-B14F-4D97-AF65-F5344CB8AC3E}">
-        <p14:creationId xmlns:p14="http://schemas.microsoft.com/office/powerpoint/2010/main" val="4011267850"/>
+        <p14:creationId xmlns:p14="http://schemas.microsoft.com/office/powerpoint/2010/main" val="3821484776"/>
       </p:ext>
     </p:extLst>
   </p:cSld>
@@ -5964,7 +6980,7 @@
 </p:sld>
 </file>
 
-<file path=ppt/slides/slide17.xml><?xml version="1.0" encoding="utf-8"?>
+<file path=ppt/slides/slide19.xml><?xml version="1.0" encoding="utf-8"?>
 <p:sld xmlns:a="http://schemas.openxmlformats.org/drawingml/2006/main" xmlns:r="http://schemas.openxmlformats.org/officeDocument/2006/relationships" xmlns:p="http://schemas.openxmlformats.org/presentationml/2006/main">
   <p:cSld>
     <p:spTree>
@@ -5972,7 +6988,7 @@
         <p:cNvPr id="1" name="">
           <a:extLst>
             <a:ext uri="{FF2B5EF4-FFF2-40B4-BE49-F238E27FC236}">
-              <a16:creationId xmlns:a16="http://schemas.microsoft.com/office/drawing/2014/main" id="{C3C16CD4-324C-0B3A-F6AF-C1A009B182FB}"/>
+              <a16:creationId xmlns:a16="http://schemas.microsoft.com/office/drawing/2014/main" id="{0B5E9312-D35E-6987-00EE-E545C10B02B0}"/>
             </a:ext>
           </a:extLst>
         </p:cNvPr>
@@ -5992,7 +7008,7 @@
           <p:cNvPr id="3" name="Subtitle 2">
             <a:extLst>
               <a:ext uri="{FF2B5EF4-FFF2-40B4-BE49-F238E27FC236}">
-                <a16:creationId xmlns:a16="http://schemas.microsoft.com/office/drawing/2014/main" id="{5D155F54-71B5-11C1-C0E9-966882732701}"/>
+                <a16:creationId xmlns:a16="http://schemas.microsoft.com/office/drawing/2014/main" id="{3F2A2705-5609-A47D-00F3-2E148FC601D0}"/>
               </a:ext>
             </a:extLst>
           </p:cNvPr>
@@ -6017,7 +7033,7 @@
           <a:p>
             <a:r>
               <a:rPr lang="en-IN" b="1" dirty="0" err="1"/>
-              <a:t>splitCell</a:t>
+              <a:t>styleColumn</a:t>
             </a:r>
             <a:endParaRPr lang="en-IN" b="1" dirty="0"/>
           </a:p>
@@ -6028,7 +7044,7 @@
           <p:cNvPr id="4" name="UpdateTable">
             <a:extLst>
               <a:ext uri="{FF2B5EF4-FFF2-40B4-BE49-F238E27FC236}">
-                <a16:creationId xmlns:a16="http://schemas.microsoft.com/office/drawing/2014/main" id="{15727E9B-E8C2-52A0-888C-67D29F6DD631}"/>
+                <a16:creationId xmlns:a16="http://schemas.microsoft.com/office/drawing/2014/main" id="{1B0561AA-9FB6-7F8A-25AB-FBDEA39CD2D5}"/>
               </a:ext>
             </a:extLst>
           </p:cNvPr>
@@ -6318,7 +7334,7 @@
     </p:spTree>
     <p:extLst>
       <p:ext uri="{BB962C8B-B14F-4D97-AF65-F5344CB8AC3E}">
-        <p14:creationId xmlns:p14="http://schemas.microsoft.com/office/powerpoint/2010/main" val="2264364868"/>
+        <p14:creationId xmlns:p14="http://schemas.microsoft.com/office/powerpoint/2010/main" val="2703224045"/>
       </p:ext>
     </p:extLst>
   </p:cSld>
@@ -6328,7 +7344,7 @@
 </p:sld>
 </file>
 
-<file path=ppt/slides/slide18.xml><?xml version="1.0" encoding="utf-8"?>
+<file path=ppt/slides/slide2.xml><?xml version="1.0" encoding="utf-8"?>
 <p:sld xmlns:a="http://schemas.openxmlformats.org/drawingml/2006/main" xmlns:r="http://schemas.openxmlformats.org/officeDocument/2006/relationships" xmlns:p="http://schemas.openxmlformats.org/presentationml/2006/main">
   <p:cSld>
     <p:spTree>
@@ -6336,7 +7352,7 @@
         <p:cNvPr id="1" name="">
           <a:extLst>
             <a:ext uri="{FF2B5EF4-FFF2-40B4-BE49-F238E27FC236}">
-              <a16:creationId xmlns:a16="http://schemas.microsoft.com/office/drawing/2014/main" id="{2DE5C2A7-71F0-8FC6-7DBB-7C147AF645CA}"/>
+              <a16:creationId xmlns:a16="http://schemas.microsoft.com/office/drawing/2014/main" id="{74765665-4654-2328-5CB0-3AEFB5B65664}"/>
             </a:ext>
           </a:extLst>
         </p:cNvPr>
@@ -6356,7 +7372,7 @@
           <p:cNvPr id="3" name="Subtitle 2">
             <a:extLst>
               <a:ext uri="{FF2B5EF4-FFF2-40B4-BE49-F238E27FC236}">
-                <a16:creationId xmlns:a16="http://schemas.microsoft.com/office/drawing/2014/main" id="{611172CF-323C-E96C-775A-636A6967D5AF}"/>
+                <a16:creationId xmlns:a16="http://schemas.microsoft.com/office/drawing/2014/main" id="{F79243FD-A4EF-C68B-37DB-D24919C4E5DA}"/>
               </a:ext>
             </a:extLst>
           </p:cNvPr>
@@ -6381,7 +7397,7 @@
           <a:p>
             <a:r>
               <a:rPr lang="en-IN" b="1" dirty="0" err="1"/>
-              <a:t>styleTable</a:t>
+              <a:t>updateTable</a:t>
             </a:r>
             <a:endParaRPr lang="en-IN" b="1" dirty="0"/>
           </a:p>
@@ -6392,7 +7408,371 @@
           <p:cNvPr id="4" name="UpdateTable">
             <a:extLst>
               <a:ext uri="{FF2B5EF4-FFF2-40B4-BE49-F238E27FC236}">
-                <a16:creationId xmlns:a16="http://schemas.microsoft.com/office/drawing/2014/main" id="{CF894ED1-CD1E-8A7E-8363-860F63369400}"/>
+                <a16:creationId xmlns:a16="http://schemas.microsoft.com/office/drawing/2014/main" id="{300A0393-F742-F01C-2B99-FD6539BCF308}"/>
+              </a:ext>
+            </a:extLst>
+          </p:cNvPr>
+          <p:cNvGraphicFramePr>
+            <a:graphicFrameLocks/>
+          </p:cNvGraphicFramePr>
+          <p:nvPr>
+            <p:extLst>
+              <p:ext uri="{D42A27DB-BD31-4B8C-83A1-F6EECF244321}">
+                <p14:modId xmlns:p14="http://schemas.microsoft.com/office/powerpoint/2010/main" val="2848691384"/>
+              </p:ext>
+            </p:extLst>
+          </p:nvPr>
+        </p:nvGraphicFramePr>
+        <p:xfrm>
+          <a:off x="838200" y="1024010"/>
+          <a:ext cx="10515600" cy="1112520"/>
+        </p:xfrm>
+        <a:graphic>
+          <a:graphicData uri="http://schemas.openxmlformats.org/drawingml/2006/table">
+            <a:tbl>
+              <a:tblPr firstRow="1" bandRow="1">
+                <a:tableStyleId>{5C22544A-7EE6-4342-B048-85BDC9FD1C3A}</a:tableStyleId>
+              </a:tblPr>
+              <a:tblGrid>
+                <a:gridCol w="2103120">
+                  <a:extLst>
+                    <a:ext uri="{9D8B030D-6E8A-4147-A177-3AD203B41FA5}">
+                      <a16:colId xmlns:a16="http://schemas.microsoft.com/office/drawing/2014/main" val="1526623959"/>
+                    </a:ext>
+                  </a:extLst>
+                </a:gridCol>
+                <a:gridCol w="2103120">
+                  <a:extLst>
+                    <a:ext uri="{9D8B030D-6E8A-4147-A177-3AD203B41FA5}">
+                      <a16:colId xmlns:a16="http://schemas.microsoft.com/office/drawing/2014/main" val="1036110465"/>
+                    </a:ext>
+                  </a:extLst>
+                </a:gridCol>
+                <a:gridCol w="2103120">
+                  <a:extLst>
+                    <a:ext uri="{9D8B030D-6E8A-4147-A177-3AD203B41FA5}">
+                      <a16:colId xmlns:a16="http://schemas.microsoft.com/office/drawing/2014/main" val="1994860425"/>
+                    </a:ext>
+                  </a:extLst>
+                </a:gridCol>
+                <a:gridCol w="2103120">
+                  <a:extLst>
+                    <a:ext uri="{9D8B030D-6E8A-4147-A177-3AD203B41FA5}">
+                      <a16:colId xmlns:a16="http://schemas.microsoft.com/office/drawing/2014/main" val="3533840823"/>
+                    </a:ext>
+                  </a:extLst>
+                </a:gridCol>
+                <a:gridCol w="2103120">
+                  <a:extLst>
+                    <a:ext uri="{9D8B030D-6E8A-4147-A177-3AD203B41FA5}">
+                      <a16:colId xmlns:a16="http://schemas.microsoft.com/office/drawing/2014/main" val="1604916882"/>
+                    </a:ext>
+                  </a:extLst>
+                </a:gridCol>
+              </a:tblGrid>
+              <a:tr h="370840">
+                <a:tc gridSpan="2">
+                  <a:txBody>
+                    <a:bodyPr/>
+                    <a:lstStyle/>
+                    <a:p>
+                      <a:pPr algn="ctr"/>
+                      <a:r>
+                        <a:rPr lang="en-IN" dirty="0"/>
+                        <a:t>Department</a:t>
+                      </a:r>
+                    </a:p>
+                  </a:txBody>
+                  <a:tcPr/>
+                </a:tc>
+                <a:tc hMerge="1">
+                  <a:txBody>
+                    <a:bodyPr/>
+                    <a:lstStyle/>
+                    <a:p>
+                      <a:endParaRPr lang="en-IN"/>
+                    </a:p>
+                  </a:txBody>
+                  <a:tcPr/>
+                </a:tc>
+                <a:tc>
+                  <a:txBody>
+                    <a:bodyPr/>
+                    <a:lstStyle/>
+                    <a:p>
+                      <a:r>
+                        <a:rPr dirty="0"/>
+                        <a:t>Q1 Target</a:t>
+                      </a:r>
+                    </a:p>
+                  </a:txBody>
+                  <a:tcPr/>
+                </a:tc>
+                <a:tc>
+                  <a:txBody>
+                    <a:bodyPr/>
+                    <a:lstStyle/>
+                    <a:p>
+                      <a:r>
+                        <a:rPr dirty="0"/>
+                        <a:t>Q1 Actual</a:t>
+                      </a:r>
+                    </a:p>
+                  </a:txBody>
+                  <a:tcPr/>
+                </a:tc>
+                <a:tc>
+                  <a:txBody>
+                    <a:bodyPr/>
+                    <a:lstStyle/>
+                    <a:p>
+                      <a:endParaRPr dirty="0"/>
+                    </a:p>
+                  </a:txBody>
+                  <a:tcPr/>
+                </a:tc>
+                <a:extLst>
+                  <a:ext uri="{0D108BD9-81ED-4DB2-BD59-A6C34878D82A}">
+                    <a16:rowId xmlns:a16="http://schemas.microsoft.com/office/drawing/2014/main" val="1869212938"/>
+                  </a:ext>
+                </a:extLst>
+              </a:tr>
+              <a:tr h="370840">
+                <a:tc gridSpan="2">
+                  <a:txBody>
+                    <a:bodyPr/>
+                    <a:lstStyle/>
+                    <a:p>
+                      <a:pPr marL="0" marR="0" lvl="0" indent="0" algn="ctr" defTabSz="914400" rtl="0" eaLnBrk="1" fontAlgn="auto" latinLnBrk="0" hangingPunct="1">
+                        <a:lnSpc>
+                          <a:spcPct val="100000"/>
+                        </a:lnSpc>
+                        <a:spcBef>
+                          <a:spcPts val="0"/>
+                        </a:spcBef>
+                        <a:spcAft>
+                          <a:spcPts val="0"/>
+                        </a:spcAft>
+                        <a:buClrTx/>
+                        <a:buSzTx/>
+                        <a:buFontTx/>
+                        <a:buNone/>
+                        <a:tabLst/>
+                        <a:defRPr/>
+                      </a:pPr>
+                      <a:r>
+                        <a:rPr lang="en-IN" dirty="0"/>
+                        <a:t>Global Marketing</a:t>
+                      </a:r>
+                    </a:p>
+                  </a:txBody>
+                  <a:tcPr/>
+                </a:tc>
+                <a:tc hMerge="1">
+                  <a:txBody>
+                    <a:bodyPr/>
+                    <a:lstStyle/>
+                    <a:p>
+                      <a:endParaRPr lang="en-IN"/>
+                    </a:p>
+                  </a:txBody>
+                  <a:tcPr/>
+                </a:tc>
+                <a:tc>
+                  <a:txBody>
+                    <a:bodyPr/>
+                    <a:lstStyle/>
+                    <a:p>
+                      <a:r>
+                        <a:rPr dirty="0"/>
+                        <a:t>$500,000</a:t>
+                      </a:r>
+                    </a:p>
+                  </a:txBody>
+                  <a:tcPr/>
+                </a:tc>
+                <a:tc>
+                  <a:txBody>
+                    <a:bodyPr/>
+                    <a:lstStyle/>
+                    <a:p>
+                      <a:r>
+                        <a:rPr dirty="0"/>
+                        <a:t>$520,000</a:t>
+                      </a:r>
+                    </a:p>
+                  </a:txBody>
+                  <a:tcPr/>
+                </a:tc>
+                <a:tc>
+                  <a:txBody>
+                    <a:bodyPr/>
+                    <a:lstStyle/>
+                    <a:p>
+                      <a:endParaRPr dirty="0"/>
+                    </a:p>
+                  </a:txBody>
+                  <a:tcPr/>
+                </a:tc>
+                <a:extLst>
+                  <a:ext uri="{0D108BD9-81ED-4DB2-BD59-A6C34878D82A}">
+                    <a16:rowId xmlns:a16="http://schemas.microsoft.com/office/drawing/2014/main" val="2673184772"/>
+                  </a:ext>
+                </a:extLst>
+              </a:tr>
+              <a:tr h="370840">
+                <a:tc>
+                  <a:txBody>
+                    <a:bodyPr/>
+                    <a:lstStyle/>
+                    <a:p>
+                      <a:pPr algn="ctr"/>
+                      <a:r>
+                        <a:rPr lang="en-IN" dirty="0"/>
+                        <a:t>Engineering</a:t>
+                      </a:r>
+                    </a:p>
+                  </a:txBody>
+                  <a:tcPr/>
+                </a:tc>
+                <a:tc>
+                  <a:txBody>
+                    <a:bodyPr/>
+                    <a:lstStyle/>
+                    <a:p>
+                      <a:pPr algn="ctr"/>
+                      <a:r>
+                        <a:rPr lang="en-IN" dirty="0"/>
+                        <a:t>Product</a:t>
+                      </a:r>
+                    </a:p>
+                  </a:txBody>
+                  <a:tcPr/>
+                </a:tc>
+                <a:tc>
+                  <a:txBody>
+                    <a:bodyPr/>
+                    <a:lstStyle/>
+                    <a:p>
+                      <a:r>
+                        <a:rPr dirty="0"/>
+                        <a:t>$250,000</a:t>
+                      </a:r>
+                    </a:p>
+                  </a:txBody>
+                  <a:tcPr/>
+                </a:tc>
+                <a:tc>
+                  <a:txBody>
+                    <a:bodyPr/>
+                    <a:lstStyle/>
+                    <a:p>
+                      <a:r>
+                        <a:rPr dirty="0"/>
+                        <a:t>$245,000</a:t>
+                      </a:r>
+                    </a:p>
+                  </a:txBody>
+                  <a:tcPr/>
+                </a:tc>
+                <a:tc>
+                  <a:txBody>
+                    <a:bodyPr/>
+                    <a:lstStyle/>
+                    <a:p>
+                      <a:endParaRPr dirty="0"/>
+                    </a:p>
+                  </a:txBody>
+                  <a:tcPr/>
+                </a:tc>
+                <a:extLst>
+                  <a:ext uri="{0D108BD9-81ED-4DB2-BD59-A6C34878D82A}">
+                    <a16:rowId xmlns:a16="http://schemas.microsoft.com/office/drawing/2014/main" val="2462398921"/>
+                  </a:ext>
+                </a:extLst>
+              </a:tr>
+            </a:tbl>
+          </a:graphicData>
+        </a:graphic>
+      </p:graphicFrame>
+    </p:spTree>
+    <p:extLst>
+      <p:ext uri="{BB962C8B-B14F-4D97-AF65-F5344CB8AC3E}">
+        <p14:creationId xmlns:p14="http://schemas.microsoft.com/office/powerpoint/2010/main" val="4095613205"/>
+      </p:ext>
+    </p:extLst>
+  </p:cSld>
+  <p:clrMapOvr>
+    <a:masterClrMapping/>
+  </p:clrMapOvr>
+</p:sld>
+</file>
+
+<file path=ppt/slides/slide20.xml><?xml version="1.0" encoding="utf-8"?>
+<p:sld xmlns:a="http://schemas.openxmlformats.org/drawingml/2006/main" xmlns:r="http://schemas.openxmlformats.org/officeDocument/2006/relationships" xmlns:p="http://schemas.openxmlformats.org/presentationml/2006/main">
+  <p:cSld>
+    <p:spTree>
+      <p:nvGrpSpPr>
+        <p:cNvPr id="1" name="">
+          <a:extLst>
+            <a:ext uri="{FF2B5EF4-FFF2-40B4-BE49-F238E27FC236}">
+              <a16:creationId xmlns:a16="http://schemas.microsoft.com/office/drawing/2014/main" id="{AC4DF0A3-E48F-DB21-F862-29DB8B730C2A}"/>
+            </a:ext>
+          </a:extLst>
+        </p:cNvPr>
+        <p:cNvGrpSpPr/>
+        <p:nvPr/>
+      </p:nvGrpSpPr>
+      <p:grpSpPr>
+        <a:xfrm>
+          <a:off x="0" y="0"/>
+          <a:ext cx="0" cy="0"/>
+          <a:chOff x="0" y="0"/>
+          <a:chExt cx="0" cy="0"/>
+        </a:xfrm>
+      </p:grpSpPr>
+      <p:sp>
+        <p:nvSpPr>
+          <p:cNvPr id="3" name="Subtitle 2">
+            <a:extLst>
+              <a:ext uri="{FF2B5EF4-FFF2-40B4-BE49-F238E27FC236}">
+                <a16:creationId xmlns:a16="http://schemas.microsoft.com/office/drawing/2014/main" id="{D0BF13AF-9988-C34E-19AD-5120F990B3D9}"/>
+              </a:ext>
+            </a:extLst>
+          </p:cNvPr>
+          <p:cNvSpPr>
+            <a:spLocks noGrp="1"/>
+          </p:cNvSpPr>
+          <p:nvPr>
+            <p:ph type="subTitle" idx="1"/>
+          </p:nvPr>
+        </p:nvSpPr>
+        <p:spPr>
+          <a:xfrm>
+            <a:off x="1524000" y="340092"/>
+            <a:ext cx="9144000" cy="380877"/>
+          </a:xfrm>
+        </p:spPr>
+        <p:txBody>
+          <a:bodyPr>
+            <a:normAutofit fontScale="92500" lnSpcReduction="10000"/>
+          </a:bodyPr>
+          <a:lstStyle/>
+          <a:p>
+            <a:r>
+              <a:rPr lang="en-IN" b="1" dirty="0" err="1"/>
+              <a:t>styleRow</a:t>
+            </a:r>
+            <a:endParaRPr lang="en-IN" b="1" dirty="0"/>
+          </a:p>
+        </p:txBody>
+      </p:sp>
+      <p:graphicFrame>
+        <p:nvGraphicFramePr>
+          <p:cNvPr id="4" name="UpdateTable">
+            <a:extLst>
+              <a:ext uri="{FF2B5EF4-FFF2-40B4-BE49-F238E27FC236}">
+                <a16:creationId xmlns:a16="http://schemas.microsoft.com/office/drawing/2014/main" id="{514F4F1B-9653-A4E1-BD07-73A31A82FAE5}"/>
               </a:ext>
             </a:extLst>
           </p:cNvPr>
@@ -6682,7 +8062,7 @@
     </p:spTree>
     <p:extLst>
       <p:ext uri="{BB962C8B-B14F-4D97-AF65-F5344CB8AC3E}">
-        <p14:creationId xmlns:p14="http://schemas.microsoft.com/office/powerpoint/2010/main" val="3821484776"/>
+        <p14:creationId xmlns:p14="http://schemas.microsoft.com/office/powerpoint/2010/main" val="1023019502"/>
       </p:ext>
     </p:extLst>
   </p:cSld>
@@ -6692,7 +8072,7 @@
 </p:sld>
 </file>
 
-<file path=ppt/slides/slide19.xml><?xml version="1.0" encoding="utf-8"?>
+<file path=ppt/slides/slide21.xml><?xml version="1.0" encoding="utf-8"?>
 <p:sld xmlns:a="http://schemas.openxmlformats.org/drawingml/2006/main" xmlns:r="http://schemas.openxmlformats.org/officeDocument/2006/relationships" xmlns:p="http://schemas.openxmlformats.org/presentationml/2006/main">
   <p:cSld>
     <p:spTree>
@@ -6700,7 +8080,7 @@
         <p:cNvPr id="1" name="">
           <a:extLst>
             <a:ext uri="{FF2B5EF4-FFF2-40B4-BE49-F238E27FC236}">
-              <a16:creationId xmlns:a16="http://schemas.microsoft.com/office/drawing/2014/main" id="{0B5E9312-D35E-6987-00EE-E545C10B02B0}"/>
+              <a16:creationId xmlns:a16="http://schemas.microsoft.com/office/drawing/2014/main" id="{C472BA87-A7CD-5279-BF28-C7488F5700DE}"/>
             </a:ext>
           </a:extLst>
         </p:cNvPr>
@@ -6720,7 +8100,7 @@
           <p:cNvPr id="3" name="Subtitle 2">
             <a:extLst>
               <a:ext uri="{FF2B5EF4-FFF2-40B4-BE49-F238E27FC236}">
-                <a16:creationId xmlns:a16="http://schemas.microsoft.com/office/drawing/2014/main" id="{3F2A2705-5609-A47D-00F3-2E148FC601D0}"/>
+                <a16:creationId xmlns:a16="http://schemas.microsoft.com/office/drawing/2014/main" id="{A6F471E8-C609-63EF-ED39-B06788033540}"/>
               </a:ext>
             </a:extLst>
           </p:cNvPr>
@@ -6745,7 +8125,7 @@
           <a:p>
             <a:r>
               <a:rPr lang="en-IN" b="1" dirty="0" err="1"/>
-              <a:t>styleColumn</a:t>
+              <a:t>styleCell</a:t>
             </a:r>
             <a:endParaRPr lang="en-IN" b="1" dirty="0"/>
           </a:p>
@@ -6756,7 +8136,7 @@
           <p:cNvPr id="4" name="UpdateTable">
             <a:extLst>
               <a:ext uri="{FF2B5EF4-FFF2-40B4-BE49-F238E27FC236}">
-                <a16:creationId xmlns:a16="http://schemas.microsoft.com/office/drawing/2014/main" id="{1B0561AA-9FB6-7F8A-25AB-FBDEA39CD2D5}"/>
+                <a16:creationId xmlns:a16="http://schemas.microsoft.com/office/drawing/2014/main" id="{B05C0DE4-BC8A-F702-C8DC-46688D9B6B68}"/>
               </a:ext>
             </a:extLst>
           </p:cNvPr>
@@ -7046,7 +8426,7 @@
     </p:spTree>
     <p:extLst>
       <p:ext uri="{BB962C8B-B14F-4D97-AF65-F5344CB8AC3E}">
-        <p14:creationId xmlns:p14="http://schemas.microsoft.com/office/powerpoint/2010/main" val="2703224045"/>
+        <p14:creationId xmlns:p14="http://schemas.microsoft.com/office/powerpoint/2010/main" val="1433047158"/>
       </p:ext>
     </p:extLst>
   </p:cSld>
@@ -7056,7 +8436,7 @@
 </p:sld>
 </file>
 
-<file path=ppt/slides/slide2.xml><?xml version="1.0" encoding="utf-8"?>
+<file path=ppt/slides/slide3.xml><?xml version="1.0" encoding="utf-8"?>
 <p:sld xmlns:a="http://schemas.openxmlformats.org/drawingml/2006/main" xmlns:r="http://schemas.openxmlformats.org/officeDocument/2006/relationships" xmlns:p="http://schemas.openxmlformats.org/presentationml/2006/main">
   <p:cSld>
     <p:spTree>
@@ -7064,7 +8444,7 @@
         <p:cNvPr id="1" name="">
           <a:extLst>
             <a:ext uri="{FF2B5EF4-FFF2-40B4-BE49-F238E27FC236}">
-              <a16:creationId xmlns:a16="http://schemas.microsoft.com/office/drawing/2014/main" id="{74765665-4654-2328-5CB0-3AEFB5B65664}"/>
+              <a16:creationId xmlns:a16="http://schemas.microsoft.com/office/drawing/2014/main" id="{EFFB792F-E739-8C40-5F77-DF6F21ECBDB2}"/>
             </a:ext>
           </a:extLst>
         </p:cNvPr>
@@ -7084,7 +8464,7 @@
           <p:cNvPr id="3" name="Subtitle 2">
             <a:extLst>
               <a:ext uri="{FF2B5EF4-FFF2-40B4-BE49-F238E27FC236}">
-                <a16:creationId xmlns:a16="http://schemas.microsoft.com/office/drawing/2014/main" id="{F79243FD-A4EF-C68B-37DB-D24919C4E5DA}"/>
+                <a16:creationId xmlns:a16="http://schemas.microsoft.com/office/drawing/2014/main" id="{970AFF2A-B21B-34F9-DAD8-91D039FB445D}"/>
               </a:ext>
             </a:extLst>
           </p:cNvPr>
@@ -7109,7 +8489,7 @@
           <a:p>
             <a:r>
               <a:rPr lang="en-IN" b="1" dirty="0" err="1"/>
-              <a:t>updateTable</a:t>
+              <a:t>updateTableData</a:t>
             </a:r>
             <a:endParaRPr lang="en-IN" b="1" dirty="0"/>
           </a:p>
@@ -7117,374 +8497,10 @@
       </p:sp>
       <p:graphicFrame>
         <p:nvGraphicFramePr>
-          <p:cNvPr id="4" name="UpdateTable">
-            <a:extLst>
-              <a:ext uri="{FF2B5EF4-FFF2-40B4-BE49-F238E27FC236}">
-                <a16:creationId xmlns:a16="http://schemas.microsoft.com/office/drawing/2014/main" id="{300A0393-F742-F01C-2B99-FD6539BCF308}"/>
-              </a:ext>
-            </a:extLst>
-          </p:cNvPr>
-          <p:cNvGraphicFramePr>
-            <a:graphicFrameLocks/>
-          </p:cNvGraphicFramePr>
-          <p:nvPr>
-            <p:extLst>
-              <p:ext uri="{D42A27DB-BD31-4B8C-83A1-F6EECF244321}">
-                <p14:modId xmlns:p14="http://schemas.microsoft.com/office/powerpoint/2010/main" val="2848691384"/>
-              </p:ext>
-            </p:extLst>
-          </p:nvPr>
-        </p:nvGraphicFramePr>
-        <p:xfrm>
-          <a:off x="838200" y="1024010"/>
-          <a:ext cx="10515600" cy="1112520"/>
-        </p:xfrm>
-        <a:graphic>
-          <a:graphicData uri="http://schemas.openxmlformats.org/drawingml/2006/table">
-            <a:tbl>
-              <a:tblPr firstRow="1" bandRow="1">
-                <a:tableStyleId>{5C22544A-7EE6-4342-B048-85BDC9FD1C3A}</a:tableStyleId>
-              </a:tblPr>
-              <a:tblGrid>
-                <a:gridCol w="2103120">
-                  <a:extLst>
-                    <a:ext uri="{9D8B030D-6E8A-4147-A177-3AD203B41FA5}">
-                      <a16:colId xmlns:a16="http://schemas.microsoft.com/office/drawing/2014/main" val="1526623959"/>
-                    </a:ext>
-                  </a:extLst>
-                </a:gridCol>
-                <a:gridCol w="2103120">
-                  <a:extLst>
-                    <a:ext uri="{9D8B030D-6E8A-4147-A177-3AD203B41FA5}">
-                      <a16:colId xmlns:a16="http://schemas.microsoft.com/office/drawing/2014/main" val="1036110465"/>
-                    </a:ext>
-                  </a:extLst>
-                </a:gridCol>
-                <a:gridCol w="2103120">
-                  <a:extLst>
-                    <a:ext uri="{9D8B030D-6E8A-4147-A177-3AD203B41FA5}">
-                      <a16:colId xmlns:a16="http://schemas.microsoft.com/office/drawing/2014/main" val="1994860425"/>
-                    </a:ext>
-                  </a:extLst>
-                </a:gridCol>
-                <a:gridCol w="2103120">
-                  <a:extLst>
-                    <a:ext uri="{9D8B030D-6E8A-4147-A177-3AD203B41FA5}">
-                      <a16:colId xmlns:a16="http://schemas.microsoft.com/office/drawing/2014/main" val="3533840823"/>
-                    </a:ext>
-                  </a:extLst>
-                </a:gridCol>
-                <a:gridCol w="2103120">
-                  <a:extLst>
-                    <a:ext uri="{9D8B030D-6E8A-4147-A177-3AD203B41FA5}">
-                      <a16:colId xmlns:a16="http://schemas.microsoft.com/office/drawing/2014/main" val="1604916882"/>
-                    </a:ext>
-                  </a:extLst>
-                </a:gridCol>
-              </a:tblGrid>
-              <a:tr h="370840">
-                <a:tc gridSpan="2">
-                  <a:txBody>
-                    <a:bodyPr/>
-                    <a:lstStyle/>
-                    <a:p>
-                      <a:pPr algn="ctr"/>
-                      <a:r>
-                        <a:rPr lang="en-IN" dirty="0"/>
-                        <a:t>Department</a:t>
-                      </a:r>
-                    </a:p>
-                  </a:txBody>
-                  <a:tcPr/>
-                </a:tc>
-                <a:tc hMerge="1">
-                  <a:txBody>
-                    <a:bodyPr/>
-                    <a:lstStyle/>
-                    <a:p>
-                      <a:endParaRPr lang="en-IN"/>
-                    </a:p>
-                  </a:txBody>
-                  <a:tcPr/>
-                </a:tc>
-                <a:tc>
-                  <a:txBody>
-                    <a:bodyPr/>
-                    <a:lstStyle/>
-                    <a:p>
-                      <a:r>
-                        <a:rPr dirty="0"/>
-                        <a:t>Q1 Target</a:t>
-                      </a:r>
-                    </a:p>
-                  </a:txBody>
-                  <a:tcPr/>
-                </a:tc>
-                <a:tc>
-                  <a:txBody>
-                    <a:bodyPr/>
-                    <a:lstStyle/>
-                    <a:p>
-                      <a:r>
-                        <a:rPr dirty="0"/>
-                        <a:t>Q1 Actual</a:t>
-                      </a:r>
-                    </a:p>
-                  </a:txBody>
-                  <a:tcPr/>
-                </a:tc>
-                <a:tc>
-                  <a:txBody>
-                    <a:bodyPr/>
-                    <a:lstStyle/>
-                    <a:p>
-                      <a:endParaRPr dirty="0"/>
-                    </a:p>
-                  </a:txBody>
-                  <a:tcPr/>
-                </a:tc>
-                <a:extLst>
-                  <a:ext uri="{0D108BD9-81ED-4DB2-BD59-A6C34878D82A}">
-                    <a16:rowId xmlns:a16="http://schemas.microsoft.com/office/drawing/2014/main" val="1869212938"/>
-                  </a:ext>
-                </a:extLst>
-              </a:tr>
-              <a:tr h="370840">
-                <a:tc gridSpan="2">
-                  <a:txBody>
-                    <a:bodyPr/>
-                    <a:lstStyle/>
-                    <a:p>
-                      <a:pPr marL="0" marR="0" lvl="0" indent="0" algn="ctr" defTabSz="914400" rtl="0" eaLnBrk="1" fontAlgn="auto" latinLnBrk="0" hangingPunct="1">
-                        <a:lnSpc>
-                          <a:spcPct val="100000"/>
-                        </a:lnSpc>
-                        <a:spcBef>
-                          <a:spcPts val="0"/>
-                        </a:spcBef>
-                        <a:spcAft>
-                          <a:spcPts val="0"/>
-                        </a:spcAft>
-                        <a:buClrTx/>
-                        <a:buSzTx/>
-                        <a:buFontTx/>
-                        <a:buNone/>
-                        <a:tabLst/>
-                        <a:defRPr/>
-                      </a:pPr>
-                      <a:r>
-                        <a:rPr lang="en-IN" dirty="0"/>
-                        <a:t>Global Marketing</a:t>
-                      </a:r>
-                    </a:p>
-                  </a:txBody>
-                  <a:tcPr/>
-                </a:tc>
-                <a:tc hMerge="1">
-                  <a:txBody>
-                    <a:bodyPr/>
-                    <a:lstStyle/>
-                    <a:p>
-                      <a:endParaRPr lang="en-IN"/>
-                    </a:p>
-                  </a:txBody>
-                  <a:tcPr/>
-                </a:tc>
-                <a:tc>
-                  <a:txBody>
-                    <a:bodyPr/>
-                    <a:lstStyle/>
-                    <a:p>
-                      <a:r>
-                        <a:rPr dirty="0"/>
-                        <a:t>$500,000</a:t>
-                      </a:r>
-                    </a:p>
-                  </a:txBody>
-                  <a:tcPr/>
-                </a:tc>
-                <a:tc>
-                  <a:txBody>
-                    <a:bodyPr/>
-                    <a:lstStyle/>
-                    <a:p>
-                      <a:r>
-                        <a:rPr dirty="0"/>
-                        <a:t>$520,000</a:t>
-                      </a:r>
-                    </a:p>
-                  </a:txBody>
-                  <a:tcPr/>
-                </a:tc>
-                <a:tc>
-                  <a:txBody>
-                    <a:bodyPr/>
-                    <a:lstStyle/>
-                    <a:p>
-                      <a:endParaRPr dirty="0"/>
-                    </a:p>
-                  </a:txBody>
-                  <a:tcPr/>
-                </a:tc>
-                <a:extLst>
-                  <a:ext uri="{0D108BD9-81ED-4DB2-BD59-A6C34878D82A}">
-                    <a16:rowId xmlns:a16="http://schemas.microsoft.com/office/drawing/2014/main" val="2673184772"/>
-                  </a:ext>
-                </a:extLst>
-              </a:tr>
-              <a:tr h="370840">
-                <a:tc>
-                  <a:txBody>
-                    <a:bodyPr/>
-                    <a:lstStyle/>
-                    <a:p>
-                      <a:pPr algn="ctr"/>
-                      <a:r>
-                        <a:rPr lang="en-IN" dirty="0"/>
-                        <a:t>Engineering</a:t>
-                      </a:r>
-                    </a:p>
-                  </a:txBody>
-                  <a:tcPr/>
-                </a:tc>
-                <a:tc>
-                  <a:txBody>
-                    <a:bodyPr/>
-                    <a:lstStyle/>
-                    <a:p>
-                      <a:pPr algn="ctr"/>
-                      <a:r>
-                        <a:rPr lang="en-IN" dirty="0"/>
-                        <a:t>Product</a:t>
-                      </a:r>
-                    </a:p>
-                  </a:txBody>
-                  <a:tcPr/>
-                </a:tc>
-                <a:tc>
-                  <a:txBody>
-                    <a:bodyPr/>
-                    <a:lstStyle/>
-                    <a:p>
-                      <a:r>
-                        <a:rPr dirty="0"/>
-                        <a:t>$250,000</a:t>
-                      </a:r>
-                    </a:p>
-                  </a:txBody>
-                  <a:tcPr/>
-                </a:tc>
-                <a:tc>
-                  <a:txBody>
-                    <a:bodyPr/>
-                    <a:lstStyle/>
-                    <a:p>
-                      <a:r>
-                        <a:rPr dirty="0"/>
-                        <a:t>$245,000</a:t>
-                      </a:r>
-                    </a:p>
-                  </a:txBody>
-                  <a:tcPr/>
-                </a:tc>
-                <a:tc>
-                  <a:txBody>
-                    <a:bodyPr/>
-                    <a:lstStyle/>
-                    <a:p>
-                      <a:endParaRPr dirty="0"/>
-                    </a:p>
-                  </a:txBody>
-                  <a:tcPr/>
-                </a:tc>
-                <a:extLst>
-                  <a:ext uri="{0D108BD9-81ED-4DB2-BD59-A6C34878D82A}">
-                    <a16:rowId xmlns:a16="http://schemas.microsoft.com/office/drawing/2014/main" val="2462398921"/>
-                  </a:ext>
-                </a:extLst>
-              </a:tr>
-            </a:tbl>
-          </a:graphicData>
-        </a:graphic>
-      </p:graphicFrame>
-    </p:spTree>
-    <p:extLst>
-      <p:ext uri="{BB962C8B-B14F-4D97-AF65-F5344CB8AC3E}">
-        <p14:creationId xmlns:p14="http://schemas.microsoft.com/office/powerpoint/2010/main" val="4095613205"/>
-      </p:ext>
-    </p:extLst>
-  </p:cSld>
-  <p:clrMapOvr>
-    <a:masterClrMapping/>
-  </p:clrMapOvr>
-</p:sld>
-</file>
-
-<file path=ppt/slides/slide20.xml><?xml version="1.0" encoding="utf-8"?>
-<p:sld xmlns:a="http://schemas.openxmlformats.org/drawingml/2006/main" xmlns:r="http://schemas.openxmlformats.org/officeDocument/2006/relationships" xmlns:p="http://schemas.openxmlformats.org/presentationml/2006/main">
-  <p:cSld>
-    <p:spTree>
-      <p:nvGrpSpPr>
-        <p:cNvPr id="1" name="">
-          <a:extLst>
-            <a:ext uri="{FF2B5EF4-FFF2-40B4-BE49-F238E27FC236}">
-              <a16:creationId xmlns:a16="http://schemas.microsoft.com/office/drawing/2014/main" id="{AC4DF0A3-E48F-DB21-F862-29DB8B730C2A}"/>
-            </a:ext>
-          </a:extLst>
-        </p:cNvPr>
-        <p:cNvGrpSpPr/>
-        <p:nvPr/>
-      </p:nvGrpSpPr>
-      <p:grpSpPr>
-        <a:xfrm>
-          <a:off x="0" y="0"/>
-          <a:ext cx="0" cy="0"/>
-          <a:chOff x="0" y="0"/>
-          <a:chExt cx="0" cy="0"/>
-        </a:xfrm>
-      </p:grpSpPr>
-      <p:sp>
-        <p:nvSpPr>
-          <p:cNvPr id="3" name="Subtitle 2">
-            <a:extLst>
-              <a:ext uri="{FF2B5EF4-FFF2-40B4-BE49-F238E27FC236}">
-                <a16:creationId xmlns:a16="http://schemas.microsoft.com/office/drawing/2014/main" id="{D0BF13AF-9988-C34E-19AD-5120F990B3D9}"/>
-              </a:ext>
-            </a:extLst>
-          </p:cNvPr>
-          <p:cNvSpPr>
-            <a:spLocks noGrp="1"/>
-          </p:cNvSpPr>
-          <p:nvPr>
-            <p:ph type="subTitle" idx="1"/>
-          </p:nvPr>
-        </p:nvSpPr>
-        <p:spPr>
-          <a:xfrm>
-            <a:off x="1524000" y="340092"/>
-            <a:ext cx="9144000" cy="380877"/>
-          </a:xfrm>
-        </p:spPr>
-        <p:txBody>
-          <a:bodyPr>
-            <a:normAutofit fontScale="92500" lnSpcReduction="10000"/>
-          </a:bodyPr>
-          <a:lstStyle/>
-          <a:p>
-            <a:r>
-              <a:rPr lang="en-IN" b="1" dirty="0" err="1"/>
-              <a:t>styleRow</a:t>
-            </a:r>
-            <a:endParaRPr lang="en-IN" b="1" dirty="0"/>
-          </a:p>
-        </p:txBody>
-      </p:sp>
-      <p:graphicFrame>
-        <p:nvGraphicFramePr>
-          <p:cNvPr id="4" name="UpdateTable">
-            <a:extLst>
-              <a:ext uri="{FF2B5EF4-FFF2-40B4-BE49-F238E27FC236}">
-                <a16:creationId xmlns:a16="http://schemas.microsoft.com/office/drawing/2014/main" id="{514F4F1B-9653-A4E1-BD07-73A31A82FAE5}"/>
+          <p:cNvPr id="6" name="UpdateTable">
+            <a:extLst>
+              <a:ext uri="{FF2B5EF4-FFF2-40B4-BE49-F238E27FC236}">
+                <a16:creationId xmlns:a16="http://schemas.microsoft.com/office/drawing/2014/main" id="{BE98AB81-673A-03EF-4B48-FC66C4A24AAA}"/>
               </a:ext>
             </a:extLst>
           </p:cNvPr>
@@ -7774,7 +8790,7 @@
     </p:spTree>
     <p:extLst>
       <p:ext uri="{BB962C8B-B14F-4D97-AF65-F5344CB8AC3E}">
-        <p14:creationId xmlns:p14="http://schemas.microsoft.com/office/powerpoint/2010/main" val="1023019502"/>
+        <p14:creationId xmlns:p14="http://schemas.microsoft.com/office/powerpoint/2010/main" val="1121382331"/>
       </p:ext>
     </p:extLst>
   </p:cSld>
@@ -7784,7 +8800,7 @@
 </p:sld>
 </file>
 
-<file path=ppt/slides/slide21.xml><?xml version="1.0" encoding="utf-8"?>
+<file path=ppt/slides/slide4.xml><?xml version="1.0" encoding="utf-8"?>
 <p:sld xmlns:a="http://schemas.openxmlformats.org/drawingml/2006/main" xmlns:r="http://schemas.openxmlformats.org/officeDocument/2006/relationships" xmlns:p="http://schemas.openxmlformats.org/presentationml/2006/main">
   <p:cSld>
     <p:spTree>
@@ -7792,7 +8808,7 @@
         <p:cNvPr id="1" name="">
           <a:extLst>
             <a:ext uri="{FF2B5EF4-FFF2-40B4-BE49-F238E27FC236}">
-              <a16:creationId xmlns:a16="http://schemas.microsoft.com/office/drawing/2014/main" id="{C472BA87-A7CD-5279-BF28-C7488F5700DE}"/>
+              <a16:creationId xmlns:a16="http://schemas.microsoft.com/office/drawing/2014/main" id="{087E1792-8E73-2FA6-E171-5A9FA16B7180}"/>
             </a:ext>
           </a:extLst>
         </p:cNvPr>
@@ -7812,7 +8828,7 @@
           <p:cNvPr id="3" name="Subtitle 2">
             <a:extLst>
               <a:ext uri="{FF2B5EF4-FFF2-40B4-BE49-F238E27FC236}">
-                <a16:creationId xmlns:a16="http://schemas.microsoft.com/office/drawing/2014/main" id="{A6F471E8-C609-63EF-ED39-B06788033540}"/>
+                <a16:creationId xmlns:a16="http://schemas.microsoft.com/office/drawing/2014/main" id="{34280283-C3D5-92C4-58D6-69FFD63325CF}"/>
               </a:ext>
             </a:extLst>
           </p:cNvPr>
@@ -7837,7 +8853,7 @@
           <a:p>
             <a:r>
               <a:rPr lang="en-IN" b="1" dirty="0" err="1"/>
-              <a:t>styleCell</a:t>
+              <a:t>removeTable</a:t>
             </a:r>
             <a:endParaRPr lang="en-IN" b="1" dirty="0"/>
           </a:p>
@@ -7845,10 +8861,10 @@
       </p:sp>
       <p:graphicFrame>
         <p:nvGraphicFramePr>
-          <p:cNvPr id="4" name="UpdateTable">
-            <a:extLst>
-              <a:ext uri="{FF2B5EF4-FFF2-40B4-BE49-F238E27FC236}">
-                <a16:creationId xmlns:a16="http://schemas.microsoft.com/office/drawing/2014/main" id="{B05C0DE4-BC8A-F702-C8DC-46688D9B6B68}"/>
+          <p:cNvPr id="6" name="UpdateTable">
+            <a:extLst>
+              <a:ext uri="{FF2B5EF4-FFF2-40B4-BE49-F238E27FC236}">
+                <a16:creationId xmlns:a16="http://schemas.microsoft.com/office/drawing/2014/main" id="{533B111E-3064-040D-C535-37D7520B8A04}"/>
               </a:ext>
             </a:extLst>
           </p:cNvPr>
@@ -8135,10 +9151,102 @@
           </a:graphicData>
         </a:graphic>
       </p:graphicFrame>
+      <p:sp>
+        <p:nvSpPr>
+          <p:cNvPr id="4" name="Rectangle 3">
+            <a:extLst>
+              <a:ext uri="{FF2B5EF4-FFF2-40B4-BE49-F238E27FC236}">
+                <a16:creationId xmlns:a16="http://schemas.microsoft.com/office/drawing/2014/main" id="{B4F88E00-06BC-9A59-ABC4-A07B671AD10A}"/>
+              </a:ext>
+            </a:extLst>
+          </p:cNvPr>
+          <p:cNvSpPr/>
+          <p:nvPr/>
+        </p:nvSpPr>
+        <p:spPr>
+          <a:xfrm>
+            <a:off x="9328639" y="1461574"/>
+            <a:ext cx="342900" cy="237392"/>
+          </a:xfrm>
+          <a:prstGeom prst="rect">
+            <a:avLst/>
+          </a:prstGeom>
+        </p:spPr>
+        <p:style>
+          <a:lnRef idx="2">
+            <a:schemeClr val="accent1">
+              <a:shade val="15000"/>
+            </a:schemeClr>
+          </a:lnRef>
+          <a:fillRef idx="1">
+            <a:schemeClr val="accent1"/>
+          </a:fillRef>
+          <a:effectRef idx="0">
+            <a:schemeClr val="accent1"/>
+          </a:effectRef>
+          <a:fontRef idx="minor">
+            <a:schemeClr val="lt1"/>
+          </a:fontRef>
+        </p:style>
+        <p:txBody>
+          <a:bodyPr rtlCol="0" anchor="ctr"/>
+          <a:lstStyle/>
+          <a:p>
+            <a:pPr algn="ctr"/>
+            <a:endParaRPr lang="en-IN"/>
+          </a:p>
+        </p:txBody>
+      </p:sp>
+      <p:sp>
+        <p:nvSpPr>
+          <p:cNvPr id="7" name="Oval 6">
+            <a:extLst>
+              <a:ext uri="{FF2B5EF4-FFF2-40B4-BE49-F238E27FC236}">
+                <a16:creationId xmlns:a16="http://schemas.microsoft.com/office/drawing/2014/main" id="{C0A83AF2-7F4D-211B-BA1C-916DCCEB2599}"/>
+              </a:ext>
+            </a:extLst>
+          </p:cNvPr>
+          <p:cNvSpPr/>
+          <p:nvPr/>
+        </p:nvSpPr>
+        <p:spPr>
+          <a:xfrm>
+            <a:off x="10155115" y="1811215"/>
+            <a:ext cx="254977" cy="254977"/>
+          </a:xfrm>
+          <a:prstGeom prst="ellipse">
+            <a:avLst/>
+          </a:prstGeom>
+        </p:spPr>
+        <p:style>
+          <a:lnRef idx="2">
+            <a:schemeClr val="accent6">
+              <a:shade val="15000"/>
+            </a:schemeClr>
+          </a:lnRef>
+          <a:fillRef idx="1">
+            <a:schemeClr val="accent6"/>
+          </a:fillRef>
+          <a:effectRef idx="0">
+            <a:schemeClr val="accent6"/>
+          </a:effectRef>
+          <a:fontRef idx="minor">
+            <a:schemeClr val="lt1"/>
+          </a:fontRef>
+        </p:style>
+        <p:txBody>
+          <a:bodyPr rtlCol="0" anchor="ctr"/>
+          <a:lstStyle/>
+          <a:p>
+            <a:pPr algn="ctr"/>
+            <a:endParaRPr lang="en-IN"/>
+          </a:p>
+        </p:txBody>
+      </p:sp>
     </p:spTree>
     <p:extLst>
       <p:ext uri="{BB962C8B-B14F-4D97-AF65-F5344CB8AC3E}">
-        <p14:creationId xmlns:p14="http://schemas.microsoft.com/office/powerpoint/2010/main" val="1433047158"/>
+        <p14:creationId xmlns:p14="http://schemas.microsoft.com/office/powerpoint/2010/main" val="895589941"/>
       </p:ext>
     </p:extLst>
   </p:cSld>
@@ -8148,7 +9256,7 @@
 </p:sld>
 </file>
 
-<file path=ppt/slides/slide3.xml><?xml version="1.0" encoding="utf-8"?>
+<file path=ppt/slides/slide5.xml><?xml version="1.0" encoding="utf-8"?>
 <p:sld xmlns:a="http://schemas.openxmlformats.org/drawingml/2006/main" xmlns:r="http://schemas.openxmlformats.org/officeDocument/2006/relationships" xmlns:p="http://schemas.openxmlformats.org/presentationml/2006/main">
   <p:cSld>
     <p:spTree>
@@ -8156,7 +9264,7 @@
         <p:cNvPr id="1" name="">
           <a:extLst>
             <a:ext uri="{FF2B5EF4-FFF2-40B4-BE49-F238E27FC236}">
-              <a16:creationId xmlns:a16="http://schemas.microsoft.com/office/drawing/2014/main" id="{EFFB792F-E739-8C40-5F77-DF6F21ECBDB2}"/>
+              <a16:creationId xmlns:a16="http://schemas.microsoft.com/office/drawing/2014/main" id="{9B4474D6-8E11-A4F6-9FD0-9D2F17B985D7}"/>
             </a:ext>
           </a:extLst>
         </p:cNvPr>
@@ -8176,7 +9284,7 @@
           <p:cNvPr id="3" name="Subtitle 2">
             <a:extLst>
               <a:ext uri="{FF2B5EF4-FFF2-40B4-BE49-F238E27FC236}">
-                <a16:creationId xmlns:a16="http://schemas.microsoft.com/office/drawing/2014/main" id="{970AFF2A-B21B-34F9-DAD8-91D039FB445D}"/>
+                <a16:creationId xmlns:a16="http://schemas.microsoft.com/office/drawing/2014/main" id="{941DF8AE-F4A7-10E3-7D6E-659C7EA76BAC}"/>
               </a:ext>
             </a:extLst>
           </p:cNvPr>
@@ -8201,7 +9309,7 @@
           <a:p>
             <a:r>
               <a:rPr lang="en-IN" b="1" dirty="0" err="1"/>
-              <a:t>updateTableData</a:t>
+              <a:t>cloneTable</a:t>
             </a:r>
             <a:endParaRPr lang="en-IN" b="1" dirty="0"/>
           </a:p>
@@ -8209,10 +9317,470 @@
       </p:sp>
       <p:graphicFrame>
         <p:nvGraphicFramePr>
-          <p:cNvPr id="6" name="UpdateTable">
-            <a:extLst>
-              <a:ext uri="{FF2B5EF4-FFF2-40B4-BE49-F238E27FC236}">
-                <a16:creationId xmlns:a16="http://schemas.microsoft.com/office/drawing/2014/main" id="{BE98AB81-673A-03EF-4B48-FC66C4A24AAA}"/>
+          <p:cNvPr id="4" name="UpdateTable">
+            <a:extLst>
+              <a:ext uri="{FF2B5EF4-FFF2-40B4-BE49-F238E27FC236}">
+                <a16:creationId xmlns:a16="http://schemas.microsoft.com/office/drawing/2014/main" id="{E38E004C-64AB-C0CB-C6CE-3A2A5B5D10D6}"/>
+              </a:ext>
+            </a:extLst>
+          </p:cNvPr>
+          <p:cNvGraphicFramePr>
+            <a:graphicFrameLocks/>
+          </p:cNvGraphicFramePr>
+          <p:nvPr>
+            <p:extLst>
+              <p:ext uri="{D42A27DB-BD31-4B8C-83A1-F6EECF244321}">
+                <p14:modId xmlns:p14="http://schemas.microsoft.com/office/powerpoint/2010/main" val="466749911"/>
+              </p:ext>
+            </p:extLst>
+          </p:nvPr>
+        </p:nvGraphicFramePr>
+        <p:xfrm>
+          <a:off x="838200" y="1024010"/>
+          <a:ext cx="10515600" cy="1112520"/>
+        </p:xfrm>
+        <a:graphic>
+          <a:graphicData uri="http://schemas.openxmlformats.org/drawingml/2006/table">
+            <a:tbl>
+              <a:tblPr firstRow="1" bandRow="1">
+                <a:tableStyleId>{5C22544A-7EE6-4342-B048-85BDC9FD1C3A}</a:tableStyleId>
+              </a:tblPr>
+              <a:tblGrid>
+                <a:gridCol w="2103120">
+                  <a:extLst>
+                    <a:ext uri="{9D8B030D-6E8A-4147-A177-3AD203B41FA5}">
+                      <a16:colId xmlns:a16="http://schemas.microsoft.com/office/drawing/2014/main" val="1526623959"/>
+                    </a:ext>
+                  </a:extLst>
+                </a:gridCol>
+                <a:gridCol w="2103120">
+                  <a:extLst>
+                    <a:ext uri="{9D8B030D-6E8A-4147-A177-3AD203B41FA5}">
+                      <a16:colId xmlns:a16="http://schemas.microsoft.com/office/drawing/2014/main" val="1036110465"/>
+                    </a:ext>
+                  </a:extLst>
+                </a:gridCol>
+                <a:gridCol w="2103120">
+                  <a:extLst>
+                    <a:ext uri="{9D8B030D-6E8A-4147-A177-3AD203B41FA5}">
+                      <a16:colId xmlns:a16="http://schemas.microsoft.com/office/drawing/2014/main" val="1994860425"/>
+                    </a:ext>
+                  </a:extLst>
+                </a:gridCol>
+                <a:gridCol w="2103120">
+                  <a:extLst>
+                    <a:ext uri="{9D8B030D-6E8A-4147-A177-3AD203B41FA5}">
+                      <a16:colId xmlns:a16="http://schemas.microsoft.com/office/drawing/2014/main" val="3533840823"/>
+                    </a:ext>
+                  </a:extLst>
+                </a:gridCol>
+                <a:gridCol w="2103120">
+                  <a:extLst>
+                    <a:ext uri="{9D8B030D-6E8A-4147-A177-3AD203B41FA5}">
+                      <a16:colId xmlns:a16="http://schemas.microsoft.com/office/drawing/2014/main" val="1604916882"/>
+                    </a:ext>
+                  </a:extLst>
+                </a:gridCol>
+              </a:tblGrid>
+              <a:tr h="370840">
+                <a:tc gridSpan="2">
+                  <a:txBody>
+                    <a:bodyPr/>
+                    <a:lstStyle/>
+                    <a:p>
+                      <a:pPr algn="ctr"/>
+                      <a:r>
+                        <a:rPr lang="en-IN" dirty="0"/>
+                        <a:t>Department</a:t>
+                      </a:r>
+                    </a:p>
+                  </a:txBody>
+                  <a:tcPr/>
+                </a:tc>
+                <a:tc hMerge="1">
+                  <a:txBody>
+                    <a:bodyPr/>
+                    <a:lstStyle/>
+                    <a:p>
+                      <a:endParaRPr lang="en-IN"/>
+                    </a:p>
+                  </a:txBody>
+                  <a:tcPr/>
+                </a:tc>
+                <a:tc>
+                  <a:txBody>
+                    <a:bodyPr/>
+                    <a:lstStyle/>
+                    <a:p>
+                      <a:r>
+                        <a:rPr dirty="0"/>
+                        <a:t>Q1 Target</a:t>
+                      </a:r>
+                    </a:p>
+                  </a:txBody>
+                  <a:tcPr/>
+                </a:tc>
+                <a:tc>
+                  <a:txBody>
+                    <a:bodyPr/>
+                    <a:lstStyle/>
+                    <a:p>
+                      <a:r>
+                        <a:rPr dirty="0"/>
+                        <a:t>Q1 Actual</a:t>
+                      </a:r>
+                    </a:p>
+                  </a:txBody>
+                  <a:tcPr/>
+                </a:tc>
+                <a:tc>
+                  <a:txBody>
+                    <a:bodyPr/>
+                    <a:lstStyle/>
+                    <a:p>
+                      <a:r>
+                        <a:rPr lang="en-IN" dirty="0"/>
+                        <a:t>Status</a:t>
+                      </a:r>
+                      <a:endParaRPr dirty="0"/>
+                    </a:p>
+                  </a:txBody>
+                  <a:tcPr/>
+                </a:tc>
+                <a:extLst>
+                  <a:ext uri="{0D108BD9-81ED-4DB2-BD59-A6C34878D82A}">
+                    <a16:rowId xmlns:a16="http://schemas.microsoft.com/office/drawing/2014/main" val="1869212938"/>
+                  </a:ext>
+                </a:extLst>
+              </a:tr>
+              <a:tr h="370840">
+                <a:tc gridSpan="2">
+                  <a:txBody>
+                    <a:bodyPr/>
+                    <a:lstStyle/>
+                    <a:p>
+                      <a:pPr marL="0" marR="0" lvl="0" indent="0" algn="ctr" defTabSz="914400" rtl="0" eaLnBrk="1" fontAlgn="auto" latinLnBrk="0" hangingPunct="1">
+                        <a:lnSpc>
+                          <a:spcPct val="100000"/>
+                        </a:lnSpc>
+                        <a:spcBef>
+                          <a:spcPts val="0"/>
+                        </a:spcBef>
+                        <a:spcAft>
+                          <a:spcPts val="0"/>
+                        </a:spcAft>
+                        <a:buClrTx/>
+                        <a:buSzTx/>
+                        <a:buFontTx/>
+                        <a:buNone/>
+                        <a:tabLst/>
+                        <a:defRPr/>
+                      </a:pPr>
+                      <a:r>
+                        <a:rPr lang="en-IN" dirty="0"/>
+                        <a:t>Global Marketing</a:t>
+                      </a:r>
+                    </a:p>
+                  </a:txBody>
+                  <a:tcPr/>
+                </a:tc>
+                <a:tc hMerge="1">
+                  <a:txBody>
+                    <a:bodyPr/>
+                    <a:lstStyle/>
+                    <a:p>
+                      <a:endParaRPr lang="en-IN"/>
+                    </a:p>
+                  </a:txBody>
+                  <a:tcPr/>
+                </a:tc>
+                <a:tc>
+                  <a:txBody>
+                    <a:bodyPr/>
+                    <a:lstStyle/>
+                    <a:p>
+                      <a:r>
+                        <a:rPr dirty="0"/>
+                        <a:t>$500,000</a:t>
+                      </a:r>
+                    </a:p>
+                  </a:txBody>
+                  <a:tcPr/>
+                </a:tc>
+                <a:tc>
+                  <a:txBody>
+                    <a:bodyPr/>
+                    <a:lstStyle/>
+                    <a:p>
+                      <a:r>
+                        <a:rPr dirty="0"/>
+                        <a:t>$520,000</a:t>
+                      </a:r>
+                    </a:p>
+                  </a:txBody>
+                  <a:tcPr/>
+                </a:tc>
+                <a:tc>
+                  <a:txBody>
+                    <a:bodyPr/>
+                    <a:lstStyle/>
+                    <a:p>
+                      <a:endParaRPr dirty="0"/>
+                    </a:p>
+                  </a:txBody>
+                  <a:tcPr/>
+                </a:tc>
+                <a:extLst>
+                  <a:ext uri="{0D108BD9-81ED-4DB2-BD59-A6C34878D82A}">
+                    <a16:rowId xmlns:a16="http://schemas.microsoft.com/office/drawing/2014/main" val="2673184772"/>
+                  </a:ext>
+                </a:extLst>
+              </a:tr>
+              <a:tr h="370840">
+                <a:tc>
+                  <a:txBody>
+                    <a:bodyPr/>
+                    <a:lstStyle/>
+                    <a:p>
+                      <a:pPr algn="ctr"/>
+                      <a:r>
+                        <a:rPr lang="en-IN" dirty="0"/>
+                        <a:t>Engineering</a:t>
+                      </a:r>
+                    </a:p>
+                  </a:txBody>
+                  <a:tcPr/>
+                </a:tc>
+                <a:tc>
+                  <a:txBody>
+                    <a:bodyPr/>
+                    <a:lstStyle/>
+                    <a:p>
+                      <a:pPr algn="ctr"/>
+                      <a:r>
+                        <a:rPr lang="en-IN" dirty="0"/>
+                        <a:t>Product</a:t>
+                      </a:r>
+                    </a:p>
+                  </a:txBody>
+                  <a:tcPr/>
+                </a:tc>
+                <a:tc>
+                  <a:txBody>
+                    <a:bodyPr/>
+                    <a:lstStyle/>
+                    <a:p>
+                      <a:r>
+                        <a:rPr dirty="0"/>
+                        <a:t>$250,000</a:t>
+                      </a:r>
+                    </a:p>
+                  </a:txBody>
+                  <a:tcPr/>
+                </a:tc>
+                <a:tc>
+                  <a:txBody>
+                    <a:bodyPr/>
+                    <a:lstStyle/>
+                    <a:p>
+                      <a:r>
+                        <a:rPr dirty="0"/>
+                        <a:t>$245,000</a:t>
+                      </a:r>
+                    </a:p>
+                  </a:txBody>
+                  <a:tcPr/>
+                </a:tc>
+                <a:tc>
+                  <a:txBody>
+                    <a:bodyPr/>
+                    <a:lstStyle/>
+                    <a:p>
+                      <a:endParaRPr dirty="0"/>
+                    </a:p>
+                  </a:txBody>
+                  <a:tcPr/>
+                </a:tc>
+                <a:extLst>
+                  <a:ext uri="{0D108BD9-81ED-4DB2-BD59-A6C34878D82A}">
+                    <a16:rowId xmlns:a16="http://schemas.microsoft.com/office/drawing/2014/main" val="2462398921"/>
+                  </a:ext>
+                </a:extLst>
+              </a:tr>
+            </a:tbl>
+          </a:graphicData>
+        </a:graphic>
+      </p:graphicFrame>
+      <p:sp>
+        <p:nvSpPr>
+          <p:cNvPr id="2" name="Rectangle 1">
+            <a:extLst>
+              <a:ext uri="{FF2B5EF4-FFF2-40B4-BE49-F238E27FC236}">
+                <a16:creationId xmlns:a16="http://schemas.microsoft.com/office/drawing/2014/main" id="{B28A95C9-3E2B-2721-19FA-7E92F5790E8D}"/>
+              </a:ext>
+            </a:extLst>
+          </p:cNvPr>
+          <p:cNvSpPr/>
+          <p:nvPr/>
+        </p:nvSpPr>
+        <p:spPr>
+          <a:xfrm>
+            <a:off x="9328639" y="1461574"/>
+            <a:ext cx="342900" cy="237392"/>
+          </a:xfrm>
+          <a:prstGeom prst="rect">
+            <a:avLst/>
+          </a:prstGeom>
+        </p:spPr>
+        <p:style>
+          <a:lnRef idx="2">
+            <a:schemeClr val="accent1">
+              <a:shade val="15000"/>
+            </a:schemeClr>
+          </a:lnRef>
+          <a:fillRef idx="1">
+            <a:schemeClr val="accent1"/>
+          </a:fillRef>
+          <a:effectRef idx="0">
+            <a:schemeClr val="accent1"/>
+          </a:effectRef>
+          <a:fontRef idx="minor">
+            <a:schemeClr val="lt1"/>
+          </a:fontRef>
+        </p:style>
+        <p:txBody>
+          <a:bodyPr rtlCol="0" anchor="ctr"/>
+          <a:lstStyle/>
+          <a:p>
+            <a:pPr algn="ctr"/>
+            <a:endParaRPr lang="en-IN"/>
+          </a:p>
+        </p:txBody>
+      </p:sp>
+      <p:sp>
+        <p:nvSpPr>
+          <p:cNvPr id="5" name="Oval 4">
+            <a:extLst>
+              <a:ext uri="{FF2B5EF4-FFF2-40B4-BE49-F238E27FC236}">
+                <a16:creationId xmlns:a16="http://schemas.microsoft.com/office/drawing/2014/main" id="{9268F384-786F-94F3-8770-FFB8B03C4869}"/>
+              </a:ext>
+            </a:extLst>
+          </p:cNvPr>
+          <p:cNvSpPr/>
+          <p:nvPr/>
+        </p:nvSpPr>
+        <p:spPr>
+          <a:xfrm>
+            <a:off x="10155115" y="1811215"/>
+            <a:ext cx="254977" cy="254977"/>
+          </a:xfrm>
+          <a:prstGeom prst="ellipse">
+            <a:avLst/>
+          </a:prstGeom>
+        </p:spPr>
+        <p:style>
+          <a:lnRef idx="2">
+            <a:schemeClr val="accent6">
+              <a:shade val="15000"/>
+            </a:schemeClr>
+          </a:lnRef>
+          <a:fillRef idx="1">
+            <a:schemeClr val="accent6"/>
+          </a:fillRef>
+          <a:effectRef idx="0">
+            <a:schemeClr val="accent6"/>
+          </a:effectRef>
+          <a:fontRef idx="minor">
+            <a:schemeClr val="lt1"/>
+          </a:fontRef>
+        </p:style>
+        <p:txBody>
+          <a:bodyPr rtlCol="0" anchor="ctr"/>
+          <a:lstStyle/>
+          <a:p>
+            <a:pPr algn="ctr"/>
+            <a:endParaRPr lang="en-IN"/>
+          </a:p>
+        </p:txBody>
+      </p:sp>
+    </p:spTree>
+    <p:extLst>
+      <p:ext uri="{BB962C8B-B14F-4D97-AF65-F5344CB8AC3E}">
+        <p14:creationId xmlns:p14="http://schemas.microsoft.com/office/powerpoint/2010/main" val="2929641799"/>
+      </p:ext>
+    </p:extLst>
+  </p:cSld>
+  <p:clrMapOvr>
+    <a:masterClrMapping/>
+  </p:clrMapOvr>
+</p:sld>
+</file>
+
+<file path=ppt/slides/slide6.xml><?xml version="1.0" encoding="utf-8"?>
+<p:sld xmlns:a="http://schemas.openxmlformats.org/drawingml/2006/main" xmlns:r="http://schemas.openxmlformats.org/officeDocument/2006/relationships" xmlns:p="http://schemas.openxmlformats.org/presentationml/2006/main">
+  <p:cSld>
+    <p:spTree>
+      <p:nvGrpSpPr>
+        <p:cNvPr id="1" name="">
+          <a:extLst>
+            <a:ext uri="{FF2B5EF4-FFF2-40B4-BE49-F238E27FC236}">
+              <a16:creationId xmlns:a16="http://schemas.microsoft.com/office/drawing/2014/main" id="{2171E301-BFD3-7B4C-6311-651C85C3C297}"/>
+            </a:ext>
+          </a:extLst>
+        </p:cNvPr>
+        <p:cNvGrpSpPr/>
+        <p:nvPr/>
+      </p:nvGrpSpPr>
+      <p:grpSpPr>
+        <a:xfrm>
+          <a:off x="0" y="0"/>
+          <a:ext cx="0" cy="0"/>
+          <a:chOff x="0" y="0"/>
+          <a:chExt cx="0" cy="0"/>
+        </a:xfrm>
+      </p:grpSpPr>
+      <p:sp>
+        <p:nvSpPr>
+          <p:cNvPr id="3" name="Subtitle 2">
+            <a:extLst>
+              <a:ext uri="{FF2B5EF4-FFF2-40B4-BE49-F238E27FC236}">
+                <a16:creationId xmlns:a16="http://schemas.microsoft.com/office/drawing/2014/main" id="{7BCD5AED-1D15-0251-E462-CEC86F7D248D}"/>
+              </a:ext>
+            </a:extLst>
+          </p:cNvPr>
+          <p:cNvSpPr>
+            <a:spLocks noGrp="1"/>
+          </p:cNvSpPr>
+          <p:nvPr>
+            <p:ph type="subTitle" idx="1"/>
+          </p:nvPr>
+        </p:nvSpPr>
+        <p:spPr>
+          <a:xfrm>
+            <a:off x="1524000" y="340092"/>
+            <a:ext cx="9144000" cy="380877"/>
+          </a:xfrm>
+        </p:spPr>
+        <p:txBody>
+          <a:bodyPr>
+            <a:normAutofit fontScale="92500" lnSpcReduction="10000"/>
+          </a:bodyPr>
+          <a:lstStyle/>
+          <a:p>
+            <a:r>
+              <a:rPr lang="en-IN" b="1" dirty="0" err="1"/>
+              <a:t>addTableRow</a:t>
+            </a:r>
+            <a:endParaRPr lang="en-IN" b="1" dirty="0"/>
+          </a:p>
+        </p:txBody>
+      </p:sp>
+      <p:graphicFrame>
+        <p:nvGraphicFramePr>
+          <p:cNvPr id="4" name="UpdateTable">
+            <a:extLst>
+              <a:ext uri="{FF2B5EF4-FFF2-40B4-BE49-F238E27FC236}">
+                <a16:creationId xmlns:a16="http://schemas.microsoft.com/office/drawing/2014/main" id="{BF6AEF37-B3F6-EA3B-BECB-FA48FBCEBFD1}"/>
               </a:ext>
             </a:extLst>
           </p:cNvPr>
@@ -8502,7 +10070,7 @@
     </p:spTree>
     <p:extLst>
       <p:ext uri="{BB962C8B-B14F-4D97-AF65-F5344CB8AC3E}">
-        <p14:creationId xmlns:p14="http://schemas.microsoft.com/office/powerpoint/2010/main" val="1121382331"/>
+        <p14:creationId xmlns:p14="http://schemas.microsoft.com/office/powerpoint/2010/main" val="3736847163"/>
       </p:ext>
     </p:extLst>
   </p:cSld>
@@ -8512,7 +10080,7 @@
 </p:sld>
 </file>
 
-<file path=ppt/slides/slide4.xml><?xml version="1.0" encoding="utf-8"?>
+<file path=ppt/slides/slide7.xml><?xml version="1.0" encoding="utf-8"?>
 <p:sld xmlns:a="http://schemas.openxmlformats.org/drawingml/2006/main" xmlns:r="http://schemas.openxmlformats.org/officeDocument/2006/relationships" xmlns:p="http://schemas.openxmlformats.org/presentationml/2006/main">
   <p:cSld>
     <p:spTree>
@@ -8520,7 +10088,7 @@
         <p:cNvPr id="1" name="">
           <a:extLst>
             <a:ext uri="{FF2B5EF4-FFF2-40B4-BE49-F238E27FC236}">
-              <a16:creationId xmlns:a16="http://schemas.microsoft.com/office/drawing/2014/main" id="{087E1792-8E73-2FA6-E171-5A9FA16B7180}"/>
+              <a16:creationId xmlns:a16="http://schemas.microsoft.com/office/drawing/2014/main" id="{21246C05-2DCA-B98A-7BD0-3D4E73013299}"/>
             </a:ext>
           </a:extLst>
         </p:cNvPr>
@@ -8540,7 +10108,7 @@
           <p:cNvPr id="3" name="Subtitle 2">
             <a:extLst>
               <a:ext uri="{FF2B5EF4-FFF2-40B4-BE49-F238E27FC236}">
-                <a16:creationId xmlns:a16="http://schemas.microsoft.com/office/drawing/2014/main" id="{34280283-C3D5-92C4-58D6-69FFD63325CF}"/>
+                <a16:creationId xmlns:a16="http://schemas.microsoft.com/office/drawing/2014/main" id="{7DF20BAB-1E33-AEE8-6075-FA1E371C6990}"/>
               </a:ext>
             </a:extLst>
           </p:cNvPr>
@@ -8565,7 +10133,7 @@
           <a:p>
             <a:r>
               <a:rPr lang="en-IN" b="1" dirty="0" err="1"/>
-              <a:t>removeTable</a:t>
+              <a:t>addTableColumn</a:t>
             </a:r>
             <a:endParaRPr lang="en-IN" b="1" dirty="0"/>
           </a:p>
@@ -8573,10 +10141,10 @@
       </p:sp>
       <p:graphicFrame>
         <p:nvGraphicFramePr>
-          <p:cNvPr id="6" name="UpdateTable">
-            <a:extLst>
-              <a:ext uri="{FF2B5EF4-FFF2-40B4-BE49-F238E27FC236}">
-                <a16:creationId xmlns:a16="http://schemas.microsoft.com/office/drawing/2014/main" id="{533B111E-3064-040D-C535-37D7520B8A04}"/>
+          <p:cNvPr id="4" name="UpdateTable">
+            <a:extLst>
+              <a:ext uri="{FF2B5EF4-FFF2-40B4-BE49-F238E27FC236}">
+                <a16:creationId xmlns:a16="http://schemas.microsoft.com/office/drawing/2014/main" id="{1E75463E-D89B-73EB-C580-774CFE13FDF3}"/>
               </a:ext>
             </a:extLst>
           </p:cNvPr>
@@ -8866,7 +10434,7 @@
     </p:spTree>
     <p:extLst>
       <p:ext uri="{BB962C8B-B14F-4D97-AF65-F5344CB8AC3E}">
-        <p14:creationId xmlns:p14="http://schemas.microsoft.com/office/powerpoint/2010/main" val="895589941"/>
+        <p14:creationId xmlns:p14="http://schemas.microsoft.com/office/powerpoint/2010/main" val="3556156674"/>
       </p:ext>
     </p:extLst>
   </p:cSld>
@@ -8876,7 +10444,7 @@
 </p:sld>
 </file>
 
-<file path=ppt/slides/slide5.xml><?xml version="1.0" encoding="utf-8"?>
+<file path=ppt/slides/slide8.xml><?xml version="1.0" encoding="utf-8"?>
 <p:sld xmlns:a="http://schemas.openxmlformats.org/drawingml/2006/main" xmlns:r="http://schemas.openxmlformats.org/officeDocument/2006/relationships" xmlns:p="http://schemas.openxmlformats.org/presentationml/2006/main">
   <p:cSld>
     <p:spTree>
@@ -8884,7 +10452,7 @@
         <p:cNvPr id="1" name="">
           <a:extLst>
             <a:ext uri="{FF2B5EF4-FFF2-40B4-BE49-F238E27FC236}">
-              <a16:creationId xmlns:a16="http://schemas.microsoft.com/office/drawing/2014/main" id="{9B4474D6-8E11-A4F6-9FD0-9D2F17B985D7}"/>
+              <a16:creationId xmlns:a16="http://schemas.microsoft.com/office/drawing/2014/main" id="{52EFA33D-1F6F-6665-5D7C-75D0D2519AD8}"/>
             </a:ext>
           </a:extLst>
         </p:cNvPr>
@@ -8904,7 +10472,7 @@
           <p:cNvPr id="3" name="Subtitle 2">
             <a:extLst>
               <a:ext uri="{FF2B5EF4-FFF2-40B4-BE49-F238E27FC236}">
-                <a16:creationId xmlns:a16="http://schemas.microsoft.com/office/drawing/2014/main" id="{941DF8AE-F4A7-10E3-7D6E-659C7EA76BAC}"/>
+                <a16:creationId xmlns:a16="http://schemas.microsoft.com/office/drawing/2014/main" id="{96DC7814-3B30-E8B6-9643-28A9572BDA1A}"/>
               </a:ext>
             </a:extLst>
           </p:cNvPr>
@@ -8929,7 +10497,7 @@
           <a:p>
             <a:r>
               <a:rPr lang="en-IN" b="1" dirty="0" err="1"/>
-              <a:t>cloneTable</a:t>
+              <a:t>removeTableRow</a:t>
             </a:r>
             <a:endParaRPr lang="en-IN" b="1" dirty="0"/>
           </a:p>
@@ -8940,7 +10508,7 @@
           <p:cNvPr id="4" name="UpdateTable">
             <a:extLst>
               <a:ext uri="{FF2B5EF4-FFF2-40B4-BE49-F238E27FC236}">
-                <a16:creationId xmlns:a16="http://schemas.microsoft.com/office/drawing/2014/main" id="{E38E004C-64AB-C0CB-C6CE-3A2A5B5D10D6}"/>
+                <a16:creationId xmlns:a16="http://schemas.microsoft.com/office/drawing/2014/main" id="{46C80F9D-7082-4835-6197-A64FF1B6D4BD}"/>
               </a:ext>
             </a:extLst>
           </p:cNvPr>
@@ -9227,10 +10795,102 @@
           </a:graphicData>
         </a:graphic>
       </p:graphicFrame>
+      <p:sp>
+        <p:nvSpPr>
+          <p:cNvPr id="5" name="Rectangle 4">
+            <a:extLst>
+              <a:ext uri="{FF2B5EF4-FFF2-40B4-BE49-F238E27FC236}">
+                <a16:creationId xmlns:a16="http://schemas.microsoft.com/office/drawing/2014/main" id="{E1D27020-5FF5-C74F-301E-96FA01C9B834}"/>
+              </a:ext>
+            </a:extLst>
+          </p:cNvPr>
+          <p:cNvSpPr/>
+          <p:nvPr/>
+        </p:nvSpPr>
+        <p:spPr>
+          <a:xfrm>
+            <a:off x="9328639" y="1461574"/>
+            <a:ext cx="342900" cy="237392"/>
+          </a:xfrm>
+          <a:prstGeom prst="rect">
+            <a:avLst/>
+          </a:prstGeom>
+        </p:spPr>
+        <p:style>
+          <a:lnRef idx="2">
+            <a:schemeClr val="accent1">
+              <a:shade val="15000"/>
+            </a:schemeClr>
+          </a:lnRef>
+          <a:fillRef idx="1">
+            <a:schemeClr val="accent1"/>
+          </a:fillRef>
+          <a:effectRef idx="0">
+            <a:schemeClr val="accent1"/>
+          </a:effectRef>
+          <a:fontRef idx="minor">
+            <a:schemeClr val="lt1"/>
+          </a:fontRef>
+        </p:style>
+        <p:txBody>
+          <a:bodyPr rtlCol="0" anchor="ctr"/>
+          <a:lstStyle/>
+          <a:p>
+            <a:pPr algn="ctr"/>
+            <a:endParaRPr lang="en-IN"/>
+          </a:p>
+        </p:txBody>
+      </p:sp>
+      <p:sp>
+        <p:nvSpPr>
+          <p:cNvPr id="7" name="Oval 6">
+            <a:extLst>
+              <a:ext uri="{FF2B5EF4-FFF2-40B4-BE49-F238E27FC236}">
+                <a16:creationId xmlns:a16="http://schemas.microsoft.com/office/drawing/2014/main" id="{966307F8-89EC-A28A-7CF8-4CCEAEC9E563}"/>
+              </a:ext>
+            </a:extLst>
+          </p:cNvPr>
+          <p:cNvSpPr/>
+          <p:nvPr/>
+        </p:nvSpPr>
+        <p:spPr>
+          <a:xfrm>
+            <a:off x="10155115" y="1811215"/>
+            <a:ext cx="254977" cy="254977"/>
+          </a:xfrm>
+          <a:prstGeom prst="ellipse">
+            <a:avLst/>
+          </a:prstGeom>
+        </p:spPr>
+        <p:style>
+          <a:lnRef idx="2">
+            <a:schemeClr val="accent6">
+              <a:shade val="15000"/>
+            </a:schemeClr>
+          </a:lnRef>
+          <a:fillRef idx="1">
+            <a:schemeClr val="accent6"/>
+          </a:fillRef>
+          <a:effectRef idx="0">
+            <a:schemeClr val="accent6"/>
+          </a:effectRef>
+          <a:fontRef idx="minor">
+            <a:schemeClr val="lt1"/>
+          </a:fontRef>
+        </p:style>
+        <p:txBody>
+          <a:bodyPr rtlCol="0" anchor="ctr"/>
+          <a:lstStyle/>
+          <a:p>
+            <a:pPr algn="ctr"/>
+            <a:endParaRPr lang="en-IN"/>
+          </a:p>
+        </p:txBody>
+      </p:sp>
     </p:spTree>
     <p:extLst>
       <p:ext uri="{BB962C8B-B14F-4D97-AF65-F5344CB8AC3E}">
-        <p14:creationId xmlns:p14="http://schemas.microsoft.com/office/powerpoint/2010/main" val="2929641799"/>
+        <p14:creationId xmlns:p14="http://schemas.microsoft.com/office/powerpoint/2010/main" val="3890693090"/>
       </p:ext>
     </p:extLst>
   </p:cSld>
@@ -9240,7 +10900,7 @@
 </p:sld>
 </file>
 
-<file path=ppt/slides/slide6.xml><?xml version="1.0" encoding="utf-8"?>
+<file path=ppt/slides/slide9.xml><?xml version="1.0" encoding="utf-8"?>
 <p:sld xmlns:a="http://schemas.openxmlformats.org/drawingml/2006/main" xmlns:r="http://schemas.openxmlformats.org/officeDocument/2006/relationships" xmlns:p="http://schemas.openxmlformats.org/presentationml/2006/main">
   <p:cSld>
     <p:spTree>
@@ -9248,7 +10908,7 @@
         <p:cNvPr id="1" name="">
           <a:extLst>
             <a:ext uri="{FF2B5EF4-FFF2-40B4-BE49-F238E27FC236}">
-              <a16:creationId xmlns:a16="http://schemas.microsoft.com/office/drawing/2014/main" id="{2171E301-BFD3-7B4C-6311-651C85C3C297}"/>
+              <a16:creationId xmlns:a16="http://schemas.microsoft.com/office/drawing/2014/main" id="{147117A5-34F4-3F38-36CA-AF5AED3E7EA6}"/>
             </a:ext>
           </a:extLst>
         </p:cNvPr>
@@ -9268,7 +10928,7 @@
           <p:cNvPr id="3" name="Subtitle 2">
             <a:extLst>
               <a:ext uri="{FF2B5EF4-FFF2-40B4-BE49-F238E27FC236}">
-                <a16:creationId xmlns:a16="http://schemas.microsoft.com/office/drawing/2014/main" id="{7BCD5AED-1D15-0251-E462-CEC86F7D248D}"/>
+                <a16:creationId xmlns:a16="http://schemas.microsoft.com/office/drawing/2014/main" id="{0BCE433B-8910-122F-64DC-D443332194E3}"/>
               </a:ext>
             </a:extLst>
           </p:cNvPr>
@@ -9293,7 +10953,7 @@
           <a:p>
             <a:r>
               <a:rPr lang="en-IN" b="1" dirty="0" err="1"/>
-              <a:t>addTableRow</a:t>
+              <a:t>removeTableColumn</a:t>
             </a:r>
             <a:endParaRPr lang="en-IN" b="1" dirty="0"/>
           </a:p>
@@ -9304,7 +10964,7 @@
           <p:cNvPr id="4" name="UpdateTable">
             <a:extLst>
               <a:ext uri="{FF2B5EF4-FFF2-40B4-BE49-F238E27FC236}">
-                <a16:creationId xmlns:a16="http://schemas.microsoft.com/office/drawing/2014/main" id="{BF6AEF37-B3F6-EA3B-BECB-FA48FBCEBFD1}"/>
+                <a16:creationId xmlns:a16="http://schemas.microsoft.com/office/drawing/2014/main" id="{4B306EB2-98AE-5DA2-F421-3410E63ECE42}"/>
               </a:ext>
             </a:extLst>
           </p:cNvPr>
@@ -9314,7 +10974,7 @@
           <p:nvPr>
             <p:extLst>
               <p:ext uri="{D42A27DB-BD31-4B8C-83A1-F6EECF244321}">
-                <p14:modId xmlns:p14="http://schemas.microsoft.com/office/powerpoint/2010/main" val="4085423743"/>
+                <p14:modId xmlns:p14="http://schemas.microsoft.com/office/powerpoint/2010/main" val="4085178651"/>
               </p:ext>
             </p:extLst>
           </p:nvPr>
@@ -9422,6 +11082,10 @@
                     <a:bodyPr/>
                     <a:lstStyle/>
                     <a:p>
+                      <a:r>
+                        <a:rPr lang="en-IN" dirty="0"/>
+                        <a:t>Status</a:t>
+                      </a:r>
                       <a:endParaRPr dirty="0"/>
                     </a:p>
                   </a:txBody>
@@ -9591,1098 +11255,98 @@
           </a:graphicData>
         </a:graphic>
       </p:graphicFrame>
-    </p:spTree>
-    <p:extLst>
-      <p:ext uri="{BB962C8B-B14F-4D97-AF65-F5344CB8AC3E}">
-        <p14:creationId xmlns:p14="http://schemas.microsoft.com/office/powerpoint/2010/main" val="3736847163"/>
-      </p:ext>
-    </p:extLst>
-  </p:cSld>
-  <p:clrMapOvr>
-    <a:masterClrMapping/>
-  </p:clrMapOvr>
-</p:sld>
-</file>
-
-<file path=ppt/slides/slide7.xml><?xml version="1.0" encoding="utf-8"?>
-<p:sld xmlns:a="http://schemas.openxmlformats.org/drawingml/2006/main" xmlns:r="http://schemas.openxmlformats.org/officeDocument/2006/relationships" xmlns:p="http://schemas.openxmlformats.org/presentationml/2006/main">
-  <p:cSld>
-    <p:spTree>
-      <p:nvGrpSpPr>
-        <p:cNvPr id="1" name="">
-          <a:extLst>
-            <a:ext uri="{FF2B5EF4-FFF2-40B4-BE49-F238E27FC236}">
-              <a16:creationId xmlns:a16="http://schemas.microsoft.com/office/drawing/2014/main" id="{21246C05-2DCA-B98A-7BD0-3D4E73013299}"/>
-            </a:ext>
-          </a:extLst>
-        </p:cNvPr>
-        <p:cNvGrpSpPr/>
-        <p:nvPr/>
-      </p:nvGrpSpPr>
-      <p:grpSpPr>
-        <a:xfrm>
-          <a:off x="0" y="0"/>
-          <a:ext cx="0" cy="0"/>
-          <a:chOff x="0" y="0"/>
-          <a:chExt cx="0" cy="0"/>
-        </a:xfrm>
-      </p:grpSpPr>
       <p:sp>
         <p:nvSpPr>
-          <p:cNvPr id="3" name="Subtitle 2">
-            <a:extLst>
-              <a:ext uri="{FF2B5EF4-FFF2-40B4-BE49-F238E27FC236}">
-                <a16:creationId xmlns:a16="http://schemas.microsoft.com/office/drawing/2014/main" id="{7DF20BAB-1E33-AEE8-6075-FA1E371C6990}"/>
-              </a:ext>
-            </a:extLst>
-          </p:cNvPr>
-          <p:cNvSpPr>
-            <a:spLocks noGrp="1"/>
-          </p:cNvSpPr>
-          <p:nvPr>
-            <p:ph type="subTitle" idx="1"/>
-          </p:nvPr>
+          <p:cNvPr id="5" name="Rectangle 4">
+            <a:extLst>
+              <a:ext uri="{FF2B5EF4-FFF2-40B4-BE49-F238E27FC236}">
+                <a16:creationId xmlns:a16="http://schemas.microsoft.com/office/drawing/2014/main" id="{92D22F7E-ECA1-E961-33FD-83BC9E929AF7}"/>
+              </a:ext>
+            </a:extLst>
+          </p:cNvPr>
+          <p:cNvSpPr/>
+          <p:nvPr/>
         </p:nvSpPr>
         <p:spPr>
           <a:xfrm>
-            <a:off x="1524000" y="340092"/>
-            <a:ext cx="9144000" cy="380877"/>
+            <a:off x="9328639" y="1461574"/>
+            <a:ext cx="342900" cy="237392"/>
           </a:xfrm>
+          <a:prstGeom prst="rect">
+            <a:avLst/>
+          </a:prstGeom>
         </p:spPr>
+        <p:style>
+          <a:lnRef idx="2">
+            <a:schemeClr val="accent1">
+              <a:shade val="15000"/>
+            </a:schemeClr>
+          </a:lnRef>
+          <a:fillRef idx="1">
+            <a:schemeClr val="accent1"/>
+          </a:fillRef>
+          <a:effectRef idx="0">
+            <a:schemeClr val="accent1"/>
+          </a:effectRef>
+          <a:fontRef idx="minor">
+            <a:schemeClr val="lt1"/>
+          </a:fontRef>
+        </p:style>
         <p:txBody>
-          <a:bodyPr>
-            <a:normAutofit fontScale="92500" lnSpcReduction="10000"/>
-          </a:bodyPr>
+          <a:bodyPr rtlCol="0" anchor="ctr"/>
           <a:lstStyle/>
           <a:p>
-            <a:r>
-              <a:rPr lang="en-IN" b="1" dirty="0" err="1"/>
-              <a:t>addTableColumn</a:t>
-            </a:r>
-            <a:endParaRPr lang="en-IN" b="1" dirty="0"/>
+            <a:pPr algn="ctr"/>
+            <a:endParaRPr lang="en-IN"/>
           </a:p>
         </p:txBody>
       </p:sp>
-      <p:graphicFrame>
-        <p:nvGraphicFramePr>
-          <p:cNvPr id="4" name="UpdateTable">
-            <a:extLst>
-              <a:ext uri="{FF2B5EF4-FFF2-40B4-BE49-F238E27FC236}">
-                <a16:creationId xmlns:a16="http://schemas.microsoft.com/office/drawing/2014/main" id="{1E75463E-D89B-73EB-C580-774CFE13FDF3}"/>
-              </a:ext>
-            </a:extLst>
-          </p:cNvPr>
-          <p:cNvGraphicFramePr>
-            <a:graphicFrameLocks/>
-          </p:cNvGraphicFramePr>
-          <p:nvPr>
-            <p:extLst>
-              <p:ext uri="{D42A27DB-BD31-4B8C-83A1-F6EECF244321}">
-                <p14:modId xmlns:p14="http://schemas.microsoft.com/office/powerpoint/2010/main" val="4085423743"/>
-              </p:ext>
-            </p:extLst>
-          </p:nvPr>
-        </p:nvGraphicFramePr>
-        <p:xfrm>
-          <a:off x="838200" y="1024010"/>
-          <a:ext cx="10515600" cy="1112520"/>
-        </p:xfrm>
-        <a:graphic>
-          <a:graphicData uri="http://schemas.openxmlformats.org/drawingml/2006/table">
-            <a:tbl>
-              <a:tblPr firstRow="1" bandRow="1">
-                <a:tableStyleId>{5C22544A-7EE6-4342-B048-85BDC9FD1C3A}</a:tableStyleId>
-              </a:tblPr>
-              <a:tblGrid>
-                <a:gridCol w="2103120">
-                  <a:extLst>
-                    <a:ext uri="{9D8B030D-6E8A-4147-A177-3AD203B41FA5}">
-                      <a16:colId xmlns:a16="http://schemas.microsoft.com/office/drawing/2014/main" val="1526623959"/>
-                    </a:ext>
-                  </a:extLst>
-                </a:gridCol>
-                <a:gridCol w="2103120">
-                  <a:extLst>
-                    <a:ext uri="{9D8B030D-6E8A-4147-A177-3AD203B41FA5}">
-                      <a16:colId xmlns:a16="http://schemas.microsoft.com/office/drawing/2014/main" val="1036110465"/>
-                    </a:ext>
-                  </a:extLst>
-                </a:gridCol>
-                <a:gridCol w="2103120">
-                  <a:extLst>
-                    <a:ext uri="{9D8B030D-6E8A-4147-A177-3AD203B41FA5}">
-                      <a16:colId xmlns:a16="http://schemas.microsoft.com/office/drawing/2014/main" val="1994860425"/>
-                    </a:ext>
-                  </a:extLst>
-                </a:gridCol>
-                <a:gridCol w="2103120">
-                  <a:extLst>
-                    <a:ext uri="{9D8B030D-6E8A-4147-A177-3AD203B41FA5}">
-                      <a16:colId xmlns:a16="http://schemas.microsoft.com/office/drawing/2014/main" val="3533840823"/>
-                    </a:ext>
-                  </a:extLst>
-                </a:gridCol>
-                <a:gridCol w="2103120">
-                  <a:extLst>
-                    <a:ext uri="{9D8B030D-6E8A-4147-A177-3AD203B41FA5}">
-                      <a16:colId xmlns:a16="http://schemas.microsoft.com/office/drawing/2014/main" val="1604916882"/>
-                    </a:ext>
-                  </a:extLst>
-                </a:gridCol>
-              </a:tblGrid>
-              <a:tr h="370840">
-                <a:tc gridSpan="2">
-                  <a:txBody>
-                    <a:bodyPr/>
-                    <a:lstStyle/>
-                    <a:p>
-                      <a:pPr algn="ctr"/>
-                      <a:r>
-                        <a:rPr lang="en-IN" dirty="0"/>
-                        <a:t>Department</a:t>
-                      </a:r>
-                    </a:p>
-                  </a:txBody>
-                  <a:tcPr/>
-                </a:tc>
-                <a:tc hMerge="1">
-                  <a:txBody>
-                    <a:bodyPr/>
-                    <a:lstStyle/>
-                    <a:p>
-                      <a:endParaRPr lang="en-IN"/>
-                    </a:p>
-                  </a:txBody>
-                  <a:tcPr/>
-                </a:tc>
-                <a:tc>
-                  <a:txBody>
-                    <a:bodyPr/>
-                    <a:lstStyle/>
-                    <a:p>
-                      <a:r>
-                        <a:rPr dirty="0"/>
-                        <a:t>Q1 Target</a:t>
-                      </a:r>
-                    </a:p>
-                  </a:txBody>
-                  <a:tcPr/>
-                </a:tc>
-                <a:tc>
-                  <a:txBody>
-                    <a:bodyPr/>
-                    <a:lstStyle/>
-                    <a:p>
-                      <a:r>
-                        <a:rPr dirty="0"/>
-                        <a:t>Q1 Actual</a:t>
-                      </a:r>
-                    </a:p>
-                  </a:txBody>
-                  <a:tcPr/>
-                </a:tc>
-                <a:tc>
-                  <a:txBody>
-                    <a:bodyPr/>
-                    <a:lstStyle/>
-                    <a:p>
-                      <a:endParaRPr dirty="0"/>
-                    </a:p>
-                  </a:txBody>
-                  <a:tcPr/>
-                </a:tc>
-                <a:extLst>
-                  <a:ext uri="{0D108BD9-81ED-4DB2-BD59-A6C34878D82A}">
-                    <a16:rowId xmlns:a16="http://schemas.microsoft.com/office/drawing/2014/main" val="1869212938"/>
-                  </a:ext>
-                </a:extLst>
-              </a:tr>
-              <a:tr h="370840">
-                <a:tc gridSpan="2">
-                  <a:txBody>
-                    <a:bodyPr/>
-                    <a:lstStyle/>
-                    <a:p>
-                      <a:pPr marL="0" marR="0" lvl="0" indent="0" algn="ctr" defTabSz="914400" rtl="0" eaLnBrk="1" fontAlgn="auto" latinLnBrk="0" hangingPunct="1">
-                        <a:lnSpc>
-                          <a:spcPct val="100000"/>
-                        </a:lnSpc>
-                        <a:spcBef>
-                          <a:spcPts val="0"/>
-                        </a:spcBef>
-                        <a:spcAft>
-                          <a:spcPts val="0"/>
-                        </a:spcAft>
-                        <a:buClrTx/>
-                        <a:buSzTx/>
-                        <a:buFontTx/>
-                        <a:buNone/>
-                        <a:tabLst/>
-                        <a:defRPr/>
-                      </a:pPr>
-                      <a:r>
-                        <a:rPr lang="en-IN" dirty="0"/>
-                        <a:t>Global Marketing</a:t>
-                      </a:r>
-                    </a:p>
-                  </a:txBody>
-                  <a:tcPr/>
-                </a:tc>
-                <a:tc hMerge="1">
-                  <a:txBody>
-                    <a:bodyPr/>
-                    <a:lstStyle/>
-                    <a:p>
-                      <a:endParaRPr lang="en-IN"/>
-                    </a:p>
-                  </a:txBody>
-                  <a:tcPr/>
-                </a:tc>
-                <a:tc>
-                  <a:txBody>
-                    <a:bodyPr/>
-                    <a:lstStyle/>
-                    <a:p>
-                      <a:r>
-                        <a:rPr dirty="0"/>
-                        <a:t>$500,000</a:t>
-                      </a:r>
-                    </a:p>
-                  </a:txBody>
-                  <a:tcPr/>
-                </a:tc>
-                <a:tc>
-                  <a:txBody>
-                    <a:bodyPr/>
-                    <a:lstStyle/>
-                    <a:p>
-                      <a:r>
-                        <a:rPr dirty="0"/>
-                        <a:t>$520,000</a:t>
-                      </a:r>
-                    </a:p>
-                  </a:txBody>
-                  <a:tcPr/>
-                </a:tc>
-                <a:tc>
-                  <a:txBody>
-                    <a:bodyPr/>
-                    <a:lstStyle/>
-                    <a:p>
-                      <a:endParaRPr dirty="0"/>
-                    </a:p>
-                  </a:txBody>
-                  <a:tcPr/>
-                </a:tc>
-                <a:extLst>
-                  <a:ext uri="{0D108BD9-81ED-4DB2-BD59-A6C34878D82A}">
-                    <a16:rowId xmlns:a16="http://schemas.microsoft.com/office/drawing/2014/main" val="2673184772"/>
-                  </a:ext>
-                </a:extLst>
-              </a:tr>
-              <a:tr h="370840">
-                <a:tc>
-                  <a:txBody>
-                    <a:bodyPr/>
-                    <a:lstStyle/>
-                    <a:p>
-                      <a:pPr algn="ctr"/>
-                      <a:r>
-                        <a:rPr lang="en-IN" dirty="0"/>
-                        <a:t>Engineering</a:t>
-                      </a:r>
-                    </a:p>
-                  </a:txBody>
-                  <a:tcPr/>
-                </a:tc>
-                <a:tc>
-                  <a:txBody>
-                    <a:bodyPr/>
-                    <a:lstStyle/>
-                    <a:p>
-                      <a:pPr algn="ctr"/>
-                      <a:r>
-                        <a:rPr lang="en-IN" dirty="0"/>
-                        <a:t>Product</a:t>
-                      </a:r>
-                    </a:p>
-                  </a:txBody>
-                  <a:tcPr/>
-                </a:tc>
-                <a:tc>
-                  <a:txBody>
-                    <a:bodyPr/>
-                    <a:lstStyle/>
-                    <a:p>
-                      <a:r>
-                        <a:rPr dirty="0"/>
-                        <a:t>$250,000</a:t>
-                      </a:r>
-                    </a:p>
-                  </a:txBody>
-                  <a:tcPr/>
-                </a:tc>
-                <a:tc>
-                  <a:txBody>
-                    <a:bodyPr/>
-                    <a:lstStyle/>
-                    <a:p>
-                      <a:r>
-                        <a:rPr dirty="0"/>
-                        <a:t>$245,000</a:t>
-                      </a:r>
-                    </a:p>
-                  </a:txBody>
-                  <a:tcPr/>
-                </a:tc>
-                <a:tc>
-                  <a:txBody>
-                    <a:bodyPr/>
-                    <a:lstStyle/>
-                    <a:p>
-                      <a:endParaRPr dirty="0"/>
-                    </a:p>
-                  </a:txBody>
-                  <a:tcPr/>
-                </a:tc>
-                <a:extLst>
-                  <a:ext uri="{0D108BD9-81ED-4DB2-BD59-A6C34878D82A}">
-                    <a16:rowId xmlns:a16="http://schemas.microsoft.com/office/drawing/2014/main" val="2462398921"/>
-                  </a:ext>
-                </a:extLst>
-              </a:tr>
-            </a:tbl>
-          </a:graphicData>
-        </a:graphic>
-      </p:graphicFrame>
-    </p:spTree>
-    <p:extLst>
-      <p:ext uri="{BB962C8B-B14F-4D97-AF65-F5344CB8AC3E}">
-        <p14:creationId xmlns:p14="http://schemas.microsoft.com/office/powerpoint/2010/main" val="3556156674"/>
-      </p:ext>
-    </p:extLst>
-  </p:cSld>
-  <p:clrMapOvr>
-    <a:masterClrMapping/>
-  </p:clrMapOvr>
-</p:sld>
-</file>
-
-<file path=ppt/slides/slide8.xml><?xml version="1.0" encoding="utf-8"?>
-<p:sld xmlns:a="http://schemas.openxmlformats.org/drawingml/2006/main" xmlns:r="http://schemas.openxmlformats.org/officeDocument/2006/relationships" xmlns:p="http://schemas.openxmlformats.org/presentationml/2006/main">
-  <p:cSld>
-    <p:spTree>
-      <p:nvGrpSpPr>
-        <p:cNvPr id="1" name="">
-          <a:extLst>
-            <a:ext uri="{FF2B5EF4-FFF2-40B4-BE49-F238E27FC236}">
-              <a16:creationId xmlns:a16="http://schemas.microsoft.com/office/drawing/2014/main" id="{52EFA33D-1F6F-6665-5D7C-75D0D2519AD8}"/>
-            </a:ext>
-          </a:extLst>
-        </p:cNvPr>
-        <p:cNvGrpSpPr/>
-        <p:nvPr/>
-      </p:nvGrpSpPr>
-      <p:grpSpPr>
-        <a:xfrm>
-          <a:off x="0" y="0"/>
-          <a:ext cx="0" cy="0"/>
-          <a:chOff x="0" y="0"/>
-          <a:chExt cx="0" cy="0"/>
-        </a:xfrm>
-      </p:grpSpPr>
       <p:sp>
         <p:nvSpPr>
-          <p:cNvPr id="3" name="Subtitle 2">
-            <a:extLst>
-              <a:ext uri="{FF2B5EF4-FFF2-40B4-BE49-F238E27FC236}">
-                <a16:creationId xmlns:a16="http://schemas.microsoft.com/office/drawing/2014/main" id="{96DC7814-3B30-E8B6-9643-28A9572BDA1A}"/>
-              </a:ext>
-            </a:extLst>
-          </p:cNvPr>
-          <p:cNvSpPr>
-            <a:spLocks noGrp="1"/>
-          </p:cNvSpPr>
-          <p:nvPr>
-            <p:ph type="subTitle" idx="1"/>
-          </p:nvPr>
+          <p:cNvPr id="7" name="Oval 6">
+            <a:extLst>
+              <a:ext uri="{FF2B5EF4-FFF2-40B4-BE49-F238E27FC236}">
+                <a16:creationId xmlns:a16="http://schemas.microsoft.com/office/drawing/2014/main" id="{ADB49E2A-004B-1C95-42F2-D76A9B4825EE}"/>
+              </a:ext>
+            </a:extLst>
+          </p:cNvPr>
+          <p:cNvSpPr/>
+          <p:nvPr/>
         </p:nvSpPr>
         <p:spPr>
           <a:xfrm>
-            <a:off x="1524000" y="340092"/>
-            <a:ext cx="9144000" cy="380877"/>
+            <a:off x="10155115" y="1811215"/>
+            <a:ext cx="254977" cy="254977"/>
           </a:xfrm>
+          <a:prstGeom prst="ellipse">
+            <a:avLst/>
+          </a:prstGeom>
         </p:spPr>
+        <p:style>
+          <a:lnRef idx="2">
+            <a:schemeClr val="accent6">
+              <a:shade val="15000"/>
+            </a:schemeClr>
+          </a:lnRef>
+          <a:fillRef idx="1">
+            <a:schemeClr val="accent6"/>
+          </a:fillRef>
+          <a:effectRef idx="0">
+            <a:schemeClr val="accent6"/>
+          </a:effectRef>
+          <a:fontRef idx="minor">
+            <a:schemeClr val="lt1"/>
+          </a:fontRef>
+        </p:style>
         <p:txBody>
-          <a:bodyPr>
-            <a:normAutofit fontScale="92500" lnSpcReduction="10000"/>
-          </a:bodyPr>
+          <a:bodyPr rtlCol="0" anchor="ctr"/>
           <a:lstStyle/>
           <a:p>
-            <a:r>
-              <a:rPr lang="en-IN" b="1" dirty="0" err="1"/>
-              <a:t>removeTableRow</a:t>
-            </a:r>
-            <a:endParaRPr lang="en-IN" b="1" dirty="0"/>
+            <a:pPr algn="ctr"/>
+            <a:endParaRPr lang="en-IN"/>
           </a:p>
         </p:txBody>
       </p:sp>
-      <p:graphicFrame>
-        <p:nvGraphicFramePr>
-          <p:cNvPr id="4" name="UpdateTable">
-            <a:extLst>
-              <a:ext uri="{FF2B5EF4-FFF2-40B4-BE49-F238E27FC236}">
-                <a16:creationId xmlns:a16="http://schemas.microsoft.com/office/drawing/2014/main" id="{46C80F9D-7082-4835-6197-A64FF1B6D4BD}"/>
-              </a:ext>
-            </a:extLst>
-          </p:cNvPr>
-          <p:cNvGraphicFramePr>
-            <a:graphicFrameLocks/>
-          </p:cNvGraphicFramePr>
-          <p:nvPr>
-            <p:extLst>
-              <p:ext uri="{D42A27DB-BD31-4B8C-83A1-F6EECF244321}">
-                <p14:modId xmlns:p14="http://schemas.microsoft.com/office/powerpoint/2010/main" val="4085423743"/>
-              </p:ext>
-            </p:extLst>
-          </p:nvPr>
-        </p:nvGraphicFramePr>
-        <p:xfrm>
-          <a:off x="838200" y="1024010"/>
-          <a:ext cx="10515600" cy="1112520"/>
-        </p:xfrm>
-        <a:graphic>
-          <a:graphicData uri="http://schemas.openxmlformats.org/drawingml/2006/table">
-            <a:tbl>
-              <a:tblPr firstRow="1" bandRow="1">
-                <a:tableStyleId>{5C22544A-7EE6-4342-B048-85BDC9FD1C3A}</a:tableStyleId>
-              </a:tblPr>
-              <a:tblGrid>
-                <a:gridCol w="2103120">
-                  <a:extLst>
-                    <a:ext uri="{9D8B030D-6E8A-4147-A177-3AD203B41FA5}">
-                      <a16:colId xmlns:a16="http://schemas.microsoft.com/office/drawing/2014/main" val="1526623959"/>
-                    </a:ext>
-                  </a:extLst>
-                </a:gridCol>
-                <a:gridCol w="2103120">
-                  <a:extLst>
-                    <a:ext uri="{9D8B030D-6E8A-4147-A177-3AD203B41FA5}">
-                      <a16:colId xmlns:a16="http://schemas.microsoft.com/office/drawing/2014/main" val="1036110465"/>
-                    </a:ext>
-                  </a:extLst>
-                </a:gridCol>
-                <a:gridCol w="2103120">
-                  <a:extLst>
-                    <a:ext uri="{9D8B030D-6E8A-4147-A177-3AD203B41FA5}">
-                      <a16:colId xmlns:a16="http://schemas.microsoft.com/office/drawing/2014/main" val="1994860425"/>
-                    </a:ext>
-                  </a:extLst>
-                </a:gridCol>
-                <a:gridCol w="2103120">
-                  <a:extLst>
-                    <a:ext uri="{9D8B030D-6E8A-4147-A177-3AD203B41FA5}">
-                      <a16:colId xmlns:a16="http://schemas.microsoft.com/office/drawing/2014/main" val="3533840823"/>
-                    </a:ext>
-                  </a:extLst>
-                </a:gridCol>
-                <a:gridCol w="2103120">
-                  <a:extLst>
-                    <a:ext uri="{9D8B030D-6E8A-4147-A177-3AD203B41FA5}">
-                      <a16:colId xmlns:a16="http://schemas.microsoft.com/office/drawing/2014/main" val="1604916882"/>
-                    </a:ext>
-                  </a:extLst>
-                </a:gridCol>
-              </a:tblGrid>
-              <a:tr h="370840">
-                <a:tc gridSpan="2">
-                  <a:txBody>
-                    <a:bodyPr/>
-                    <a:lstStyle/>
-                    <a:p>
-                      <a:pPr algn="ctr"/>
-                      <a:r>
-                        <a:rPr lang="en-IN" dirty="0"/>
-                        <a:t>Department</a:t>
-                      </a:r>
-                    </a:p>
-                  </a:txBody>
-                  <a:tcPr/>
-                </a:tc>
-                <a:tc hMerge="1">
-                  <a:txBody>
-                    <a:bodyPr/>
-                    <a:lstStyle/>
-                    <a:p>
-                      <a:endParaRPr lang="en-IN"/>
-                    </a:p>
-                  </a:txBody>
-                  <a:tcPr/>
-                </a:tc>
-                <a:tc>
-                  <a:txBody>
-                    <a:bodyPr/>
-                    <a:lstStyle/>
-                    <a:p>
-                      <a:r>
-                        <a:rPr dirty="0"/>
-                        <a:t>Q1 Target</a:t>
-                      </a:r>
-                    </a:p>
-                  </a:txBody>
-                  <a:tcPr/>
-                </a:tc>
-                <a:tc>
-                  <a:txBody>
-                    <a:bodyPr/>
-                    <a:lstStyle/>
-                    <a:p>
-                      <a:r>
-                        <a:rPr dirty="0"/>
-                        <a:t>Q1 Actual</a:t>
-                      </a:r>
-                    </a:p>
-                  </a:txBody>
-                  <a:tcPr/>
-                </a:tc>
-                <a:tc>
-                  <a:txBody>
-                    <a:bodyPr/>
-                    <a:lstStyle/>
-                    <a:p>
-                      <a:endParaRPr dirty="0"/>
-                    </a:p>
-                  </a:txBody>
-                  <a:tcPr/>
-                </a:tc>
-                <a:extLst>
-                  <a:ext uri="{0D108BD9-81ED-4DB2-BD59-A6C34878D82A}">
-                    <a16:rowId xmlns:a16="http://schemas.microsoft.com/office/drawing/2014/main" val="1869212938"/>
-                  </a:ext>
-                </a:extLst>
-              </a:tr>
-              <a:tr h="370840">
-                <a:tc gridSpan="2">
-                  <a:txBody>
-                    <a:bodyPr/>
-                    <a:lstStyle/>
-                    <a:p>
-                      <a:pPr marL="0" marR="0" lvl="0" indent="0" algn="ctr" defTabSz="914400" rtl="0" eaLnBrk="1" fontAlgn="auto" latinLnBrk="0" hangingPunct="1">
-                        <a:lnSpc>
-                          <a:spcPct val="100000"/>
-                        </a:lnSpc>
-                        <a:spcBef>
-                          <a:spcPts val="0"/>
-                        </a:spcBef>
-                        <a:spcAft>
-                          <a:spcPts val="0"/>
-                        </a:spcAft>
-                        <a:buClrTx/>
-                        <a:buSzTx/>
-                        <a:buFontTx/>
-                        <a:buNone/>
-                        <a:tabLst/>
-                        <a:defRPr/>
-                      </a:pPr>
-                      <a:r>
-                        <a:rPr lang="en-IN" dirty="0"/>
-                        <a:t>Global Marketing</a:t>
-                      </a:r>
-                    </a:p>
-                  </a:txBody>
-                  <a:tcPr/>
-                </a:tc>
-                <a:tc hMerge="1">
-                  <a:txBody>
-                    <a:bodyPr/>
-                    <a:lstStyle/>
-                    <a:p>
-                      <a:endParaRPr lang="en-IN"/>
-                    </a:p>
-                  </a:txBody>
-                  <a:tcPr/>
-                </a:tc>
-                <a:tc>
-                  <a:txBody>
-                    <a:bodyPr/>
-                    <a:lstStyle/>
-                    <a:p>
-                      <a:r>
-                        <a:rPr dirty="0"/>
-                        <a:t>$500,000</a:t>
-                      </a:r>
-                    </a:p>
-                  </a:txBody>
-                  <a:tcPr/>
-                </a:tc>
-                <a:tc>
-                  <a:txBody>
-                    <a:bodyPr/>
-                    <a:lstStyle/>
-                    <a:p>
-                      <a:r>
-                        <a:rPr dirty="0"/>
-                        <a:t>$520,000</a:t>
-                      </a:r>
-                    </a:p>
-                  </a:txBody>
-                  <a:tcPr/>
-                </a:tc>
-                <a:tc>
-                  <a:txBody>
-                    <a:bodyPr/>
-                    <a:lstStyle/>
-                    <a:p>
-                      <a:endParaRPr dirty="0"/>
-                    </a:p>
-                  </a:txBody>
-                  <a:tcPr/>
-                </a:tc>
-                <a:extLst>
-                  <a:ext uri="{0D108BD9-81ED-4DB2-BD59-A6C34878D82A}">
-                    <a16:rowId xmlns:a16="http://schemas.microsoft.com/office/drawing/2014/main" val="2673184772"/>
-                  </a:ext>
-                </a:extLst>
-              </a:tr>
-              <a:tr h="370840">
-                <a:tc>
-                  <a:txBody>
-                    <a:bodyPr/>
-                    <a:lstStyle/>
-                    <a:p>
-                      <a:pPr algn="ctr"/>
-                      <a:r>
-                        <a:rPr lang="en-IN" dirty="0"/>
-                        <a:t>Engineering</a:t>
-                      </a:r>
-                    </a:p>
-                  </a:txBody>
-                  <a:tcPr/>
-                </a:tc>
-                <a:tc>
-                  <a:txBody>
-                    <a:bodyPr/>
-                    <a:lstStyle/>
-                    <a:p>
-                      <a:pPr algn="ctr"/>
-                      <a:r>
-                        <a:rPr lang="en-IN" dirty="0"/>
-                        <a:t>Product</a:t>
-                      </a:r>
-                    </a:p>
-                  </a:txBody>
-                  <a:tcPr/>
-                </a:tc>
-                <a:tc>
-                  <a:txBody>
-                    <a:bodyPr/>
-                    <a:lstStyle/>
-                    <a:p>
-                      <a:r>
-                        <a:rPr dirty="0"/>
-                        <a:t>$250,000</a:t>
-                      </a:r>
-                    </a:p>
-                  </a:txBody>
-                  <a:tcPr/>
-                </a:tc>
-                <a:tc>
-                  <a:txBody>
-                    <a:bodyPr/>
-                    <a:lstStyle/>
-                    <a:p>
-                      <a:r>
-                        <a:rPr dirty="0"/>
-                        <a:t>$245,000</a:t>
-                      </a:r>
-                    </a:p>
-                  </a:txBody>
-                  <a:tcPr/>
-                </a:tc>
-                <a:tc>
-                  <a:txBody>
-                    <a:bodyPr/>
-                    <a:lstStyle/>
-                    <a:p>
-                      <a:endParaRPr dirty="0"/>
-                    </a:p>
-                  </a:txBody>
-                  <a:tcPr/>
-                </a:tc>
-                <a:extLst>
-                  <a:ext uri="{0D108BD9-81ED-4DB2-BD59-A6C34878D82A}">
-                    <a16:rowId xmlns:a16="http://schemas.microsoft.com/office/drawing/2014/main" val="2462398921"/>
-                  </a:ext>
-                </a:extLst>
-              </a:tr>
-            </a:tbl>
-          </a:graphicData>
-        </a:graphic>
-      </p:graphicFrame>
-    </p:spTree>
-    <p:extLst>
-      <p:ext uri="{BB962C8B-B14F-4D97-AF65-F5344CB8AC3E}">
-        <p14:creationId xmlns:p14="http://schemas.microsoft.com/office/powerpoint/2010/main" val="3890693090"/>
-      </p:ext>
-    </p:extLst>
-  </p:cSld>
-  <p:clrMapOvr>
-    <a:masterClrMapping/>
-  </p:clrMapOvr>
-</p:sld>
-</file>
-
-<file path=ppt/slides/slide9.xml><?xml version="1.0" encoding="utf-8"?>
-<p:sld xmlns:a="http://schemas.openxmlformats.org/drawingml/2006/main" xmlns:r="http://schemas.openxmlformats.org/officeDocument/2006/relationships" xmlns:p="http://schemas.openxmlformats.org/presentationml/2006/main">
-  <p:cSld>
-    <p:spTree>
-      <p:nvGrpSpPr>
-        <p:cNvPr id="1" name="">
-          <a:extLst>
-            <a:ext uri="{FF2B5EF4-FFF2-40B4-BE49-F238E27FC236}">
-              <a16:creationId xmlns:a16="http://schemas.microsoft.com/office/drawing/2014/main" id="{147117A5-34F4-3F38-36CA-AF5AED3E7EA6}"/>
-            </a:ext>
-          </a:extLst>
-        </p:cNvPr>
-        <p:cNvGrpSpPr/>
-        <p:nvPr/>
-      </p:nvGrpSpPr>
-      <p:grpSpPr>
-        <a:xfrm>
-          <a:off x="0" y="0"/>
-          <a:ext cx="0" cy="0"/>
-          <a:chOff x="0" y="0"/>
-          <a:chExt cx="0" cy="0"/>
-        </a:xfrm>
-      </p:grpSpPr>
-      <p:sp>
-        <p:nvSpPr>
-          <p:cNvPr id="3" name="Subtitle 2">
-            <a:extLst>
-              <a:ext uri="{FF2B5EF4-FFF2-40B4-BE49-F238E27FC236}">
-                <a16:creationId xmlns:a16="http://schemas.microsoft.com/office/drawing/2014/main" id="{0BCE433B-8910-122F-64DC-D443332194E3}"/>
-              </a:ext>
-            </a:extLst>
-          </p:cNvPr>
-          <p:cNvSpPr>
-            <a:spLocks noGrp="1"/>
-          </p:cNvSpPr>
-          <p:nvPr>
-            <p:ph type="subTitle" idx="1"/>
-          </p:nvPr>
-        </p:nvSpPr>
-        <p:spPr>
-          <a:xfrm>
-            <a:off x="1524000" y="340092"/>
-            <a:ext cx="9144000" cy="380877"/>
-          </a:xfrm>
-        </p:spPr>
-        <p:txBody>
-          <a:bodyPr>
-            <a:normAutofit fontScale="92500" lnSpcReduction="10000"/>
-          </a:bodyPr>
-          <a:lstStyle/>
-          <a:p>
-            <a:r>
-              <a:rPr lang="en-IN" b="1" dirty="0" err="1"/>
-              <a:t>removeTableColumn</a:t>
-            </a:r>
-            <a:endParaRPr lang="en-IN" b="1" dirty="0"/>
-          </a:p>
-        </p:txBody>
-      </p:sp>
-      <p:graphicFrame>
-        <p:nvGraphicFramePr>
-          <p:cNvPr id="4" name="UpdateTable">
-            <a:extLst>
-              <a:ext uri="{FF2B5EF4-FFF2-40B4-BE49-F238E27FC236}">
-                <a16:creationId xmlns:a16="http://schemas.microsoft.com/office/drawing/2014/main" id="{4B306EB2-98AE-5DA2-F421-3410E63ECE42}"/>
-              </a:ext>
-            </a:extLst>
-          </p:cNvPr>
-          <p:cNvGraphicFramePr>
-            <a:graphicFrameLocks/>
-          </p:cNvGraphicFramePr>
-          <p:nvPr>
-            <p:extLst>
-              <p:ext uri="{D42A27DB-BD31-4B8C-83A1-F6EECF244321}">
-                <p14:modId xmlns:p14="http://schemas.microsoft.com/office/powerpoint/2010/main" val="4085423743"/>
-              </p:ext>
-            </p:extLst>
-          </p:nvPr>
-        </p:nvGraphicFramePr>
-        <p:xfrm>
-          <a:off x="838200" y="1024010"/>
-          <a:ext cx="10515600" cy="1112520"/>
-        </p:xfrm>
-        <a:graphic>
-          <a:graphicData uri="http://schemas.openxmlformats.org/drawingml/2006/table">
-            <a:tbl>
-              <a:tblPr firstRow="1" bandRow="1">
-                <a:tableStyleId>{5C22544A-7EE6-4342-B048-85BDC9FD1C3A}</a:tableStyleId>
-              </a:tblPr>
-              <a:tblGrid>
-                <a:gridCol w="2103120">
-                  <a:extLst>
-                    <a:ext uri="{9D8B030D-6E8A-4147-A177-3AD203B41FA5}">
-                      <a16:colId xmlns:a16="http://schemas.microsoft.com/office/drawing/2014/main" val="1526623959"/>
-                    </a:ext>
-                  </a:extLst>
-                </a:gridCol>
-                <a:gridCol w="2103120">
-                  <a:extLst>
-                    <a:ext uri="{9D8B030D-6E8A-4147-A177-3AD203B41FA5}">
-                      <a16:colId xmlns:a16="http://schemas.microsoft.com/office/drawing/2014/main" val="1036110465"/>
-                    </a:ext>
-                  </a:extLst>
-                </a:gridCol>
-                <a:gridCol w="2103120">
-                  <a:extLst>
-                    <a:ext uri="{9D8B030D-6E8A-4147-A177-3AD203B41FA5}">
-                      <a16:colId xmlns:a16="http://schemas.microsoft.com/office/drawing/2014/main" val="1994860425"/>
-                    </a:ext>
-                  </a:extLst>
-                </a:gridCol>
-                <a:gridCol w="2103120">
-                  <a:extLst>
-                    <a:ext uri="{9D8B030D-6E8A-4147-A177-3AD203B41FA5}">
-                      <a16:colId xmlns:a16="http://schemas.microsoft.com/office/drawing/2014/main" val="3533840823"/>
-                    </a:ext>
-                  </a:extLst>
-                </a:gridCol>
-                <a:gridCol w="2103120">
-                  <a:extLst>
-                    <a:ext uri="{9D8B030D-6E8A-4147-A177-3AD203B41FA5}">
-                      <a16:colId xmlns:a16="http://schemas.microsoft.com/office/drawing/2014/main" val="1604916882"/>
-                    </a:ext>
-                  </a:extLst>
-                </a:gridCol>
-              </a:tblGrid>
-              <a:tr h="370840">
-                <a:tc gridSpan="2">
-                  <a:txBody>
-                    <a:bodyPr/>
-                    <a:lstStyle/>
-                    <a:p>
-                      <a:pPr algn="ctr"/>
-                      <a:r>
-                        <a:rPr lang="en-IN" dirty="0"/>
-                        <a:t>Department</a:t>
-                      </a:r>
-                    </a:p>
-                  </a:txBody>
-                  <a:tcPr/>
-                </a:tc>
-                <a:tc hMerge="1">
-                  <a:txBody>
-                    <a:bodyPr/>
-                    <a:lstStyle/>
-                    <a:p>
-                      <a:endParaRPr lang="en-IN"/>
-                    </a:p>
-                  </a:txBody>
-                  <a:tcPr/>
-                </a:tc>
-                <a:tc>
-                  <a:txBody>
-                    <a:bodyPr/>
-                    <a:lstStyle/>
-                    <a:p>
-                      <a:r>
-                        <a:rPr dirty="0"/>
-                        <a:t>Q1 Target</a:t>
-                      </a:r>
-                    </a:p>
-                  </a:txBody>
-                  <a:tcPr/>
-                </a:tc>
-                <a:tc>
-                  <a:txBody>
-                    <a:bodyPr/>
-                    <a:lstStyle/>
-                    <a:p>
-                      <a:r>
-                        <a:rPr dirty="0"/>
-                        <a:t>Q1 Actual</a:t>
-                      </a:r>
-                    </a:p>
-                  </a:txBody>
-                  <a:tcPr/>
-                </a:tc>
-                <a:tc>
-                  <a:txBody>
-                    <a:bodyPr/>
-                    <a:lstStyle/>
-                    <a:p>
-                      <a:endParaRPr dirty="0"/>
-                    </a:p>
-                  </a:txBody>
-                  <a:tcPr/>
-                </a:tc>
-                <a:extLst>
-                  <a:ext uri="{0D108BD9-81ED-4DB2-BD59-A6C34878D82A}">
-                    <a16:rowId xmlns:a16="http://schemas.microsoft.com/office/drawing/2014/main" val="1869212938"/>
-                  </a:ext>
-                </a:extLst>
-              </a:tr>
-              <a:tr h="370840">
-                <a:tc gridSpan="2">
-                  <a:txBody>
-                    <a:bodyPr/>
-                    <a:lstStyle/>
-                    <a:p>
-                      <a:pPr marL="0" marR="0" lvl="0" indent="0" algn="ctr" defTabSz="914400" rtl="0" eaLnBrk="1" fontAlgn="auto" latinLnBrk="0" hangingPunct="1">
-                        <a:lnSpc>
-                          <a:spcPct val="100000"/>
-                        </a:lnSpc>
-                        <a:spcBef>
-                          <a:spcPts val="0"/>
-                        </a:spcBef>
-                        <a:spcAft>
-                          <a:spcPts val="0"/>
-                        </a:spcAft>
-                        <a:buClrTx/>
-                        <a:buSzTx/>
-                        <a:buFontTx/>
-                        <a:buNone/>
-                        <a:tabLst/>
-                        <a:defRPr/>
-                      </a:pPr>
-                      <a:r>
-                        <a:rPr lang="en-IN" dirty="0"/>
-                        <a:t>Global Marketing</a:t>
-                      </a:r>
-                    </a:p>
-                  </a:txBody>
-                  <a:tcPr/>
-                </a:tc>
-                <a:tc hMerge="1">
-                  <a:txBody>
-                    <a:bodyPr/>
-                    <a:lstStyle/>
-                    <a:p>
-                      <a:endParaRPr lang="en-IN"/>
-                    </a:p>
-                  </a:txBody>
-                  <a:tcPr/>
-                </a:tc>
-                <a:tc>
-                  <a:txBody>
-                    <a:bodyPr/>
-                    <a:lstStyle/>
-                    <a:p>
-                      <a:r>
-                        <a:rPr dirty="0"/>
-                        <a:t>$500,000</a:t>
-                      </a:r>
-                    </a:p>
-                  </a:txBody>
-                  <a:tcPr/>
-                </a:tc>
-                <a:tc>
-                  <a:txBody>
-                    <a:bodyPr/>
-                    <a:lstStyle/>
-                    <a:p>
-                      <a:r>
-                        <a:rPr dirty="0"/>
-                        <a:t>$520,000</a:t>
-                      </a:r>
-                    </a:p>
-                  </a:txBody>
-                  <a:tcPr/>
-                </a:tc>
-                <a:tc>
-                  <a:txBody>
-                    <a:bodyPr/>
-                    <a:lstStyle/>
-                    <a:p>
-                      <a:endParaRPr dirty="0"/>
-                    </a:p>
-                  </a:txBody>
-                  <a:tcPr/>
-                </a:tc>
-                <a:extLst>
-                  <a:ext uri="{0D108BD9-81ED-4DB2-BD59-A6C34878D82A}">
-                    <a16:rowId xmlns:a16="http://schemas.microsoft.com/office/drawing/2014/main" val="2673184772"/>
-                  </a:ext>
-                </a:extLst>
-              </a:tr>
-              <a:tr h="370840">
-                <a:tc>
-                  <a:txBody>
-                    <a:bodyPr/>
-                    <a:lstStyle/>
-                    <a:p>
-                      <a:pPr algn="ctr"/>
-                      <a:r>
-                        <a:rPr lang="en-IN" dirty="0"/>
-                        <a:t>Engineering</a:t>
-                      </a:r>
-                    </a:p>
-                  </a:txBody>
-                  <a:tcPr/>
-                </a:tc>
-                <a:tc>
-                  <a:txBody>
-                    <a:bodyPr/>
-                    <a:lstStyle/>
-                    <a:p>
-                      <a:pPr algn="ctr"/>
-                      <a:r>
-                        <a:rPr lang="en-IN" dirty="0"/>
-                        <a:t>Product</a:t>
-                      </a:r>
-                    </a:p>
-                  </a:txBody>
-                  <a:tcPr/>
-                </a:tc>
-                <a:tc>
-                  <a:txBody>
-                    <a:bodyPr/>
-                    <a:lstStyle/>
-                    <a:p>
-                      <a:r>
-                        <a:rPr dirty="0"/>
-                        <a:t>$250,000</a:t>
-                      </a:r>
-                    </a:p>
-                  </a:txBody>
-                  <a:tcPr/>
-                </a:tc>
-                <a:tc>
-                  <a:txBody>
-                    <a:bodyPr/>
-                    <a:lstStyle/>
-                    <a:p>
-                      <a:r>
-                        <a:rPr dirty="0"/>
-                        <a:t>$245,000</a:t>
-                      </a:r>
-                    </a:p>
-                  </a:txBody>
-                  <a:tcPr/>
-                </a:tc>
-                <a:tc>
-                  <a:txBody>
-                    <a:bodyPr/>
-                    <a:lstStyle/>
-                    <a:p>
-                      <a:endParaRPr dirty="0"/>
-                    </a:p>
-                  </a:txBody>
-                  <a:tcPr/>
-                </a:tc>
-                <a:extLst>
-                  <a:ext uri="{0D108BD9-81ED-4DB2-BD59-A6C34878D82A}">
-                    <a16:rowId xmlns:a16="http://schemas.microsoft.com/office/drawing/2014/main" val="2462398921"/>
-                  </a:ext>
-                </a:extLst>
-              </a:tr>
-            </a:tbl>
-          </a:graphicData>
-        </a:graphic>
-      </p:graphicFrame>
     </p:spTree>
     <p:extLst>
       <p:ext uri="{BB962C8B-B14F-4D97-AF65-F5344CB8AC3E}">

</xml_diff>

<commit_message>
feat: add advanced table showcase and arrow shape removal support for table operations
</commit_message>
<xml_diff>
--- a/showcase/templates/TablePowerPointSample.pptx
+++ b/showcase/templates/TablePowerPointSample.pptx
@@ -281,7 +281,7 @@
           <a:p>
             <a:fld id="{93C22856-B332-42D6-94F6-347491DB4324}" type="datetimeFigureOut">
               <a:rPr lang="en-IN" smtClean="0"/>
-              <a:t>25-10-2026</a:t>
+              <a:t>26-10-2026</a:t>
             </a:fld>
             <a:endParaRPr lang="en-IN"/>
           </a:p>
@@ -481,7 +481,7 @@
           <a:p>
             <a:fld id="{93C22856-B332-42D6-94F6-347491DB4324}" type="datetimeFigureOut">
               <a:rPr lang="en-IN" smtClean="0"/>
-              <a:t>25-10-2026</a:t>
+              <a:t>26-10-2026</a:t>
             </a:fld>
             <a:endParaRPr lang="en-IN"/>
           </a:p>
@@ -691,7 +691,7 @@
           <a:p>
             <a:fld id="{93C22856-B332-42D6-94F6-347491DB4324}" type="datetimeFigureOut">
               <a:rPr lang="en-IN" smtClean="0"/>
-              <a:t>25-10-2026</a:t>
+              <a:t>26-10-2026</a:t>
             </a:fld>
             <a:endParaRPr lang="en-IN"/>
           </a:p>
@@ -891,7 +891,7 @@
           <a:p>
             <a:fld id="{93C22856-B332-42D6-94F6-347491DB4324}" type="datetimeFigureOut">
               <a:rPr lang="en-IN" smtClean="0"/>
-              <a:t>25-10-2026</a:t>
+              <a:t>26-10-2026</a:t>
             </a:fld>
             <a:endParaRPr lang="en-IN"/>
           </a:p>
@@ -1167,7 +1167,7 @@
           <a:p>
             <a:fld id="{93C22856-B332-42D6-94F6-347491DB4324}" type="datetimeFigureOut">
               <a:rPr lang="en-IN" smtClean="0"/>
-              <a:t>25-10-2026</a:t>
+              <a:t>26-10-2026</a:t>
             </a:fld>
             <a:endParaRPr lang="en-IN"/>
           </a:p>
@@ -1435,7 +1435,7 @@
           <a:p>
             <a:fld id="{93C22856-B332-42D6-94F6-347491DB4324}" type="datetimeFigureOut">
               <a:rPr lang="en-IN" smtClean="0"/>
-              <a:t>25-10-2026</a:t>
+              <a:t>26-10-2026</a:t>
             </a:fld>
             <a:endParaRPr lang="en-IN"/>
           </a:p>
@@ -1850,7 +1850,7 @@
           <a:p>
             <a:fld id="{93C22856-B332-42D6-94F6-347491DB4324}" type="datetimeFigureOut">
               <a:rPr lang="en-IN" smtClean="0"/>
-              <a:t>25-10-2026</a:t>
+              <a:t>26-10-2026</a:t>
             </a:fld>
             <a:endParaRPr lang="en-IN"/>
           </a:p>
@@ -1992,7 +1992,7 @@
           <a:p>
             <a:fld id="{93C22856-B332-42D6-94F6-347491DB4324}" type="datetimeFigureOut">
               <a:rPr lang="en-IN" smtClean="0"/>
-              <a:t>25-10-2026</a:t>
+              <a:t>26-10-2026</a:t>
             </a:fld>
             <a:endParaRPr lang="en-IN"/>
           </a:p>
@@ -2105,7 +2105,7 @@
           <a:p>
             <a:fld id="{93C22856-B332-42D6-94F6-347491DB4324}" type="datetimeFigureOut">
               <a:rPr lang="en-IN" smtClean="0"/>
-              <a:t>25-10-2026</a:t>
+              <a:t>26-10-2026</a:t>
             </a:fld>
             <a:endParaRPr lang="en-IN"/>
           </a:p>
@@ -2418,7 +2418,7 @@
           <a:p>
             <a:fld id="{93C22856-B332-42D6-94F6-347491DB4324}" type="datetimeFigureOut">
               <a:rPr lang="en-IN" smtClean="0"/>
-              <a:t>25-10-2026</a:t>
+              <a:t>26-10-2026</a:t>
             </a:fld>
             <a:endParaRPr lang="en-IN"/>
           </a:p>
@@ -2707,7 +2707,7 @@
           <a:p>
             <a:fld id="{93C22856-B332-42D6-94F6-347491DB4324}" type="datetimeFigureOut">
               <a:rPr lang="en-IN" smtClean="0"/>
-              <a:t>25-10-2026</a:t>
+              <a:t>26-10-2026</a:t>
             </a:fld>
             <a:endParaRPr lang="en-IN"/>
           </a:p>
@@ -2950,7 +2950,7 @@
           <a:p>
             <a:fld id="{93C22856-B332-42D6-94F6-347491DB4324}" type="datetimeFigureOut">
               <a:rPr lang="en-IN" smtClean="0"/>
-              <a:t>25-10-2026</a:t>
+              <a:t>26-10-2026</a:t>
             </a:fld>
             <a:endParaRPr lang="en-IN"/>
           </a:p>
@@ -10518,14 +10518,14 @@
           <p:nvPr>
             <p:extLst>
               <p:ext uri="{D42A27DB-BD31-4B8C-83A1-F6EECF244321}">
-                <p14:modId xmlns:p14="http://schemas.microsoft.com/office/powerpoint/2010/main" val="4085423743"/>
+                <p14:modId xmlns:p14="http://schemas.microsoft.com/office/powerpoint/2010/main" val="4261283748"/>
               </p:ext>
             </p:extLst>
           </p:nvPr>
         </p:nvGraphicFramePr>
         <p:xfrm>
           <a:off x="838200" y="1024010"/>
-          <a:ext cx="10515600" cy="1112520"/>
+          <a:ext cx="10515600" cy="2225040"/>
         </p:xfrm>
         <a:graphic>
           <a:graphicData uri="http://schemas.openxmlformats.org/drawingml/2006/table">
@@ -10729,7 +10729,7 @@
                       <a:pPr algn="ctr"/>
                       <a:r>
                         <a:rPr lang="en-IN" dirty="0"/>
-                        <a:t>Engineering</a:t>
+                        <a:t>Engineering2</a:t>
                       </a:r>
                     </a:p>
                   </a:txBody>
@@ -10788,6 +10788,232 @@
                 <a:extLst>
                   <a:ext uri="{0D108BD9-81ED-4DB2-BD59-A6C34878D82A}">
                     <a16:rowId xmlns:a16="http://schemas.microsoft.com/office/drawing/2014/main" val="2462398921"/>
+                  </a:ext>
+                </a:extLst>
+              </a:tr>
+              <a:tr h="370840">
+                <a:tc>
+                  <a:txBody>
+                    <a:bodyPr/>
+                    <a:lstStyle/>
+                    <a:p>
+                      <a:pPr algn="ctr"/>
+                      <a:r>
+                        <a:rPr lang="en-IN" dirty="0"/>
+                        <a:t>Engineering3</a:t>
+                      </a:r>
+                    </a:p>
+                  </a:txBody>
+                  <a:tcPr/>
+                </a:tc>
+                <a:tc>
+                  <a:txBody>
+                    <a:bodyPr/>
+                    <a:lstStyle/>
+                    <a:p>
+                      <a:pPr algn="ctr"/>
+                      <a:r>
+                        <a:rPr lang="en-IN" dirty="0"/>
+                        <a:t>Product</a:t>
+                      </a:r>
+                    </a:p>
+                  </a:txBody>
+                  <a:tcPr/>
+                </a:tc>
+                <a:tc>
+                  <a:txBody>
+                    <a:bodyPr/>
+                    <a:lstStyle/>
+                    <a:p>
+                      <a:r>
+                        <a:rPr dirty="0"/>
+                        <a:t>$250,000</a:t>
+                      </a:r>
+                    </a:p>
+                  </a:txBody>
+                  <a:tcPr/>
+                </a:tc>
+                <a:tc>
+                  <a:txBody>
+                    <a:bodyPr/>
+                    <a:lstStyle/>
+                    <a:p>
+                      <a:r>
+                        <a:rPr dirty="0"/>
+                        <a:t>$245,000</a:t>
+                      </a:r>
+                    </a:p>
+                  </a:txBody>
+                  <a:tcPr/>
+                </a:tc>
+                <a:tc>
+                  <a:txBody>
+                    <a:bodyPr/>
+                    <a:lstStyle/>
+                    <a:p>
+                      <a:pPr algn="r"/>
+                      <a:r>
+                        <a:rPr lang="en-IN" dirty="0"/>
+                        <a:t>Wow</a:t>
+                      </a:r>
+                      <a:endParaRPr dirty="0"/>
+                    </a:p>
+                  </a:txBody>
+                  <a:tcPr/>
+                </a:tc>
+                <a:extLst>
+                  <a:ext uri="{0D108BD9-81ED-4DB2-BD59-A6C34878D82A}">
+                    <a16:rowId xmlns:a16="http://schemas.microsoft.com/office/drawing/2014/main" val="2589158065"/>
+                  </a:ext>
+                </a:extLst>
+              </a:tr>
+              <a:tr h="370840">
+                <a:tc>
+                  <a:txBody>
+                    <a:bodyPr/>
+                    <a:lstStyle/>
+                    <a:p>
+                      <a:pPr algn="ctr"/>
+                      <a:r>
+                        <a:rPr lang="en-IN" dirty="0"/>
+                        <a:t>Engineering4</a:t>
+                      </a:r>
+                    </a:p>
+                  </a:txBody>
+                  <a:tcPr/>
+                </a:tc>
+                <a:tc>
+                  <a:txBody>
+                    <a:bodyPr/>
+                    <a:lstStyle/>
+                    <a:p>
+                      <a:pPr algn="ctr"/>
+                      <a:r>
+                        <a:rPr lang="en-IN" dirty="0"/>
+                        <a:t>Product</a:t>
+                      </a:r>
+                    </a:p>
+                  </a:txBody>
+                  <a:tcPr/>
+                </a:tc>
+                <a:tc>
+                  <a:txBody>
+                    <a:bodyPr/>
+                    <a:lstStyle/>
+                    <a:p>
+                      <a:r>
+                        <a:rPr dirty="0"/>
+                        <a:t>$250,000</a:t>
+                      </a:r>
+                    </a:p>
+                  </a:txBody>
+                  <a:tcPr/>
+                </a:tc>
+                <a:tc>
+                  <a:txBody>
+                    <a:bodyPr/>
+                    <a:lstStyle/>
+                    <a:p>
+                      <a:r>
+                        <a:rPr dirty="0"/>
+                        <a:t>$245,000</a:t>
+                      </a:r>
+                    </a:p>
+                  </a:txBody>
+                  <a:tcPr/>
+                </a:tc>
+                <a:tc>
+                  <a:txBody>
+                    <a:bodyPr/>
+                    <a:lstStyle/>
+                    <a:p>
+                      <a:r>
+                        <a:rPr lang="en-IN" dirty="0"/>
+                        <a:t>Wow</a:t>
+                      </a:r>
+                      <a:endParaRPr dirty="0"/>
+                    </a:p>
+                  </a:txBody>
+                  <a:tcPr/>
+                </a:tc>
+                <a:extLst>
+                  <a:ext uri="{0D108BD9-81ED-4DB2-BD59-A6C34878D82A}">
+                    <a16:rowId xmlns:a16="http://schemas.microsoft.com/office/drawing/2014/main" val="977933646"/>
+                  </a:ext>
+                </a:extLst>
+              </a:tr>
+              <a:tr h="370840">
+                <a:tc>
+                  <a:txBody>
+                    <a:bodyPr/>
+                    <a:lstStyle/>
+                    <a:p>
+                      <a:pPr algn="ctr"/>
+                      <a:r>
+                        <a:rPr lang="en-IN"/>
+                        <a:t>Engineering</a:t>
+                      </a:r>
+                      <a:r>
+                        <a:rPr lang="en-IN" dirty="0"/>
+                        <a:t>5</a:t>
+                      </a:r>
+                    </a:p>
+                  </a:txBody>
+                  <a:tcPr/>
+                </a:tc>
+                <a:tc>
+                  <a:txBody>
+                    <a:bodyPr/>
+                    <a:lstStyle/>
+                    <a:p>
+                      <a:pPr algn="ctr"/>
+                      <a:r>
+                        <a:rPr lang="en-IN" dirty="0"/>
+                        <a:t>Product</a:t>
+                      </a:r>
+                    </a:p>
+                  </a:txBody>
+                  <a:tcPr/>
+                </a:tc>
+                <a:tc>
+                  <a:txBody>
+                    <a:bodyPr/>
+                    <a:lstStyle/>
+                    <a:p>
+                      <a:r>
+                        <a:rPr dirty="0"/>
+                        <a:t>$250,000</a:t>
+                      </a:r>
+                    </a:p>
+                  </a:txBody>
+                  <a:tcPr/>
+                </a:tc>
+                <a:tc>
+                  <a:txBody>
+                    <a:bodyPr/>
+                    <a:lstStyle/>
+                    <a:p>
+                      <a:r>
+                        <a:rPr dirty="0"/>
+                        <a:t>$245,000</a:t>
+                      </a:r>
+                    </a:p>
+                  </a:txBody>
+                  <a:tcPr/>
+                </a:tc>
+                <a:tc>
+                  <a:txBody>
+                    <a:bodyPr/>
+                    <a:lstStyle/>
+                    <a:p>
+                      <a:endParaRPr dirty="0"/>
+                    </a:p>
+                  </a:txBody>
+                  <a:tcPr/>
+                </a:tc>
+                <a:extLst>
+                  <a:ext uri="{0D108BD9-81ED-4DB2-BD59-A6C34878D82A}">
+                    <a16:rowId xmlns:a16="http://schemas.microsoft.com/office/drawing/2014/main" val="2444845291"/>
                   </a:ext>
                 </a:extLst>
               </a:tr>
@@ -10887,6 +11113,360 @@
           </a:p>
         </p:txBody>
       </p:sp>
+      <p:sp>
+        <p:nvSpPr>
+          <p:cNvPr id="6" name="Rectangle 5">
+            <a:extLst>
+              <a:ext uri="{FF2B5EF4-FFF2-40B4-BE49-F238E27FC236}">
+                <a16:creationId xmlns:a16="http://schemas.microsoft.com/office/drawing/2014/main" id="{0A7D36DB-D635-193E-246B-477659DF861E}"/>
+              </a:ext>
+            </a:extLst>
+          </p:cNvPr>
+          <p:cNvSpPr/>
+          <p:nvPr/>
+        </p:nvSpPr>
+        <p:spPr>
+          <a:xfrm>
+            <a:off x="10067192" y="2193387"/>
+            <a:ext cx="342900" cy="237392"/>
+          </a:xfrm>
+          <a:prstGeom prst="rect">
+            <a:avLst/>
+          </a:prstGeom>
+        </p:spPr>
+        <p:style>
+          <a:lnRef idx="2">
+            <a:schemeClr val="accent1">
+              <a:shade val="15000"/>
+            </a:schemeClr>
+          </a:lnRef>
+          <a:fillRef idx="1">
+            <a:schemeClr val="accent1"/>
+          </a:fillRef>
+          <a:effectRef idx="0">
+            <a:schemeClr val="accent1"/>
+          </a:effectRef>
+          <a:fontRef idx="minor">
+            <a:schemeClr val="lt1"/>
+          </a:fontRef>
+        </p:style>
+        <p:txBody>
+          <a:bodyPr rtlCol="0" anchor="ctr"/>
+          <a:lstStyle/>
+          <a:p>
+            <a:pPr algn="ctr"/>
+            <a:endParaRPr lang="en-IN"/>
+          </a:p>
+        </p:txBody>
+      </p:sp>
+      <p:sp>
+        <p:nvSpPr>
+          <p:cNvPr id="8" name="Oval 7">
+            <a:extLst>
+              <a:ext uri="{FF2B5EF4-FFF2-40B4-BE49-F238E27FC236}">
+                <a16:creationId xmlns:a16="http://schemas.microsoft.com/office/drawing/2014/main" id="{98480B0F-6ACD-54FC-ADDA-918DD7DC381F}"/>
+              </a:ext>
+            </a:extLst>
+          </p:cNvPr>
+          <p:cNvSpPr/>
+          <p:nvPr/>
+        </p:nvSpPr>
+        <p:spPr>
+          <a:xfrm>
+            <a:off x="10998077" y="2568453"/>
+            <a:ext cx="254977" cy="254977"/>
+          </a:xfrm>
+          <a:prstGeom prst="ellipse">
+            <a:avLst/>
+          </a:prstGeom>
+        </p:spPr>
+        <p:style>
+          <a:lnRef idx="2">
+            <a:schemeClr val="accent6">
+              <a:shade val="15000"/>
+            </a:schemeClr>
+          </a:lnRef>
+          <a:fillRef idx="1">
+            <a:schemeClr val="accent6"/>
+          </a:fillRef>
+          <a:effectRef idx="0">
+            <a:schemeClr val="accent6"/>
+          </a:effectRef>
+          <a:fontRef idx="minor">
+            <a:schemeClr val="lt1"/>
+          </a:fontRef>
+        </p:style>
+        <p:txBody>
+          <a:bodyPr rtlCol="0" anchor="ctr"/>
+          <a:lstStyle/>
+          <a:p>
+            <a:pPr algn="ctr"/>
+            <a:endParaRPr lang="en-IN"/>
+          </a:p>
+        </p:txBody>
+      </p:sp>
+      <p:cxnSp>
+        <p:nvCxnSpPr>
+          <p:cNvPr id="10" name="Straight Arrow Connector 9">
+            <a:extLst>
+              <a:ext uri="{FF2B5EF4-FFF2-40B4-BE49-F238E27FC236}">
+                <a16:creationId xmlns:a16="http://schemas.microsoft.com/office/drawing/2014/main" id="{9DAE1ACA-823B-5FA0-06E3-DD1376124AC3}"/>
+              </a:ext>
+            </a:extLst>
+          </p:cNvPr>
+          <p:cNvCxnSpPr/>
+          <p:nvPr/>
+        </p:nvCxnSpPr>
+        <p:spPr>
+          <a:xfrm>
+            <a:off x="9410700" y="3062288"/>
+            <a:ext cx="947738" cy="0"/>
+          </a:xfrm>
+          <a:prstGeom prst="straightConnector1">
+            <a:avLst/>
+          </a:prstGeom>
+          <a:ln>
+            <a:tailEnd type="triangle"/>
+          </a:ln>
+        </p:spPr>
+        <p:style>
+          <a:lnRef idx="1">
+            <a:schemeClr val="accent1"/>
+          </a:lnRef>
+          <a:fillRef idx="0">
+            <a:schemeClr val="accent1"/>
+          </a:fillRef>
+          <a:effectRef idx="0">
+            <a:schemeClr val="accent1"/>
+          </a:effectRef>
+          <a:fontRef idx="minor">
+            <a:schemeClr val="tx1"/>
+          </a:fontRef>
+        </p:style>
+      </p:cxnSp>
+      <p:sp>
+        <p:nvSpPr>
+          <p:cNvPr id="11" name="Rectangle: Rounded Corners 10">
+            <a:extLst>
+              <a:ext uri="{FF2B5EF4-FFF2-40B4-BE49-F238E27FC236}">
+                <a16:creationId xmlns:a16="http://schemas.microsoft.com/office/drawing/2014/main" id="{539A7CC2-EA2C-892D-C466-CA51FD244487}"/>
+              </a:ext>
+            </a:extLst>
+          </p:cNvPr>
+          <p:cNvSpPr/>
+          <p:nvPr/>
+        </p:nvSpPr>
+        <p:spPr>
+          <a:xfrm>
+            <a:off x="10558463" y="2947987"/>
+            <a:ext cx="439614" cy="254977"/>
+          </a:xfrm>
+          <a:prstGeom prst="roundRect">
+            <a:avLst/>
+          </a:prstGeom>
+        </p:spPr>
+        <p:style>
+          <a:lnRef idx="2">
+            <a:schemeClr val="accent1">
+              <a:shade val="15000"/>
+            </a:schemeClr>
+          </a:lnRef>
+          <a:fillRef idx="1">
+            <a:schemeClr val="accent1"/>
+          </a:fillRef>
+          <a:effectRef idx="0">
+            <a:schemeClr val="accent1"/>
+          </a:effectRef>
+          <a:fontRef idx="minor">
+            <a:schemeClr val="lt1"/>
+          </a:fontRef>
+        </p:style>
+        <p:txBody>
+          <a:bodyPr rtlCol="0" anchor="ctr"/>
+          <a:lstStyle/>
+          <a:p>
+            <a:pPr algn="ctr"/>
+            <a:endParaRPr lang="en-IN"/>
+          </a:p>
+        </p:txBody>
+      </p:sp>
+      <p:sp>
+        <p:nvSpPr>
+          <p:cNvPr id="12" name="Rectangle 11">
+            <a:extLst>
+              <a:ext uri="{FF2B5EF4-FFF2-40B4-BE49-F238E27FC236}">
+                <a16:creationId xmlns:a16="http://schemas.microsoft.com/office/drawing/2014/main" id="{A35FB834-E0A3-9C0A-75D9-A0618B314A3E}"/>
+              </a:ext>
+            </a:extLst>
+          </p:cNvPr>
+          <p:cNvSpPr/>
+          <p:nvPr/>
+        </p:nvSpPr>
+        <p:spPr>
+          <a:xfrm>
+            <a:off x="8223739" y="2193387"/>
+            <a:ext cx="342900" cy="237392"/>
+          </a:xfrm>
+          <a:prstGeom prst="rect">
+            <a:avLst/>
+          </a:prstGeom>
+        </p:spPr>
+        <p:style>
+          <a:lnRef idx="2">
+            <a:schemeClr val="accent1">
+              <a:shade val="15000"/>
+            </a:schemeClr>
+          </a:lnRef>
+          <a:fillRef idx="1">
+            <a:schemeClr val="accent1"/>
+          </a:fillRef>
+          <a:effectRef idx="0">
+            <a:schemeClr val="accent1"/>
+          </a:effectRef>
+          <a:fontRef idx="minor">
+            <a:schemeClr val="lt1"/>
+          </a:fontRef>
+        </p:style>
+        <p:txBody>
+          <a:bodyPr rtlCol="0" anchor="ctr"/>
+          <a:lstStyle/>
+          <a:p>
+            <a:pPr algn="ctr"/>
+            <a:endParaRPr lang="en-IN"/>
+          </a:p>
+        </p:txBody>
+      </p:sp>
+      <p:sp>
+        <p:nvSpPr>
+          <p:cNvPr id="15" name="Rectangle 14">
+            <a:extLst>
+              <a:ext uri="{FF2B5EF4-FFF2-40B4-BE49-F238E27FC236}">
+                <a16:creationId xmlns:a16="http://schemas.microsoft.com/office/drawing/2014/main" id="{55D68DE9-97B3-9147-442C-B6B2283833DC}"/>
+              </a:ext>
+            </a:extLst>
+          </p:cNvPr>
+          <p:cNvSpPr/>
+          <p:nvPr/>
+        </p:nvSpPr>
+        <p:spPr>
+          <a:xfrm>
+            <a:off x="6096000" y="2956779"/>
+            <a:ext cx="342900" cy="237392"/>
+          </a:xfrm>
+          <a:prstGeom prst="rect">
+            <a:avLst/>
+          </a:prstGeom>
+        </p:spPr>
+        <p:style>
+          <a:lnRef idx="2">
+            <a:schemeClr val="accent1">
+              <a:shade val="15000"/>
+            </a:schemeClr>
+          </a:lnRef>
+          <a:fillRef idx="1">
+            <a:schemeClr val="accent1"/>
+          </a:fillRef>
+          <a:effectRef idx="0">
+            <a:schemeClr val="accent1"/>
+          </a:effectRef>
+          <a:fontRef idx="minor">
+            <a:schemeClr val="lt1"/>
+          </a:fontRef>
+        </p:style>
+        <p:txBody>
+          <a:bodyPr rtlCol="0" anchor="ctr"/>
+          <a:lstStyle/>
+          <a:p>
+            <a:pPr algn="ctr"/>
+            <a:endParaRPr lang="en-IN"/>
+          </a:p>
+        </p:txBody>
+      </p:sp>
+      <p:sp>
+        <p:nvSpPr>
+          <p:cNvPr id="16" name="Oval 15">
+            <a:extLst>
+              <a:ext uri="{FF2B5EF4-FFF2-40B4-BE49-F238E27FC236}">
+                <a16:creationId xmlns:a16="http://schemas.microsoft.com/office/drawing/2014/main" id="{0CADDF6E-6FF1-9858-1F0C-5806C7D1F830}"/>
+              </a:ext>
+            </a:extLst>
+          </p:cNvPr>
+          <p:cNvSpPr/>
+          <p:nvPr/>
+        </p:nvSpPr>
+        <p:spPr>
+          <a:xfrm>
+            <a:off x="4497265" y="2568453"/>
+            <a:ext cx="254977" cy="254977"/>
+          </a:xfrm>
+          <a:prstGeom prst="ellipse">
+            <a:avLst/>
+          </a:prstGeom>
+        </p:spPr>
+        <p:style>
+          <a:lnRef idx="2">
+            <a:schemeClr val="accent6">
+              <a:shade val="15000"/>
+            </a:schemeClr>
+          </a:lnRef>
+          <a:fillRef idx="1">
+            <a:schemeClr val="accent6"/>
+          </a:fillRef>
+          <a:effectRef idx="0">
+            <a:schemeClr val="accent6"/>
+          </a:effectRef>
+          <a:fontRef idx="minor">
+            <a:schemeClr val="lt1"/>
+          </a:fontRef>
+        </p:style>
+        <p:txBody>
+          <a:bodyPr rtlCol="0" anchor="ctr"/>
+          <a:lstStyle/>
+          <a:p>
+            <a:pPr algn="ctr"/>
+            <a:endParaRPr lang="en-IN"/>
+          </a:p>
+        </p:txBody>
+      </p:sp>
+      <p:cxnSp>
+        <p:nvCxnSpPr>
+          <p:cNvPr id="17" name="Straight Arrow Connector 16">
+            <a:extLst>
+              <a:ext uri="{FF2B5EF4-FFF2-40B4-BE49-F238E27FC236}">
+                <a16:creationId xmlns:a16="http://schemas.microsoft.com/office/drawing/2014/main" id="{1815AC48-D367-2E4F-2629-62DFA882E22D}"/>
+              </a:ext>
+            </a:extLst>
+          </p:cNvPr>
+          <p:cNvCxnSpPr/>
+          <p:nvPr/>
+        </p:nvCxnSpPr>
+        <p:spPr>
+          <a:xfrm>
+            <a:off x="3886200" y="1594558"/>
+            <a:ext cx="947738" cy="0"/>
+          </a:xfrm>
+          <a:prstGeom prst="straightConnector1">
+            <a:avLst/>
+          </a:prstGeom>
+          <a:ln>
+            <a:tailEnd type="triangle"/>
+          </a:ln>
+        </p:spPr>
+        <p:style>
+          <a:lnRef idx="1">
+            <a:schemeClr val="accent1"/>
+          </a:lnRef>
+          <a:fillRef idx="0">
+            <a:schemeClr val="accent1"/>
+          </a:fillRef>
+          <a:effectRef idx="0">
+            <a:schemeClr val="accent1"/>
+          </a:effectRef>
+          <a:fontRef idx="minor">
+            <a:schemeClr val="tx1"/>
+          </a:fontRef>
+        </p:style>
+      </p:cxnSp>
     </p:spTree>
     <p:extLst>
       <p:ext uri="{BB962C8B-B14F-4D97-AF65-F5344CB8AC3E}">
@@ -10961,10 +11541,10 @@
       </p:sp>
       <p:graphicFrame>
         <p:nvGraphicFramePr>
-          <p:cNvPr id="4" name="UpdateTable">
-            <a:extLst>
-              <a:ext uri="{FF2B5EF4-FFF2-40B4-BE49-F238E27FC236}">
-                <a16:creationId xmlns:a16="http://schemas.microsoft.com/office/drawing/2014/main" id="{4B306EB2-98AE-5DA2-F421-3410E63ECE42}"/>
+          <p:cNvPr id="15" name="UpdateTable">
+            <a:extLst>
+              <a:ext uri="{FF2B5EF4-FFF2-40B4-BE49-F238E27FC236}">
+                <a16:creationId xmlns:a16="http://schemas.microsoft.com/office/drawing/2014/main" id="{1A2CAEB1-4F25-474C-0035-5A29422A743F}"/>
               </a:ext>
             </a:extLst>
           </p:cNvPr>
@@ -10974,14 +11554,14 @@
           <p:nvPr>
             <p:extLst>
               <p:ext uri="{D42A27DB-BD31-4B8C-83A1-F6EECF244321}">
-                <p14:modId xmlns:p14="http://schemas.microsoft.com/office/powerpoint/2010/main" val="4085178651"/>
+                <p14:modId xmlns:p14="http://schemas.microsoft.com/office/powerpoint/2010/main" val="490833601"/>
               </p:ext>
             </p:extLst>
           </p:nvPr>
         </p:nvGraphicFramePr>
         <p:xfrm>
           <a:off x="838200" y="1024010"/>
-          <a:ext cx="10515600" cy="1112520"/>
+          <a:ext cx="10515600" cy="2225040"/>
         </p:xfrm>
         <a:graphic>
           <a:graphicData uri="http://schemas.openxmlformats.org/drawingml/2006/table">
@@ -11082,10 +11662,6 @@
                     <a:bodyPr/>
                     <a:lstStyle/>
                     <a:p>
-                      <a:r>
-                        <a:rPr lang="en-IN" dirty="0"/>
-                        <a:t>Status</a:t>
-                      </a:r>
                       <a:endParaRPr dirty="0"/>
                     </a:p>
                   </a:txBody>
@@ -11189,7 +11765,7 @@
                       <a:pPr algn="ctr"/>
                       <a:r>
                         <a:rPr lang="en-IN" dirty="0"/>
-                        <a:t>Engineering</a:t>
+                        <a:t>Engineering2</a:t>
                       </a:r>
                     </a:p>
                   </a:txBody>
@@ -11248,6 +11824,228 @@
                 <a:extLst>
                   <a:ext uri="{0D108BD9-81ED-4DB2-BD59-A6C34878D82A}">
                     <a16:rowId xmlns:a16="http://schemas.microsoft.com/office/drawing/2014/main" val="2462398921"/>
+                  </a:ext>
+                </a:extLst>
+              </a:tr>
+              <a:tr h="370840">
+                <a:tc>
+                  <a:txBody>
+                    <a:bodyPr/>
+                    <a:lstStyle/>
+                    <a:p>
+                      <a:pPr algn="ctr"/>
+                      <a:r>
+                        <a:rPr lang="en-IN" dirty="0"/>
+                        <a:t>Engineering3</a:t>
+                      </a:r>
+                    </a:p>
+                  </a:txBody>
+                  <a:tcPr/>
+                </a:tc>
+                <a:tc>
+                  <a:txBody>
+                    <a:bodyPr/>
+                    <a:lstStyle/>
+                    <a:p>
+                      <a:pPr algn="ctr"/>
+                      <a:r>
+                        <a:rPr lang="en-IN" dirty="0"/>
+                        <a:t>Product</a:t>
+                      </a:r>
+                    </a:p>
+                  </a:txBody>
+                  <a:tcPr/>
+                </a:tc>
+                <a:tc>
+                  <a:txBody>
+                    <a:bodyPr/>
+                    <a:lstStyle/>
+                    <a:p>
+                      <a:r>
+                        <a:rPr dirty="0"/>
+                        <a:t>$250,000</a:t>
+                      </a:r>
+                    </a:p>
+                  </a:txBody>
+                  <a:tcPr/>
+                </a:tc>
+                <a:tc>
+                  <a:txBody>
+                    <a:bodyPr/>
+                    <a:lstStyle/>
+                    <a:p>
+                      <a:r>
+                        <a:rPr dirty="0"/>
+                        <a:t>$245,000</a:t>
+                      </a:r>
+                    </a:p>
+                  </a:txBody>
+                  <a:tcPr/>
+                </a:tc>
+                <a:tc>
+                  <a:txBody>
+                    <a:bodyPr/>
+                    <a:lstStyle/>
+                    <a:p>
+                      <a:pPr algn="r"/>
+                      <a:r>
+                        <a:rPr lang="en-IN" dirty="0"/>
+                        <a:t>Wow</a:t>
+                      </a:r>
+                      <a:endParaRPr dirty="0"/>
+                    </a:p>
+                  </a:txBody>
+                  <a:tcPr/>
+                </a:tc>
+                <a:extLst>
+                  <a:ext uri="{0D108BD9-81ED-4DB2-BD59-A6C34878D82A}">
+                    <a16:rowId xmlns:a16="http://schemas.microsoft.com/office/drawing/2014/main" val="2589158065"/>
+                  </a:ext>
+                </a:extLst>
+              </a:tr>
+              <a:tr h="370840">
+                <a:tc>
+                  <a:txBody>
+                    <a:bodyPr/>
+                    <a:lstStyle/>
+                    <a:p>
+                      <a:pPr algn="ctr"/>
+                      <a:r>
+                        <a:rPr lang="en-IN" dirty="0"/>
+                        <a:t>Engineering4</a:t>
+                      </a:r>
+                    </a:p>
+                  </a:txBody>
+                  <a:tcPr/>
+                </a:tc>
+                <a:tc>
+                  <a:txBody>
+                    <a:bodyPr/>
+                    <a:lstStyle/>
+                    <a:p>
+                      <a:pPr algn="ctr"/>
+                      <a:r>
+                        <a:rPr lang="en-IN" dirty="0"/>
+                        <a:t>Product</a:t>
+                      </a:r>
+                    </a:p>
+                  </a:txBody>
+                  <a:tcPr/>
+                </a:tc>
+                <a:tc>
+                  <a:txBody>
+                    <a:bodyPr/>
+                    <a:lstStyle/>
+                    <a:p>
+                      <a:r>
+                        <a:rPr dirty="0"/>
+                        <a:t>$250,000</a:t>
+                      </a:r>
+                    </a:p>
+                  </a:txBody>
+                  <a:tcPr/>
+                </a:tc>
+                <a:tc>
+                  <a:txBody>
+                    <a:bodyPr/>
+                    <a:lstStyle/>
+                    <a:p>
+                      <a:r>
+                        <a:rPr dirty="0"/>
+                        <a:t>$245,000</a:t>
+                      </a:r>
+                    </a:p>
+                  </a:txBody>
+                  <a:tcPr/>
+                </a:tc>
+                <a:tc>
+                  <a:txBody>
+                    <a:bodyPr/>
+                    <a:lstStyle/>
+                    <a:p>
+                      <a:r>
+                        <a:rPr lang="en-IN" dirty="0"/>
+                        <a:t>Wow</a:t>
+                      </a:r>
+                      <a:endParaRPr dirty="0"/>
+                    </a:p>
+                  </a:txBody>
+                  <a:tcPr/>
+                </a:tc>
+                <a:extLst>
+                  <a:ext uri="{0D108BD9-81ED-4DB2-BD59-A6C34878D82A}">
+                    <a16:rowId xmlns:a16="http://schemas.microsoft.com/office/drawing/2014/main" val="977933646"/>
+                  </a:ext>
+                </a:extLst>
+              </a:tr>
+              <a:tr h="370840">
+                <a:tc>
+                  <a:txBody>
+                    <a:bodyPr/>
+                    <a:lstStyle/>
+                    <a:p>
+                      <a:pPr algn="ctr"/>
+                      <a:r>
+                        <a:rPr lang="en-IN" dirty="0"/>
+                        <a:t>Engineering5</a:t>
+                      </a:r>
+                    </a:p>
+                  </a:txBody>
+                  <a:tcPr/>
+                </a:tc>
+                <a:tc>
+                  <a:txBody>
+                    <a:bodyPr/>
+                    <a:lstStyle/>
+                    <a:p>
+                      <a:pPr algn="ctr"/>
+                      <a:r>
+                        <a:rPr lang="en-IN" dirty="0"/>
+                        <a:t>Product</a:t>
+                      </a:r>
+                    </a:p>
+                  </a:txBody>
+                  <a:tcPr/>
+                </a:tc>
+                <a:tc>
+                  <a:txBody>
+                    <a:bodyPr/>
+                    <a:lstStyle/>
+                    <a:p>
+                      <a:r>
+                        <a:rPr dirty="0"/>
+                        <a:t>$250,000</a:t>
+                      </a:r>
+                    </a:p>
+                  </a:txBody>
+                  <a:tcPr/>
+                </a:tc>
+                <a:tc>
+                  <a:txBody>
+                    <a:bodyPr/>
+                    <a:lstStyle/>
+                    <a:p>
+                      <a:r>
+                        <a:rPr dirty="0"/>
+                        <a:t>$245,000</a:t>
+                      </a:r>
+                    </a:p>
+                  </a:txBody>
+                  <a:tcPr/>
+                </a:tc>
+                <a:tc>
+                  <a:txBody>
+                    <a:bodyPr/>
+                    <a:lstStyle/>
+                    <a:p>
+                      <a:endParaRPr dirty="0"/>
+                    </a:p>
+                  </a:txBody>
+                  <a:tcPr/>
+                </a:tc>
+                <a:extLst>
+                  <a:ext uri="{0D108BD9-81ED-4DB2-BD59-A6C34878D82A}">
+                    <a16:rowId xmlns:a16="http://schemas.microsoft.com/office/drawing/2014/main" val="2444845291"/>
                   </a:ext>
                 </a:extLst>
               </a:tr>
@@ -11257,10 +12055,10 @@
       </p:graphicFrame>
       <p:sp>
         <p:nvSpPr>
-          <p:cNvPr id="5" name="Rectangle 4">
-            <a:extLst>
-              <a:ext uri="{FF2B5EF4-FFF2-40B4-BE49-F238E27FC236}">
-                <a16:creationId xmlns:a16="http://schemas.microsoft.com/office/drawing/2014/main" id="{92D22F7E-ECA1-E961-33FD-83BC9E929AF7}"/>
+          <p:cNvPr id="16" name="Rectangle 15">
+            <a:extLst>
+              <a:ext uri="{FF2B5EF4-FFF2-40B4-BE49-F238E27FC236}">
+                <a16:creationId xmlns:a16="http://schemas.microsoft.com/office/drawing/2014/main" id="{94397BD4-0BF1-CB5A-A2C8-8790B64A3273}"/>
               </a:ext>
             </a:extLst>
           </p:cNvPr>
@@ -11303,10 +12101,10 @@
       </p:sp>
       <p:sp>
         <p:nvSpPr>
-          <p:cNvPr id="7" name="Oval 6">
-            <a:extLst>
-              <a:ext uri="{FF2B5EF4-FFF2-40B4-BE49-F238E27FC236}">
-                <a16:creationId xmlns:a16="http://schemas.microsoft.com/office/drawing/2014/main" id="{ADB49E2A-004B-1C95-42F2-D76A9B4825EE}"/>
+          <p:cNvPr id="17" name="Oval 16">
+            <a:extLst>
+              <a:ext uri="{FF2B5EF4-FFF2-40B4-BE49-F238E27FC236}">
+                <a16:creationId xmlns:a16="http://schemas.microsoft.com/office/drawing/2014/main" id="{92123E82-1784-427F-8734-817A1483BAA1}"/>
               </a:ext>
             </a:extLst>
           </p:cNvPr>
@@ -11347,6 +12145,360 @@
           </a:p>
         </p:txBody>
       </p:sp>
+      <p:sp>
+        <p:nvSpPr>
+          <p:cNvPr id="18" name="Rectangle 17">
+            <a:extLst>
+              <a:ext uri="{FF2B5EF4-FFF2-40B4-BE49-F238E27FC236}">
+                <a16:creationId xmlns:a16="http://schemas.microsoft.com/office/drawing/2014/main" id="{06463E02-4569-5C3C-0324-1B10756FFDFD}"/>
+              </a:ext>
+            </a:extLst>
+          </p:cNvPr>
+          <p:cNvSpPr/>
+          <p:nvPr/>
+        </p:nvSpPr>
+        <p:spPr>
+          <a:xfrm>
+            <a:off x="10067192" y="2193387"/>
+            <a:ext cx="342900" cy="237392"/>
+          </a:xfrm>
+          <a:prstGeom prst="rect">
+            <a:avLst/>
+          </a:prstGeom>
+        </p:spPr>
+        <p:style>
+          <a:lnRef idx="2">
+            <a:schemeClr val="accent1">
+              <a:shade val="15000"/>
+            </a:schemeClr>
+          </a:lnRef>
+          <a:fillRef idx="1">
+            <a:schemeClr val="accent1"/>
+          </a:fillRef>
+          <a:effectRef idx="0">
+            <a:schemeClr val="accent1"/>
+          </a:effectRef>
+          <a:fontRef idx="minor">
+            <a:schemeClr val="lt1"/>
+          </a:fontRef>
+        </p:style>
+        <p:txBody>
+          <a:bodyPr rtlCol="0" anchor="ctr"/>
+          <a:lstStyle/>
+          <a:p>
+            <a:pPr algn="ctr"/>
+            <a:endParaRPr lang="en-IN"/>
+          </a:p>
+        </p:txBody>
+      </p:sp>
+      <p:sp>
+        <p:nvSpPr>
+          <p:cNvPr id="19" name="Oval 18">
+            <a:extLst>
+              <a:ext uri="{FF2B5EF4-FFF2-40B4-BE49-F238E27FC236}">
+                <a16:creationId xmlns:a16="http://schemas.microsoft.com/office/drawing/2014/main" id="{02B3A15A-6C96-493D-259F-7C1C5F01B1D7}"/>
+              </a:ext>
+            </a:extLst>
+          </p:cNvPr>
+          <p:cNvSpPr/>
+          <p:nvPr/>
+        </p:nvSpPr>
+        <p:spPr>
+          <a:xfrm>
+            <a:off x="10998077" y="2568453"/>
+            <a:ext cx="254977" cy="254977"/>
+          </a:xfrm>
+          <a:prstGeom prst="ellipse">
+            <a:avLst/>
+          </a:prstGeom>
+        </p:spPr>
+        <p:style>
+          <a:lnRef idx="2">
+            <a:schemeClr val="accent6">
+              <a:shade val="15000"/>
+            </a:schemeClr>
+          </a:lnRef>
+          <a:fillRef idx="1">
+            <a:schemeClr val="accent6"/>
+          </a:fillRef>
+          <a:effectRef idx="0">
+            <a:schemeClr val="accent6"/>
+          </a:effectRef>
+          <a:fontRef idx="minor">
+            <a:schemeClr val="lt1"/>
+          </a:fontRef>
+        </p:style>
+        <p:txBody>
+          <a:bodyPr rtlCol="0" anchor="ctr"/>
+          <a:lstStyle/>
+          <a:p>
+            <a:pPr algn="ctr"/>
+            <a:endParaRPr lang="en-IN"/>
+          </a:p>
+        </p:txBody>
+      </p:sp>
+      <p:cxnSp>
+        <p:nvCxnSpPr>
+          <p:cNvPr id="20" name="Straight Arrow Connector 19">
+            <a:extLst>
+              <a:ext uri="{FF2B5EF4-FFF2-40B4-BE49-F238E27FC236}">
+                <a16:creationId xmlns:a16="http://schemas.microsoft.com/office/drawing/2014/main" id="{7AD8C6DA-DF35-70C1-1748-748F878D67BA}"/>
+              </a:ext>
+            </a:extLst>
+          </p:cNvPr>
+          <p:cNvCxnSpPr/>
+          <p:nvPr/>
+        </p:nvCxnSpPr>
+        <p:spPr>
+          <a:xfrm>
+            <a:off x="9410700" y="3062288"/>
+            <a:ext cx="947738" cy="0"/>
+          </a:xfrm>
+          <a:prstGeom prst="straightConnector1">
+            <a:avLst/>
+          </a:prstGeom>
+          <a:ln>
+            <a:tailEnd type="triangle"/>
+          </a:ln>
+        </p:spPr>
+        <p:style>
+          <a:lnRef idx="1">
+            <a:schemeClr val="accent1"/>
+          </a:lnRef>
+          <a:fillRef idx="0">
+            <a:schemeClr val="accent1"/>
+          </a:fillRef>
+          <a:effectRef idx="0">
+            <a:schemeClr val="accent1"/>
+          </a:effectRef>
+          <a:fontRef idx="minor">
+            <a:schemeClr val="tx1"/>
+          </a:fontRef>
+        </p:style>
+      </p:cxnSp>
+      <p:sp>
+        <p:nvSpPr>
+          <p:cNvPr id="21" name="Rectangle: Rounded Corners 20">
+            <a:extLst>
+              <a:ext uri="{FF2B5EF4-FFF2-40B4-BE49-F238E27FC236}">
+                <a16:creationId xmlns:a16="http://schemas.microsoft.com/office/drawing/2014/main" id="{74A404B6-1735-D57F-5F61-FA73490D7FF2}"/>
+              </a:ext>
+            </a:extLst>
+          </p:cNvPr>
+          <p:cNvSpPr/>
+          <p:nvPr/>
+        </p:nvSpPr>
+        <p:spPr>
+          <a:xfrm>
+            <a:off x="10558463" y="2947987"/>
+            <a:ext cx="439614" cy="254977"/>
+          </a:xfrm>
+          <a:prstGeom prst="roundRect">
+            <a:avLst/>
+          </a:prstGeom>
+        </p:spPr>
+        <p:style>
+          <a:lnRef idx="2">
+            <a:schemeClr val="accent1">
+              <a:shade val="15000"/>
+            </a:schemeClr>
+          </a:lnRef>
+          <a:fillRef idx="1">
+            <a:schemeClr val="accent1"/>
+          </a:fillRef>
+          <a:effectRef idx="0">
+            <a:schemeClr val="accent1"/>
+          </a:effectRef>
+          <a:fontRef idx="minor">
+            <a:schemeClr val="lt1"/>
+          </a:fontRef>
+        </p:style>
+        <p:txBody>
+          <a:bodyPr rtlCol="0" anchor="ctr"/>
+          <a:lstStyle/>
+          <a:p>
+            <a:pPr algn="ctr"/>
+            <a:endParaRPr lang="en-IN"/>
+          </a:p>
+        </p:txBody>
+      </p:sp>
+      <p:sp>
+        <p:nvSpPr>
+          <p:cNvPr id="22" name="Rectangle 21">
+            <a:extLst>
+              <a:ext uri="{FF2B5EF4-FFF2-40B4-BE49-F238E27FC236}">
+                <a16:creationId xmlns:a16="http://schemas.microsoft.com/office/drawing/2014/main" id="{2B1CFB87-B45D-C81E-DF05-0653D10F8DC3}"/>
+              </a:ext>
+            </a:extLst>
+          </p:cNvPr>
+          <p:cNvSpPr/>
+          <p:nvPr/>
+        </p:nvSpPr>
+        <p:spPr>
+          <a:xfrm>
+            <a:off x="8223739" y="2193387"/>
+            <a:ext cx="342900" cy="237392"/>
+          </a:xfrm>
+          <a:prstGeom prst="rect">
+            <a:avLst/>
+          </a:prstGeom>
+        </p:spPr>
+        <p:style>
+          <a:lnRef idx="2">
+            <a:schemeClr val="accent1">
+              <a:shade val="15000"/>
+            </a:schemeClr>
+          </a:lnRef>
+          <a:fillRef idx="1">
+            <a:schemeClr val="accent1"/>
+          </a:fillRef>
+          <a:effectRef idx="0">
+            <a:schemeClr val="accent1"/>
+          </a:effectRef>
+          <a:fontRef idx="minor">
+            <a:schemeClr val="lt1"/>
+          </a:fontRef>
+        </p:style>
+        <p:txBody>
+          <a:bodyPr rtlCol="0" anchor="ctr"/>
+          <a:lstStyle/>
+          <a:p>
+            <a:pPr algn="ctr"/>
+            <a:endParaRPr lang="en-IN"/>
+          </a:p>
+        </p:txBody>
+      </p:sp>
+      <p:sp>
+        <p:nvSpPr>
+          <p:cNvPr id="23" name="Rectangle 22">
+            <a:extLst>
+              <a:ext uri="{FF2B5EF4-FFF2-40B4-BE49-F238E27FC236}">
+                <a16:creationId xmlns:a16="http://schemas.microsoft.com/office/drawing/2014/main" id="{AD0BF74E-7EA6-38EB-80DD-52469B108BCA}"/>
+              </a:ext>
+            </a:extLst>
+          </p:cNvPr>
+          <p:cNvSpPr/>
+          <p:nvPr/>
+        </p:nvSpPr>
+        <p:spPr>
+          <a:xfrm>
+            <a:off x="6096000" y="2956779"/>
+            <a:ext cx="342900" cy="237392"/>
+          </a:xfrm>
+          <a:prstGeom prst="rect">
+            <a:avLst/>
+          </a:prstGeom>
+        </p:spPr>
+        <p:style>
+          <a:lnRef idx="2">
+            <a:schemeClr val="accent1">
+              <a:shade val="15000"/>
+            </a:schemeClr>
+          </a:lnRef>
+          <a:fillRef idx="1">
+            <a:schemeClr val="accent1"/>
+          </a:fillRef>
+          <a:effectRef idx="0">
+            <a:schemeClr val="accent1"/>
+          </a:effectRef>
+          <a:fontRef idx="minor">
+            <a:schemeClr val="lt1"/>
+          </a:fontRef>
+        </p:style>
+        <p:txBody>
+          <a:bodyPr rtlCol="0" anchor="ctr"/>
+          <a:lstStyle/>
+          <a:p>
+            <a:pPr algn="ctr"/>
+            <a:endParaRPr lang="en-IN"/>
+          </a:p>
+        </p:txBody>
+      </p:sp>
+      <p:sp>
+        <p:nvSpPr>
+          <p:cNvPr id="24" name="Oval 23">
+            <a:extLst>
+              <a:ext uri="{FF2B5EF4-FFF2-40B4-BE49-F238E27FC236}">
+                <a16:creationId xmlns:a16="http://schemas.microsoft.com/office/drawing/2014/main" id="{E1FB32F3-879D-4401-10EC-E7BD1F7F5365}"/>
+              </a:ext>
+            </a:extLst>
+          </p:cNvPr>
+          <p:cNvSpPr/>
+          <p:nvPr/>
+        </p:nvSpPr>
+        <p:spPr>
+          <a:xfrm>
+            <a:off x="4497265" y="2568453"/>
+            <a:ext cx="254977" cy="254977"/>
+          </a:xfrm>
+          <a:prstGeom prst="ellipse">
+            <a:avLst/>
+          </a:prstGeom>
+        </p:spPr>
+        <p:style>
+          <a:lnRef idx="2">
+            <a:schemeClr val="accent6">
+              <a:shade val="15000"/>
+            </a:schemeClr>
+          </a:lnRef>
+          <a:fillRef idx="1">
+            <a:schemeClr val="accent6"/>
+          </a:fillRef>
+          <a:effectRef idx="0">
+            <a:schemeClr val="accent6"/>
+          </a:effectRef>
+          <a:fontRef idx="minor">
+            <a:schemeClr val="lt1"/>
+          </a:fontRef>
+        </p:style>
+        <p:txBody>
+          <a:bodyPr rtlCol="0" anchor="ctr"/>
+          <a:lstStyle/>
+          <a:p>
+            <a:pPr algn="ctr"/>
+            <a:endParaRPr lang="en-IN"/>
+          </a:p>
+        </p:txBody>
+      </p:sp>
+      <p:cxnSp>
+        <p:nvCxnSpPr>
+          <p:cNvPr id="25" name="Straight Arrow Connector 24">
+            <a:extLst>
+              <a:ext uri="{FF2B5EF4-FFF2-40B4-BE49-F238E27FC236}">
+                <a16:creationId xmlns:a16="http://schemas.microsoft.com/office/drawing/2014/main" id="{07D10CB3-FD6C-1FEB-C703-2CD2EB9BBA0A}"/>
+              </a:ext>
+            </a:extLst>
+          </p:cNvPr>
+          <p:cNvCxnSpPr/>
+          <p:nvPr/>
+        </p:nvCxnSpPr>
+        <p:spPr>
+          <a:xfrm>
+            <a:off x="3886200" y="1594558"/>
+            <a:ext cx="947738" cy="0"/>
+          </a:xfrm>
+          <a:prstGeom prst="straightConnector1">
+            <a:avLst/>
+          </a:prstGeom>
+          <a:ln>
+            <a:tailEnd type="triangle"/>
+          </a:ln>
+        </p:spPr>
+        <p:style>
+          <a:lnRef idx="1">
+            <a:schemeClr val="accent1"/>
+          </a:lnRef>
+          <a:fillRef idx="0">
+            <a:schemeClr val="accent1"/>
+          </a:fillRef>
+          <a:effectRef idx="0">
+            <a:schemeClr val="accent1"/>
+          </a:effectRef>
+          <a:fontRef idx="minor">
+            <a:schemeClr val="tx1"/>
+          </a:fontRef>
+        </p:style>
+      </p:cxnSp>
     </p:spTree>
     <p:extLst>
       <p:ext uri="{BB962C8B-B14F-4D97-AF65-F5344CB8AC3E}">

</xml_diff>